<commit_message>
Task 2: plot data and model with Catalax Dataset.plot
The fit figure now comes from Dataset.plot(predictor=model) on the measured
dataset (one panel per reaction); the cards describe the same call. Deck and
PDF rebuilt with the new figure.

Co-Authored-By: Claude Fable 5.1 <noreply@anthropic.com>
</commit_message>
<xml_diff>
--- a/slides/workshop.pptx
+++ b/slides/workshop.pptx
@@ -4073,8 +4073,8 @@
         </p:blipFill>
         <p:spPr>
           <a:xfrm>
-            <a:off x="2559184" y="1645920"/>
-            <a:ext cx="7073326" cy="2514600"/>
+            <a:off x="1725614" y="1645920"/>
+            <a:ext cx="8740465" cy="2514600"/>
           </a:xfrm>
           <a:prstGeom prst="rect">
             <a:avLst/>

</xml_diff>

<commit_message>
Rename repository to enzymeml-workshop-modelling-2026
Co-Authored-By: Claude Fable 5.1 <noreply@anthropic.com>
</commit_message>
<xml_diff>
--- a/slides/workshop.pptx
+++ b/slides/workshop.pptx
@@ -4397,7 +4397,7 @@
           <a:lstStyle/>
           <a:p>
             <a:r>
-              <a:t>github.com/haeussma/neus-workshop</a:t>
+              <a:t>github.com/haeussma/enzymeml-workshop-modelling-2026</a:t>
             </a:r>
           </a:p>
           <a:p>
@@ -7648,7 +7648,7 @@
           <a:p>
             <a:r>
               <a:rPr/>
-              <a:t>github.com/haeussma/neus-workshop · start with the README</a:t>
+              <a:t>github.com/haeussma/enzymeml-workshop-modelling-2026 · start with the README</a:t>
             </a:r>
           </a:p>
         </p:txBody>

</xml_diff>

<commit_message>
Deck: one flow-diagram slide per tool (Chromhandler, Catalax): inputs, steps, decisions, outputs
Co-Authored-By: Claude Fable 5.1 <noreply@anthropic.com>
</commit_message>
<xml_diff>
--- a/slides/workshop.pptx
+++ b/slides/workshop.pptx
@@ -19,6 +19,8 @@
     <p:sldId id="267" r:id="rId19"/>
     <p:sldId id="268" r:id="rId20"/>
     <p:sldId id="269" r:id="rId21"/>
+    <p:sldId id="270" r:id="rId22"/>
+    <p:sldId id="271" r:id="rId23"/>
   </p:sldIdLst>
   <p:sldSz cx="12191695" cy="6858000" type="screen4x3"/>
   <p:notesSz cx="6858000" cy="9144000"/>
@@ -585,7 +587,7 @@
           <a:lstStyle/>
           <a:p>
             <a:r>
-              <a:t>9:15 · Live demo 15 min, then hands-on 9:30–10:15. Demo: paste chromhandler.md, then the task card, then 'Let's start with task 1'. Show the count (24 reactions, 5 standards) and the peak plot. Accept the calibration explicitly ('my decision, not the assistant's'). Deliberate mistake: when asked for the reaction window, say 'the same as the standards, 11.41 ± 0.05'; chromhandler warns 'No peaks found for Neu5Ac in 6 measurement(s)' per reaction, the document has 0 Neu5Ac values, the check '6 values per reaction' fails. Say why (the shift on the peak plot), correct to 10.05 ± 0.20, continue. Export, run the checks, show this plot.</a:t>
+              <a:t>9:13 · 1 min. Task 1 with Chromhandler, task 2 with Catalax. Live demo first, then you work in pairs; the checks in the task card decide when you are done. Timing: demo 9:15, hands-on 9:30, break 10:15–10:30, demo 10:30, hands-on 10:40. At 11:25 we collect everybody's kcat and Km on one slide or the whiteboard, wrap-up 11:50.</a:t>
             </a:r>
           </a:p>
         </p:txBody>
@@ -655,7 +657,7 @@
           <a:lstStyle/>
           <a:p>
             <a:r>
-              <a:t>10:30 · Live demo 10 min, then hands-on 10:40–11:25. Paste catalax.md, then the task card. enable_x64 first. Only Neu5Ac has data; in Catalax 0.5.5 every state stays observable and the unmeasured ones get NaN arrays (observable=False breaks the sampler in this version). The priors and the sampler settings are in the card; they are decisions, say so. Show the posterior table, the trace and the fit plot. Those who did not finish task 1 start from checkpoints/neus_enzymeml.json.</a:t>
+              <a:t>9:12 · 3 min. README first. Two ways. With a language model: any chat model, free or by subscription (ChatGPT, Claude, Gemini, …); paste the tool card, then the task card; run the code it writes; paste errors back; the checks decide. Without writing code: the Colab link opens a prepared notebook with the tools installed and the data loaded; run it cell by cell, change a window, a prior, a series; ask the model inside Colab to explain any cell. notebooks/ are the reference solutions, open to everyone; checkpoints/ holds the result of task 1. Locally: uv sync.</a:t>
             </a:r>
           </a:p>
         </p:txBody>
@@ -725,7 +727,7 @@
           <a:lstStyle/>
           <a:p>
             <a:r>
-              <a:t>11:25 · 25 min. First collect everybody's kcat, Km_ManNAc, Km_PEP: how much do they differ and why (windows, priors, reactions used)? Then the misfit: one shared kcat over-predicts the ManNAc series and under-predicts the PEP series; the series were measured on different days and differ by roughly 25 % in activity. Ask: a per-day activity factor, a new experiment, both? Which decisions did the assistant try to make for you, and which did you take back?</a:t>
+              <a:t>9:15 · Live demo 15 min, then hands-on 9:30–10:15. Demo: paste chromhandler.md, then the task card, then 'Let's start with task 1'. Show the count (24 reactions, 5 standards) and the peak plot. Accept the calibration explicitly ('my decision, not the assistant's'). Deliberate mistake: when asked for the reaction window, say 'the same as the standards, 11.41 ± 0.05'; chromhandler warns 'No peaks found for Neu5Ac in 6 measurement(s)' per reaction, the document has 0 Neu5Ac values, the check '6 values per reaction' fails. Say why (the shift on the peak plot), correct to 10.05 ± 0.20, continue. Export, run the checks, show this plot.</a:t>
             </a:r>
           </a:p>
         </p:txBody>
@@ -795,7 +797,7 @@
           <a:lstStyle/>
           <a:p>
             <a:r>
-              <a:t>11:50 · 10 min. Take-home and feedback round. Ask explicitly what did not work: that is what we need to improve the cards. The cards are reusable as SKILL.md / AGENTS.md for coding agents.</a:t>
+              <a:t>10:30 · Live demo 10 min, then hands-on 10:40–11:25. Paste catalax.md, then the task card. enable_x64 first. Only Neu5Ac has data; in Catalax 0.5.5 every state stays observable and the unmeasured ones get NaN arrays (observable=False breaks the sampler in this version). The priors and the sampler settings are in the card; they are decisions, say so. Show the posterior table, the trace and the fit plot. Those who did not finish task 1 start from checkpoints/neus_enzymeml.json.</a:t>
             </a:r>
           </a:p>
         </p:txBody>
@@ -865,6 +867,146 @@
           <a:lstStyle/>
           <a:p>
             <a:r>
+              <a:t>11:25 · 25 min. First collect everybody's kcat, Km_ManNAc, Km_PEP: how much do they differ and why (windows, priors, reactions used)? Then the misfit: one shared kcat over-predicts the ManNAc series and under-predicts the PEP series; the series were measured on different days and differ by roughly 25 % in activity. Ask: a per-day activity factor, a new experiment, both? Which decisions did the assistant try to make for you, and which did you take back?</a:t>
+            </a:r>
+          </a:p>
+        </p:txBody>
+      </p:sp>
+      <p:sp>
+        <p:nvSpPr>
+          <p:cNvPr id="4" name="Slide Number Placeholder 3"/>
+          <p:cNvSpPr>
+            <a:spLocks noGrp="1"/>
+          </p:cNvSpPr>
+          <p:nvPr>
+            <p:ph type="sldNum" idx="5" sz="quarter"/>
+          </p:nvPr>
+        </p:nvSpPr>
+        <p:spPr/>
+      </p:sp>
+    </p:spTree>
+  </p:cSld>
+  <p:clrMapOvr>
+    <a:masterClrMapping/>
+  </p:clrMapOvr>
+</p:notes>
+</file>
+
+<file path=ppt/notesSlides/notesSlide15.xml><?xml version="1.0" encoding="utf-8"?>
+<p:notes xmlns:a="http://schemas.openxmlformats.org/drawingml/2006/main" xmlns:p="http://schemas.openxmlformats.org/presentationml/2006/main" xmlns:r="http://schemas.openxmlformats.org/officeDocument/2006/relationships">
+  <p:cSld>
+    <p:spTree>
+      <p:nvGrpSpPr>
+        <p:cNvPr id="1" name=""/>
+        <p:cNvGrpSpPr/>
+        <p:nvPr/>
+      </p:nvGrpSpPr>
+      <p:grpSpPr>
+        <a:xfrm>
+          <a:off x="0" y="0"/>
+          <a:ext cx="0" cy="0"/>
+          <a:chOff x="0" y="0"/>
+          <a:chExt cx="0" cy="0"/>
+        </a:xfrm>
+      </p:grpSpPr>
+      <p:sp>
+        <p:nvSpPr>
+          <p:cNvPr id="2" name="Slide Image Placeholder 1"/>
+          <p:cNvSpPr>
+            <a:spLocks noGrp="1"/>
+          </p:cNvSpPr>
+          <p:nvPr>
+            <p:ph type="sldImg" idx="2"/>
+          </p:nvPr>
+        </p:nvSpPr>
+        <p:spPr/>
+      </p:sp>
+      <p:sp>
+        <p:nvSpPr>
+          <p:cNvPr id="3" name="Notes Placeholder 2"/>
+          <p:cNvSpPr>
+            <a:spLocks noGrp="1"/>
+          </p:cNvSpPr>
+          <p:nvPr>
+            <p:ph type="body" idx="3" sz="quarter"/>
+          </p:nvPr>
+        </p:nvSpPr>
+        <p:spPr/>
+        <p:txBody>
+          <a:bodyPr/>
+          <a:lstStyle/>
+          <a:p>
+            <a:r>
+              <a:t>11:50 · 10 min. Take-home and feedback round. Ask explicitly what did not work: that is what we need to improve the cards. The cards are reusable as SKILL.md / AGENTS.md for coding agents.</a:t>
+            </a:r>
+          </a:p>
+        </p:txBody>
+      </p:sp>
+      <p:sp>
+        <p:nvSpPr>
+          <p:cNvPr id="4" name="Slide Number Placeholder 3"/>
+          <p:cNvSpPr>
+            <a:spLocks noGrp="1"/>
+          </p:cNvSpPr>
+          <p:nvPr>
+            <p:ph type="sldNum" idx="5" sz="quarter"/>
+          </p:nvPr>
+        </p:nvSpPr>
+        <p:spPr/>
+      </p:sp>
+    </p:spTree>
+  </p:cSld>
+  <p:clrMapOvr>
+    <a:masterClrMapping/>
+  </p:clrMapOvr>
+</p:notes>
+</file>
+
+<file path=ppt/notesSlides/notesSlide16.xml><?xml version="1.0" encoding="utf-8"?>
+<p:notes xmlns:a="http://schemas.openxmlformats.org/drawingml/2006/main" xmlns:p="http://schemas.openxmlformats.org/presentationml/2006/main" xmlns:r="http://schemas.openxmlformats.org/officeDocument/2006/relationships">
+  <p:cSld>
+    <p:spTree>
+      <p:nvGrpSpPr>
+        <p:cNvPr id="1" name=""/>
+        <p:cNvGrpSpPr/>
+        <p:nvPr/>
+      </p:nvGrpSpPr>
+      <p:grpSpPr>
+        <a:xfrm>
+          <a:off x="0" y="0"/>
+          <a:ext cx="0" cy="0"/>
+          <a:chOff x="0" y="0"/>
+          <a:chExt cx="0" cy="0"/>
+        </a:xfrm>
+      </p:grpSpPr>
+      <p:sp>
+        <p:nvSpPr>
+          <p:cNvPr id="2" name="Slide Image Placeholder 1"/>
+          <p:cNvSpPr>
+            <a:spLocks noGrp="1"/>
+          </p:cNvSpPr>
+          <p:nvPr>
+            <p:ph type="sldImg" idx="2"/>
+          </p:nvPr>
+        </p:nvSpPr>
+        <p:spPr/>
+      </p:sp>
+      <p:sp>
+        <p:nvSpPr>
+          <p:cNvPr id="3" name="Notes Placeholder 2"/>
+          <p:cNvSpPr>
+            <a:spLocks noGrp="1"/>
+          </p:cNvSpPr>
+          <p:nvPr>
+            <p:ph type="body" idx="3" sz="quarter"/>
+          </p:nvPr>
+        </p:nvSpPr>
+        <p:spPr/>
+        <p:txBody>
+          <a:bodyPr/>
+          <a:lstStyle/>
+          <a:p>
+            <a:r>
               <a:t>11:58 · Close. The repository stays up; questions in the break or by mail.</a:t>
             </a:r>
           </a:p>
@@ -1215,7 +1357,7 @@
           <a:lstStyle/>
           <a:p>
             <a:r>
-              <a:t>9:08 · 2 min. Neu5Ac synthase condenses ManNAc and PEP to Neu5Ac and phosphate (metal cofactor, water). HPLC-PDA at 215 nm. Two series: ManNAc varied at fixed PEP (13 reactions), PEP varied at fixed ManNAc (11 reactions); six injections each; five standards with 1–5 mM. Only the product is quantified; the substrates enter the model as their known initial values.</a:t>
+              <a:t>9:08 · 1 min. Left: what goes in, the peak tables the instrument software exported (one per injection, the reaction time in the file name), the standards with known concentrations, and the initial concentrations. Middle: the steps in order; two of them are the scientist's decisions, the retention window per session and accepting the calibration. Right: the EnzymeML document and the checks the task card asks for.</a:t>
             </a:r>
           </a:p>
         </p:txBody>
@@ -1285,7 +1427,7 @@
           <a:lstStyle/>
           <a:p>
             <a:r>
-              <a:t>9:10 · 1 min. Two series: ManNAc varied at fixed PEP (13 reactions), PEP varied at fixed ManNAc (11 reactions); six injections each, 144 chromatograms; five standards with 1–5 mM Neu5Ac that also contain the substrates, no enzyme. Participants do not get the raw traces: the instrument software exported a peak table per injection, and that is the input of task 1. Initial concentrations are in conditions.csv. Where Neu5Ac elutes is in the task card and comes up in the demo.</a:t>
+              <a:t>9:09 · 1 min. Left: the EnzymeML document, the rate law, and the assumptions, priors and noise. Middle: load, define the model, set the priors, sample with Hamiltonian Monte Carlo, then check and plot. The model, the priors and the noise are the scientist's decisions; the checks say whether the posterior can be trusted. Right: posterior distributions, not point estimates, and the plots.</a:t>
             </a:r>
           </a:p>
         </p:txBody>
@@ -1355,7 +1497,7 @@
           <a:lstStyle/>
           <a:p>
             <a:r>
-              <a:t>9:11 · 1 min. Task 1 with Chromhandler, task 2 with Catalax. Live demo first, then you work in pairs; the checks in the task card decide when you are done. Timing: demo 9:15, hands-on 9:30, break 10:15–10:30, demo 10:30, hands-on 10:40. At 11:25 we collect everybody's kcat and Km on one slide or the whiteboard, wrap-up 11:50.</a:t>
+              <a:t>9:10 · 2 min. Neu5Ac synthase condenses ManNAc and PEP to Neu5Ac and phosphate (metal cofactor, water). HPLC-PDA at 215 nm. Two series: ManNAc varied at fixed PEP (13 reactions), PEP varied at fixed ManNAc (11 reactions); six injections each; five standards with 1–5 mM. Only the product is quantified; the substrates enter the model as their known initial values.</a:t>
             </a:r>
           </a:p>
         </p:txBody>
@@ -1425,7 +1567,7 @@
           <a:lstStyle/>
           <a:p>
             <a:r>
-              <a:t>9:12 · 3 min. README first. Two ways. With a language model: any chat model, free or by subscription (ChatGPT, Claude, Gemini, …); paste the tool card, then the task card; run the code it writes; paste errors back; the checks decide. Without writing code: the Colab link opens a prepared notebook with the tools installed and the data loaded; run it cell by cell, change a window, a prior, a series; ask the model inside Colab to explain any cell. notebooks/ are the reference solutions, open to everyone; checkpoints/ holds the result of task 1. Locally: uv sync.</a:t>
+              <a:t>9:12 · 1 min. Two series: ManNAc varied at fixed PEP (13 reactions), PEP varied at fixed ManNAc (11 reactions); six injections each, 144 chromatograms; five standards with 1–5 mM Neu5Ac that also contain the substrates, no enzyme. Participants do not get the raw traces: the instrument software exported a peak table per injection, and that is the input of task 1. Initial concentrations are in conditions.csv. Where Neu5Ac elutes is in the task card and comes up in the demo.</a:t>
             </a:r>
           </a:p>
         </p:txBody>
@@ -3604,7 +3746,85 @@
           <a:p>
             <a:r>
               <a:rPr/>
-              <a:t>Task 1: from chromatograms to EnzymeML</a:t>
+              <a:t>What we do today</a:t>
+            </a:r>
+          </a:p>
+        </p:txBody>
+      </p:sp>
+      <p:sp>
+        <p:nvSpPr>
+          <p:cNvPr id="3" name="Content Placeholder 2"/>
+          <p:cNvSpPr>
+            <a:spLocks noGrp="1"/>
+          </p:cNvSpPr>
+          <p:nvPr>
+            <p:ph idx="1"/>
+          </p:nvPr>
+        </p:nvSpPr>
+        <p:spPr/>
+        <p:txBody>
+          <a:bodyPr/>
+          <a:lstStyle/>
+          <a:p>
+            <a:r>
+              <a:rPr b="1"/>
+              <a:t>Task 1: </a:t>
+            </a:r>
+            <a:r>
+              <a:rPr/>
+              <a:t>from the peak tables to an EnzymeML document (Chromhandler)</a:t>
+            </a:r>
+          </a:p>
+          <a:p>
+            <a:r>
+              <a:rPr b="1"/>
+              <a:t>Task 2: </a:t>
+            </a:r>
+            <a:r>
+              <a:rPr/>
+              <a:t>from the EnzymeML document to </a:t>
+            </a:r>
+            <a:r>
+              <a:rPr i="1"/>
+              <a:t>k</a:t>
+            </a:r>
+            <a:r>
+              <a:rPr baseline="-25000"/>
+              <a:t>cat</a:t>
+            </a:r>
+            <a:r>
+              <a:rPr/>
+              <a:t> and </a:t>
+            </a:r>
+            <a:r>
+              <a:rPr i="1"/>
+              <a:t>K</a:t>
+            </a:r>
+            <a:r>
+              <a:rPr i="1" baseline="-25000"/>
+              <a:t>M</a:t>
+            </a:r>
+            <a:r>
+              <a:rPr/>
+              <a:t> by Bayesian inference (Catalax)</a:t>
+            </a:r>
+          </a:p>
+          <a:p>
+            <a:r>
+              <a:rPr/>
+              <a:t>A live demo of each task first, then you work in pairs</a:t>
+            </a:r>
+          </a:p>
+          <a:p>
+            <a:r>
+              <a:rPr/>
+              <a:t>The checks in the task card say when you are done</a:t>
+            </a:r>
+          </a:p>
+          <a:p>
+            <a:r>
+              <a:rPr/>
+              <a:t>At the end we compare everybody's parameters and discuss</a:t>
             </a:r>
           </a:p>
         </p:txBody>
@@ -3616,106 +3836,21 @@
             <a:spLocks noGrp="1"/>
           </p:cNvSpPr>
           <p:nvPr>
-            <p:ph type="body" idx="2" sz="half"/>
-          </p:nvPr>
-        </p:nvSpPr>
-        <p:spPr>
-          <a:xfrm>
-            <a:off x="822960" y="4663440"/>
-            <a:ext cx="10545775" cy="1097280"/>
-          </a:xfrm>
-        </p:spPr>
+            <p:ph type="body" idx="13" sz="quarter"/>
+          </p:nvPr>
+        </p:nvSpPr>
+        <p:spPr/>
         <p:txBody>
           <a:bodyPr/>
           <a:lstStyle/>
           <a:p>
             <a:r>
-              <a:rPr b="1"/>
-              <a:t>Goal: </a:t>
-            </a:r>
-            <a:r>
               <a:rPr/>
-              <a:t>an EnzymeML document with 24 calibrated Neu5Ac time courses</a:t>
-            </a:r>
-          </a:p>
-          <a:p>
-            <a:r>
-              <a:rPr b="1"/>
-              <a:t>Your decision: </a:t>
-            </a:r>
-            <a:r>
-              <a:rPr/>
-              <a:t>the Neu5Ac retention window, different in standards and reactions</a:t>
-            </a:r>
-          </a:p>
-          <a:p>
-            <a:r>
-              <a:rPr b="1"/>
-              <a:t>Checks: </a:t>
-            </a:r>
-            <a:r>
-              <a:rPr/>
-              <a:t>slope ≈ 239 000 area per mM, R² ≥ 0.99; 24 measurements, six increasing time points each</a:t>
-            </a:r>
-          </a:p>
-          <a:p>
-            <a:r>
-              <a:rPr b="1"/>
-              <a:t>Live demo: </a:t>
-            </a:r>
-            <a:r>
-              <a:rPr/>
-              <a:t>one deliberate mistake, the standards window used for the reactions</a:t>
-            </a:r>
-          </a:p>
-        </p:txBody>
-      </p:sp>
-      <p:sp>
-        <p:nvSpPr>
-          <p:cNvPr id="5" name="Text Placeholder 4"/>
-          <p:cNvSpPr>
-            <a:spLocks noGrp="1"/>
-          </p:cNvSpPr>
-          <p:nvPr>
-            <p:ph type="body" idx="13" sz="quarter"/>
-          </p:nvPr>
-        </p:nvSpPr>
-        <p:spPr/>
-        <p:txBody>
-          <a:bodyPr/>
-          <a:lstStyle/>
-          <a:p>
-            <a:r>
-              <a:rPr/>
-              <a:t>Task 1</a:t>
-            </a:r>
-          </a:p>
-        </p:txBody>
-      </p:sp>
-      <p:pic>
-        <p:nvPicPr>
-          <p:cNvPr id="8" name="Picture 7" descr="time_courses.png"/>
-          <p:cNvPicPr>
-            <a:picLocks noChangeAspect="1"/>
-          </p:cNvPicPr>
-          <p:nvPr/>
-        </p:nvPicPr>
-        <p:blipFill>
-          <a:blip r:embed="rId3"/>
-          <a:stretch>
-            <a:fillRect/>
-          </a:stretch>
-        </p:blipFill>
-        <p:spPr>
-          <a:xfrm>
-            <a:off x="1928617" y="1645920"/>
-            <a:ext cx="8334461" cy="2880360"/>
-          </a:xfrm>
-          <a:prstGeom prst="rect">
-            <a:avLst/>
-          </a:prstGeom>
-        </p:spPr>
-      </p:pic>
+              <a:t>Today</a:t>
+            </a:r>
+          </a:p>
+        </p:txBody>
+      </p:sp>
     </p:spTree>
   </p:cSld>
   <p:clrMapOvr>
@@ -3751,7 +3886,7 @@
           <a:p>
             <a:r>
               <a:rPr/>
-              <a:t>Task 2: kinetic parameters by Bayesian inference</a:t>
+              <a:t>One repository, two ways to work</a:t>
             </a:r>
           </a:p>
         </p:txBody>
@@ -3763,7 +3898,7 @@
             <a:spLocks noGrp="1"/>
           </p:cNvSpPr>
           <p:nvPr>
-            <p:ph idx="1"/>
+            <p:ph idx="1" sz="half"/>
           </p:nvPr>
         </p:nvSpPr>
         <p:spPr/>
@@ -3771,94 +3906,114 @@
           <a:bodyPr/>
           <a:lstStyle/>
           <a:p>
+            <a:pPr marL="0" indent="0">
+              <a:buNone/>
+            </a:pPr>
             <a:r>
               <a:rPr b="1"/>
-              <a:t>Goal: </a:t>
+              <a:t>With a language model</a:t>
+            </a:r>
+          </a:p>
+          <a:p>
+            <a:r>
+              <a:rPr b="1"/>
+              <a:t>Any chat model, </a:t>
             </a:r>
             <a:r>
               <a:rPr/>
-              <a:t>posterior distributions of </a:t>
-            </a:r>
-            <a:r>
-              <a:rPr i="1"/>
-              <a:t>k</a:t>
-            </a:r>
-            <a:r>
-              <a:rPr baseline="-25000"/>
-              <a:t>cat</a:t>
+              <a:t>free or by subscription: ChatGPT, Claude, Gemini, …</a:t>
+            </a:r>
+          </a:p>
+          <a:p>
+            <a:r>
+              <a:rPr b="1"/>
+              <a:t>Paste </a:t>
             </a:r>
             <a:r>
               <a:rPr/>
-              <a:t>, </a:t>
-            </a:r>
-            <a:r>
-              <a:rPr i="1"/>
-              <a:t>K</a:t>
-            </a:r>
-            <a:r>
-              <a:rPr i="1" baseline="-25000"/>
-              <a:t>M</a:t>
-            </a:r>
-            <a:r>
-              <a:rPr baseline="30000"/>
-              <a:t>ManNAc</a:t>
+              <a:t>the tool card and the task card; run the code, paste errors back</a:t>
+            </a:r>
+          </a:p>
+          <a:p>
+            <a:r>
+              <a:rPr b="1"/>
+              <a:t>The checks </a:t>
             </a:r>
             <a:r>
               <a:rPr/>
-              <a:t> and </a:t>
-            </a:r>
-            <a:r>
-              <a:rPr i="1"/>
-              <a:t>K</a:t>
-            </a:r>
-            <a:r>
-              <a:rPr i="1" baseline="-25000"/>
-              <a:t>M</a:t>
-            </a:r>
-            <a:r>
-              <a:rPr baseline="30000"/>
-              <a:t>PEP</a:t>
+              <a:t>decide when you are done</a:t>
+            </a:r>
+          </a:p>
+          <a:p>
+            <a:r>
+              <a:rPr b="1"/>
+              <a:t>notebooks/ </a:t>
             </a:r>
             <a:r>
               <a:rPr/>
-              <a:t>, with a fit plot</a:t>
-            </a:r>
-          </a:p>
-          <a:p>
+              <a:t>are the reference solutions, checkpoints/ the result of task 1</a:t>
+            </a:r>
+          </a:p>
+        </p:txBody>
+      </p:sp>
+      <p:sp>
+        <p:nvSpPr>
+          <p:cNvPr id="4" name="Content Placeholder 3"/>
+          <p:cNvSpPr>
+            <a:spLocks noGrp="1"/>
+          </p:cNvSpPr>
+          <p:nvPr>
+            <p:ph idx="2" sz="half"/>
+          </p:nvPr>
+        </p:nvSpPr>
+        <p:spPr/>
+        <p:txBody>
+          <a:bodyPr/>
+          <a:lstStyle/>
+          <a:p>
+            <a:pPr marL="0" indent="0">
+              <a:buNone/>
+            </a:pPr>
             <a:r>
               <a:rPr b="1"/>
-              <a:t>Model: </a:t>
+              <a:t>Without writing code</a:t>
+            </a:r>
+          </a:p>
+          <a:p>
+            <a:r>
+              <a:rPr b="1"/>
+              <a:t>Open the Colab link: </a:t>
             </a:r>
             <a:r>
               <a:rPr/>
-              <a:t>the enzyme is in the rate law, only Neu5Ac is measured, the metal cofactor is left out (a simplification)</a:t>
+              <a:t>a prepared notebook, tools installed, data loaded</a:t>
             </a:r>
           </a:p>
           <a:p>
             <a:r>
               <a:rPr b="1"/>
-              <a:t>Your decisions: </a:t>
+              <a:t>Run it cell by cell; </a:t>
             </a:r>
             <a:r>
               <a:rPr/>
-              <a:t>the priors, the assumed measurement noise, the sampler settings</a:t>
+              <a:t>change a window, a prior, a series</a:t>
             </a:r>
           </a:p>
           <a:p>
             <a:r>
               <a:rPr b="1"/>
-              <a:t>Checks: </a:t>
+              <a:t>Ask the model in Colab </a:t>
             </a:r>
             <a:r>
               <a:rPr/>
-              <a:t>r-hat near 1, no divergences, posterior clear of the prior bounds</a:t>
-            </a:r>
-          </a:p>
-        </p:txBody>
-      </p:sp>
-      <p:sp>
-        <p:nvSpPr>
-          <p:cNvPr id="4" name="Text Placeholder 3"/>
+              <a:t>to explain any cell</a:t>
+            </a:r>
+          </a:p>
+        </p:txBody>
+      </p:sp>
+      <p:sp>
+        <p:nvSpPr>
+          <p:cNvPr id="5" name="Text Placeholder 4"/>
           <p:cNvSpPr>
             <a:spLocks noGrp="1"/>
           </p:cNvSpPr>
@@ -3873,14 +4028,14 @@
           <a:p>
             <a:r>
               <a:rPr/>
-              <a:t>Task 2</a:t>
-            </a:r>
-          </a:p>
-        </p:txBody>
-      </p:sp>
-      <p:sp>
-        <p:nvSpPr>
-          <p:cNvPr id="5" name="Text Placeholder 4"/>
+              <a:t>Toolkit</a:t>
+            </a:r>
+          </a:p>
+        </p:txBody>
+      </p:sp>
+      <p:sp>
+        <p:nvSpPr>
+          <p:cNvPr id="6" name="Text Placeholder 5"/>
           <p:cNvSpPr>
             <a:spLocks noGrp="1"/>
           </p:cNvSpPr>
@@ -3895,51 +4050,7 @@
           <a:p>
             <a:r>
               <a:rPr/>
-              <a:t>v = </a:t>
-            </a:r>
-            <a:r>
-              <a:rPr i="1"/>
-              <a:t>k</a:t>
-            </a:r>
-            <a:r>
-              <a:rPr baseline="-25000"/>
-              <a:t>cat</a:t>
-            </a:r>
-            <a:r>
-              <a:rPr/>
-              <a:t> · [NeuS] · [ManNAc] · [PEP] / ((</a:t>
-            </a:r>
-            <a:r>
-              <a:rPr i="1"/>
-              <a:t>K</a:t>
-            </a:r>
-            <a:r>
-              <a:rPr i="1" baseline="-25000"/>
-              <a:t>M</a:t>
-            </a:r>
-            <a:r>
-              <a:rPr baseline="30000"/>
-              <a:t>ManNAc</a:t>
-            </a:r>
-            <a:r>
-              <a:rPr/>
-              <a:t> + [ManNAc]) (</a:t>
-            </a:r>
-            <a:r>
-              <a:rPr i="1"/>
-              <a:t>K</a:t>
-            </a:r>
-            <a:r>
-              <a:rPr i="1" baseline="-25000"/>
-              <a:t>M</a:t>
-            </a:r>
-            <a:r>
-              <a:rPr baseline="30000"/>
-              <a:t>PEP</a:t>
-            </a:r>
-            <a:r>
-              <a:rPr/>
-              <a:t> + [PEP]))</a:t>
+              <a:t>github.com/haeussma/enzymeml-workshop-modelling-2026 · start with the README</a:t>
             </a:r>
           </a:p>
         </p:txBody>
@@ -3953,6 +4064,381 @@
 </file>
 
 <file path=ppt/slides/slide12.xml><?xml version="1.0" encoding="utf-8"?>
+<p:sld xmlns:a="http://schemas.openxmlformats.org/drawingml/2006/main" xmlns:p="http://schemas.openxmlformats.org/presentationml/2006/main" xmlns:r="http://schemas.openxmlformats.org/officeDocument/2006/relationships">
+  <p:cSld>
+    <p:spTree>
+      <p:nvGrpSpPr>
+        <p:cNvPr id="1" name=""/>
+        <p:cNvGrpSpPr/>
+        <p:nvPr/>
+      </p:nvGrpSpPr>
+      <p:grpSpPr/>
+      <p:sp>
+        <p:nvSpPr>
+          <p:cNvPr id="2" name="Title 1"/>
+          <p:cNvSpPr>
+            <a:spLocks noGrp="1"/>
+          </p:cNvSpPr>
+          <p:nvPr>
+            <p:ph type="title"/>
+          </p:nvPr>
+        </p:nvSpPr>
+        <p:spPr/>
+        <p:txBody>
+          <a:bodyPr/>
+          <a:lstStyle/>
+          <a:p>
+            <a:r>
+              <a:rPr/>
+              <a:t>Task 1: from chromatograms to EnzymeML</a:t>
+            </a:r>
+          </a:p>
+        </p:txBody>
+      </p:sp>
+      <p:sp>
+        <p:nvSpPr>
+          <p:cNvPr id="4" name="Text Placeholder 3"/>
+          <p:cNvSpPr>
+            <a:spLocks noGrp="1"/>
+          </p:cNvSpPr>
+          <p:nvPr>
+            <p:ph type="body" idx="2" sz="half"/>
+          </p:nvPr>
+        </p:nvSpPr>
+        <p:spPr>
+          <a:xfrm>
+            <a:off x="822960" y="4663440"/>
+            <a:ext cx="10545775" cy="1097280"/>
+          </a:xfrm>
+        </p:spPr>
+        <p:txBody>
+          <a:bodyPr/>
+          <a:lstStyle/>
+          <a:p>
+            <a:r>
+              <a:rPr b="1"/>
+              <a:t>Goal: </a:t>
+            </a:r>
+            <a:r>
+              <a:rPr/>
+              <a:t>an EnzymeML document with 24 calibrated Neu5Ac time courses</a:t>
+            </a:r>
+          </a:p>
+          <a:p>
+            <a:r>
+              <a:rPr b="1"/>
+              <a:t>Your decision: </a:t>
+            </a:r>
+            <a:r>
+              <a:rPr/>
+              <a:t>the Neu5Ac retention window, different in standards and reactions</a:t>
+            </a:r>
+          </a:p>
+          <a:p>
+            <a:r>
+              <a:rPr b="1"/>
+              <a:t>Checks: </a:t>
+            </a:r>
+            <a:r>
+              <a:rPr/>
+              <a:t>slope ≈ 239 000 area per mM, R² ≥ 0.99; 24 measurements, six increasing time points each</a:t>
+            </a:r>
+          </a:p>
+          <a:p>
+            <a:r>
+              <a:rPr b="1"/>
+              <a:t>Live demo: </a:t>
+            </a:r>
+            <a:r>
+              <a:rPr/>
+              <a:t>one deliberate mistake, the standards window used for the reactions</a:t>
+            </a:r>
+          </a:p>
+        </p:txBody>
+      </p:sp>
+      <p:sp>
+        <p:nvSpPr>
+          <p:cNvPr id="5" name="Text Placeholder 4"/>
+          <p:cNvSpPr>
+            <a:spLocks noGrp="1"/>
+          </p:cNvSpPr>
+          <p:nvPr>
+            <p:ph type="body" idx="13" sz="quarter"/>
+          </p:nvPr>
+        </p:nvSpPr>
+        <p:spPr/>
+        <p:txBody>
+          <a:bodyPr/>
+          <a:lstStyle/>
+          <a:p>
+            <a:r>
+              <a:rPr/>
+              <a:t>Task 1</a:t>
+            </a:r>
+          </a:p>
+        </p:txBody>
+      </p:sp>
+      <p:pic>
+        <p:nvPicPr>
+          <p:cNvPr id="8" name="Picture 7" descr="time_courses.png"/>
+          <p:cNvPicPr>
+            <a:picLocks noChangeAspect="1"/>
+          </p:cNvPicPr>
+          <p:nvPr/>
+        </p:nvPicPr>
+        <p:blipFill>
+          <a:blip r:embed="rId3"/>
+          <a:stretch>
+            <a:fillRect/>
+          </a:stretch>
+        </p:blipFill>
+        <p:spPr>
+          <a:xfrm>
+            <a:off x="1928617" y="1645920"/>
+            <a:ext cx="8334461" cy="2880360"/>
+          </a:xfrm>
+          <a:prstGeom prst="rect">
+            <a:avLst/>
+          </a:prstGeom>
+        </p:spPr>
+      </p:pic>
+    </p:spTree>
+  </p:cSld>
+  <p:clrMapOvr>
+    <a:masterClrMapping/>
+  </p:clrMapOvr>
+</p:sld>
+</file>
+
+<file path=ppt/slides/slide13.xml><?xml version="1.0" encoding="utf-8"?>
+<p:sld xmlns:a="http://schemas.openxmlformats.org/drawingml/2006/main" xmlns:p="http://schemas.openxmlformats.org/presentationml/2006/main" xmlns:r="http://schemas.openxmlformats.org/officeDocument/2006/relationships">
+  <p:cSld>
+    <p:spTree>
+      <p:nvGrpSpPr>
+        <p:cNvPr id="1" name=""/>
+        <p:cNvGrpSpPr/>
+        <p:nvPr/>
+      </p:nvGrpSpPr>
+      <p:grpSpPr/>
+      <p:sp>
+        <p:nvSpPr>
+          <p:cNvPr id="2" name="Title 1"/>
+          <p:cNvSpPr>
+            <a:spLocks noGrp="1"/>
+          </p:cNvSpPr>
+          <p:nvPr>
+            <p:ph type="title"/>
+          </p:nvPr>
+        </p:nvSpPr>
+        <p:spPr/>
+        <p:txBody>
+          <a:bodyPr/>
+          <a:lstStyle/>
+          <a:p>
+            <a:r>
+              <a:rPr/>
+              <a:t>Task 2: kinetic parameters by Bayesian inference</a:t>
+            </a:r>
+          </a:p>
+        </p:txBody>
+      </p:sp>
+      <p:sp>
+        <p:nvSpPr>
+          <p:cNvPr id="3" name="Content Placeholder 2"/>
+          <p:cNvSpPr>
+            <a:spLocks noGrp="1"/>
+          </p:cNvSpPr>
+          <p:nvPr>
+            <p:ph idx="1"/>
+          </p:nvPr>
+        </p:nvSpPr>
+        <p:spPr/>
+        <p:txBody>
+          <a:bodyPr/>
+          <a:lstStyle/>
+          <a:p>
+            <a:r>
+              <a:rPr b="1"/>
+              <a:t>Goal: </a:t>
+            </a:r>
+            <a:r>
+              <a:rPr/>
+              <a:t>posterior distributions of </a:t>
+            </a:r>
+            <a:r>
+              <a:rPr i="1"/>
+              <a:t>k</a:t>
+            </a:r>
+            <a:r>
+              <a:rPr baseline="-25000"/>
+              <a:t>cat</a:t>
+            </a:r>
+            <a:r>
+              <a:rPr/>
+              <a:t>, </a:t>
+            </a:r>
+            <a:r>
+              <a:rPr i="1"/>
+              <a:t>K</a:t>
+            </a:r>
+            <a:r>
+              <a:rPr i="1" baseline="-25000"/>
+              <a:t>M</a:t>
+            </a:r>
+            <a:r>
+              <a:rPr baseline="30000"/>
+              <a:t>ManNAc</a:t>
+            </a:r>
+            <a:r>
+              <a:rPr/>
+              <a:t> and </a:t>
+            </a:r>
+            <a:r>
+              <a:rPr i="1"/>
+              <a:t>K</a:t>
+            </a:r>
+            <a:r>
+              <a:rPr i="1" baseline="-25000"/>
+              <a:t>M</a:t>
+            </a:r>
+            <a:r>
+              <a:rPr baseline="30000"/>
+              <a:t>PEP</a:t>
+            </a:r>
+            <a:r>
+              <a:rPr/>
+              <a:t>, with a fit plot</a:t>
+            </a:r>
+          </a:p>
+          <a:p>
+            <a:r>
+              <a:rPr b="1"/>
+              <a:t>Model: </a:t>
+            </a:r>
+            <a:r>
+              <a:rPr/>
+              <a:t>the enzyme is in the rate law, only Neu5Ac is measured, the metal cofactor is left out (a simplification)</a:t>
+            </a:r>
+          </a:p>
+          <a:p>
+            <a:r>
+              <a:rPr b="1"/>
+              <a:t>Your decisions: </a:t>
+            </a:r>
+            <a:r>
+              <a:rPr/>
+              <a:t>the priors, the assumed measurement noise, the sampler settings</a:t>
+            </a:r>
+          </a:p>
+          <a:p>
+            <a:r>
+              <a:rPr b="1"/>
+              <a:t>Checks: </a:t>
+            </a:r>
+            <a:r>
+              <a:rPr/>
+              <a:t>r-hat near 1, no divergences, posterior clear of the prior bounds</a:t>
+            </a:r>
+          </a:p>
+        </p:txBody>
+      </p:sp>
+      <p:sp>
+        <p:nvSpPr>
+          <p:cNvPr id="4" name="Text Placeholder 3"/>
+          <p:cNvSpPr>
+            <a:spLocks noGrp="1"/>
+          </p:cNvSpPr>
+          <p:nvPr>
+            <p:ph type="body" idx="13" sz="quarter"/>
+          </p:nvPr>
+        </p:nvSpPr>
+        <p:spPr/>
+        <p:txBody>
+          <a:bodyPr/>
+          <a:lstStyle/>
+          <a:p>
+            <a:r>
+              <a:rPr/>
+              <a:t>Task 2</a:t>
+            </a:r>
+          </a:p>
+        </p:txBody>
+      </p:sp>
+      <p:sp>
+        <p:nvSpPr>
+          <p:cNvPr id="5" name="Text Placeholder 4"/>
+          <p:cNvSpPr>
+            <a:spLocks noGrp="1"/>
+          </p:cNvSpPr>
+          <p:nvPr>
+            <p:ph type="body" idx="15" sz="quarter"/>
+          </p:nvPr>
+        </p:nvSpPr>
+        <p:spPr/>
+        <p:txBody>
+          <a:bodyPr/>
+          <a:lstStyle/>
+          <a:p>
+            <a:r>
+              <a:rPr/>
+              <a:t>v = </a:t>
+            </a:r>
+            <a:r>
+              <a:rPr i="1"/>
+              <a:t>k</a:t>
+            </a:r>
+            <a:r>
+              <a:rPr baseline="-25000"/>
+              <a:t>cat</a:t>
+            </a:r>
+            <a:r>
+              <a:rPr/>
+              <a:t> · [NeuS] · [ManNAc] · [PEP] / ((</a:t>
+            </a:r>
+            <a:r>
+              <a:rPr i="1"/>
+              <a:t>K</a:t>
+            </a:r>
+            <a:r>
+              <a:rPr i="1" baseline="-25000"/>
+              <a:t>M</a:t>
+            </a:r>
+            <a:r>
+              <a:rPr baseline="30000"/>
+              <a:t>ManNAc</a:t>
+            </a:r>
+            <a:r>
+              <a:rPr/>
+              <a:t> + [ManNAc]) (</a:t>
+            </a:r>
+            <a:r>
+              <a:rPr i="1"/>
+              <a:t>K</a:t>
+            </a:r>
+            <a:r>
+              <a:rPr i="1" baseline="-25000"/>
+              <a:t>M</a:t>
+            </a:r>
+            <a:r>
+              <a:rPr baseline="30000"/>
+              <a:t>PEP</a:t>
+            </a:r>
+            <a:r>
+              <a:rPr/>
+              <a:t> + [PEP]))</a:t>
+            </a:r>
+          </a:p>
+        </p:txBody>
+      </p:sp>
+    </p:spTree>
+  </p:cSld>
+  <p:clrMapOvr>
+    <a:masterClrMapping/>
+  </p:clrMapOvr>
+</p:sld>
+</file>
+
+<file path=ppt/slides/slide14.xml><?xml version="1.0" encoding="utf-8"?>
 <p:sld xmlns:a="http://schemas.openxmlformats.org/drawingml/2006/main" xmlns:p="http://schemas.openxmlformats.org/presentationml/2006/main" xmlns:r="http://schemas.openxmlformats.org/officeDocument/2006/relationships">
   <p:cSld>
     <p:spTree>
@@ -4247,7 +4733,7 @@
 </p:sld>
 </file>
 
-<file path=ppt/slides/slide13.xml><?xml version="1.0" encoding="utf-8"?>
+<file path=ppt/slides/slide15.xml><?xml version="1.0" encoding="utf-8"?>
 <p:sld xmlns:a="http://schemas.openxmlformats.org/drawingml/2006/main" xmlns:p="http://schemas.openxmlformats.org/presentationml/2006/main" xmlns:r="http://schemas.openxmlformats.org/officeDocument/2006/relationships">
   <p:cSld>
     <p:spTree>
@@ -4349,7 +4835,7 @@
 </p:sld>
 </file>
 
-<file path=ppt/slides/slide14.xml><?xml version="1.0" encoding="utf-8"?>
+<file path=ppt/slides/slide16.xml><?xml version="1.0" encoding="utf-8"?>
 <p:sld xmlns:a="http://schemas.openxmlformats.org/drawingml/2006/main" xmlns:p="http://schemas.openxmlformats.org/presentationml/2006/main" xmlns:r="http://schemas.openxmlformats.org/officeDocument/2006/relationships">
   <p:cSld>
     <p:spTree>
@@ -6873,6 +7359,2682 @@
           <a:p>
             <a:r>
               <a:rPr/>
+              <a:t>Chromhandler: from peak tables to concentrations</a:t>
+            </a:r>
+          </a:p>
+        </p:txBody>
+      </p:sp>
+      <p:sp>
+        <p:nvSpPr>
+          <p:cNvPr id="3" name="Text Placeholder 2"/>
+          <p:cNvSpPr>
+            <a:spLocks noGrp="1"/>
+          </p:cNvSpPr>
+          <p:nvPr>
+            <p:ph type="body" idx="13" sz="quarter"/>
+          </p:nvPr>
+        </p:nvSpPr>
+        <p:spPr/>
+        <p:txBody>
+          <a:bodyPr/>
+          <a:lstStyle/>
+          <a:p>
+            <a:r>
+              <a:rPr/>
+              <a:t>Tool 1 · Chromhandler</a:t>
+            </a:r>
+          </a:p>
+        </p:txBody>
+      </p:sp>
+      <p:sp>
+        <p:nvSpPr>
+          <p:cNvPr id="4" name="Text Placeholder 3"/>
+          <p:cNvSpPr>
+            <a:spLocks noGrp="1"/>
+          </p:cNvSpPr>
+          <p:nvPr>
+            <p:ph type="body" idx="15" sz="quarter"/>
+          </p:nvPr>
+        </p:nvSpPr>
+        <p:spPr/>
+        <p:txBody>
+          <a:bodyPr/>
+          <a:lstStyle/>
+          <a:p>
+            <a:r>
+              <a:rPr/>
+              <a:t>Reads the instrument's exports, assigns and calibrates one peak per compound, writes EnzymeML</a:t>
+            </a:r>
+          </a:p>
+        </p:txBody>
+      </p:sp>
+      <p:sp>
+        <p:nvSpPr>
+          <p:cNvPr id="6" name="TextBox 5"/>
+          <p:cNvSpPr txBox="1"/>
+          <p:nvPr/>
+        </p:nvSpPr>
+        <p:spPr>
+          <a:xfrm>
+            <a:off x="822960" y="2057400"/>
+            <a:ext cx="2743200" cy="274320"/>
+          </a:xfrm>
+          <a:prstGeom prst="rect">
+            <a:avLst/>
+          </a:prstGeom>
+          <a:noFill/>
+        </p:spPr>
+        <p:txBody>
+          <a:bodyPr wrap="square" lIns="0" rIns="0" tIns="0" bIns="0">
+            <a:spAutoFit/>
+          </a:bodyPr>
+          <a:lstStyle/>
+          <a:p>
+            <a:pPr algn="ctr"/>
+            <a:r>
+              <a:rPr sz="1200">
+                <a:solidFill>
+                  <a:srgbClr val="6F6F6F"/>
+                </a:solidFill>
+              </a:rPr>
+              <a:t>Input</a:t>
+            </a:r>
+          </a:p>
+        </p:txBody>
+      </p:sp>
+      <p:sp>
+        <p:nvSpPr>
+          <p:cNvPr id="7" name="TextBox 6"/>
+          <p:cNvSpPr txBox="1"/>
+          <p:nvPr/>
+        </p:nvSpPr>
+        <p:spPr>
+          <a:xfrm>
+            <a:off x="4087368" y="2057400"/>
+            <a:ext cx="4023360" cy="274320"/>
+          </a:xfrm>
+          <a:prstGeom prst="rect">
+            <a:avLst/>
+          </a:prstGeom>
+          <a:noFill/>
+        </p:spPr>
+        <p:txBody>
+          <a:bodyPr wrap="square" lIns="0" rIns="0" tIns="0" bIns="0">
+            <a:spAutoFit/>
+          </a:bodyPr>
+          <a:lstStyle/>
+          <a:p>
+            <a:pPr algn="ctr"/>
+            <a:r>
+              <a:rPr sz="1200">
+                <a:solidFill>
+                  <a:srgbClr val="6F6F6F"/>
+                </a:solidFill>
+              </a:rPr>
+              <a:t>Steps</a:t>
+            </a:r>
+          </a:p>
+        </p:txBody>
+      </p:sp>
+      <p:sp>
+        <p:nvSpPr>
+          <p:cNvPr id="8" name="TextBox 7"/>
+          <p:cNvSpPr txBox="1"/>
+          <p:nvPr/>
+        </p:nvSpPr>
+        <p:spPr>
+          <a:xfrm>
+            <a:off x="8622792" y="2057400"/>
+            <a:ext cx="2743200" cy="274320"/>
+          </a:xfrm>
+          <a:prstGeom prst="rect">
+            <a:avLst/>
+          </a:prstGeom>
+          <a:noFill/>
+        </p:spPr>
+        <p:txBody>
+          <a:bodyPr wrap="square" lIns="0" rIns="0" tIns="0" bIns="0">
+            <a:spAutoFit/>
+          </a:bodyPr>
+          <a:lstStyle/>
+          <a:p>
+            <a:pPr algn="ctr"/>
+            <a:r>
+              <a:rPr sz="1200">
+                <a:solidFill>
+                  <a:srgbClr val="6F6F6F"/>
+                </a:solidFill>
+              </a:rPr>
+              <a:t>Output</a:t>
+            </a:r>
+          </a:p>
+        </p:txBody>
+      </p:sp>
+      <p:sp>
+        <p:nvSpPr>
+          <p:cNvPr id="9" name="Rounded Rectangle 8"/>
+          <p:cNvSpPr/>
+          <p:nvPr/>
+        </p:nvSpPr>
+        <p:spPr>
+          <a:xfrm>
+            <a:off x="822960" y="2377440"/>
+            <a:ext cx="2743200" cy="685800"/>
+          </a:xfrm>
+          <a:prstGeom prst="roundRect">
+            <a:avLst>
+              <a:gd name="adj" fmla="val 12000"/>
+            </a:avLst>
+          </a:prstGeom>
+          <a:noFill/>
+          <a:ln w="12700">
+            <a:solidFill>
+              <a:srgbClr val="0A0A0A"/>
+            </a:solidFill>
+          </a:ln>
+          <a:effectLst/>
+        </p:spPr>
+        <p:style>
+          <a:lnRef idx="1">
+            <a:schemeClr val="accent1"/>
+          </a:lnRef>
+          <a:fillRef idx="3">
+            <a:schemeClr val="accent1"/>
+          </a:fillRef>
+          <a:effectRef idx="2">
+            <a:schemeClr val="accent1"/>
+          </a:effectRef>
+          <a:fontRef idx="minor">
+            <a:schemeClr val="lt1"/>
+          </a:fontRef>
+        </p:style>
+        <p:txBody>
+          <a:bodyPr rtlCol="0" anchor="ctr" wrap="square" lIns="73152" rIns="73152"/>
+          <a:lstStyle/>
+          <a:p>
+            <a:pPr algn="ctr"/>
+            <a:r>
+              <a:rPr b="1" sz="1400">
+                <a:solidFill>
+                  <a:srgbClr val="0A0A0A"/>
+                </a:solidFill>
+              </a:rPr>
+              <a:t>Peak tables</a:t>
+            </a:r>
+          </a:p>
+          <a:p>
+            <a:pPr algn="ctr"/>
+            <a:r>
+              <a:rPr sz="1100">
+                <a:solidFill>
+                  <a:srgbClr val="6F6F6F"/>
+                </a:solidFill>
+              </a:rPr>
+              <a:t>one export per injection, the time in the file name</a:t>
+            </a:r>
+          </a:p>
+        </p:txBody>
+      </p:sp>
+      <p:cxnSp>
+        <p:nvCxnSpPr>
+          <p:cNvPr id="10" name="Connector 9"/>
+          <p:cNvCxnSpPr/>
+          <p:nvPr/>
+        </p:nvCxnSpPr>
+        <p:spPr>
+          <a:xfrm>
+            <a:off x="3566160" y="2720340"/>
+            <a:ext cx="228600" cy="0"/>
+          </a:xfrm>
+          <a:prstGeom prst="line">
+            <a:avLst/>
+          </a:prstGeom>
+          <a:ln w="15875">
+            <a:solidFill>
+              <a:srgbClr val="0A0A0A"/>
+            </a:solidFill>
+          </a:ln>
+        </p:spPr>
+        <p:style>
+          <a:lnRef idx="2">
+            <a:schemeClr val="accent1"/>
+          </a:lnRef>
+          <a:fillRef idx="0">
+            <a:schemeClr val="accent1"/>
+          </a:fillRef>
+          <a:effectRef idx="1">
+            <a:schemeClr val="accent1"/>
+          </a:effectRef>
+          <a:fontRef idx="minor">
+            <a:schemeClr val="tx1"/>
+          </a:fontRef>
+        </p:style>
+      </p:cxnSp>
+      <p:sp>
+        <p:nvSpPr>
+          <p:cNvPr id="11" name="Rounded Rectangle 10"/>
+          <p:cNvSpPr/>
+          <p:nvPr/>
+        </p:nvSpPr>
+        <p:spPr>
+          <a:xfrm>
+            <a:off x="822960" y="3291840"/>
+            <a:ext cx="2743200" cy="685800"/>
+          </a:xfrm>
+          <a:prstGeom prst="roundRect">
+            <a:avLst>
+              <a:gd name="adj" fmla="val 12000"/>
+            </a:avLst>
+          </a:prstGeom>
+          <a:noFill/>
+          <a:ln w="12700">
+            <a:solidFill>
+              <a:srgbClr val="0A0A0A"/>
+            </a:solidFill>
+          </a:ln>
+          <a:effectLst/>
+        </p:spPr>
+        <p:style>
+          <a:lnRef idx="1">
+            <a:schemeClr val="accent1"/>
+          </a:lnRef>
+          <a:fillRef idx="3">
+            <a:schemeClr val="accent1"/>
+          </a:fillRef>
+          <a:effectRef idx="2">
+            <a:schemeClr val="accent1"/>
+          </a:effectRef>
+          <a:fontRef idx="minor">
+            <a:schemeClr val="lt1"/>
+          </a:fontRef>
+        </p:style>
+        <p:txBody>
+          <a:bodyPr rtlCol="0" anchor="ctr" wrap="square" lIns="73152" rIns="73152"/>
+          <a:lstStyle/>
+          <a:p>
+            <a:pPr algn="ctr"/>
+            <a:r>
+              <a:rPr b="1" sz="1400">
+                <a:solidFill>
+                  <a:srgbClr val="0A0A0A"/>
+                </a:solidFill>
+              </a:rPr>
+              <a:t>Calibration standards</a:t>
+            </a:r>
+          </a:p>
+          <a:p>
+            <a:pPr algn="ctr"/>
+            <a:r>
+              <a:rPr sz="1100">
+                <a:solidFill>
+                  <a:srgbClr val="6F6F6F"/>
+                </a:solidFill>
+              </a:rPr>
+              <a:t>exports with known concentrations</a:t>
+            </a:r>
+          </a:p>
+        </p:txBody>
+      </p:sp>
+      <p:cxnSp>
+        <p:nvCxnSpPr>
+          <p:cNvPr id="12" name="Connector 11"/>
+          <p:cNvCxnSpPr/>
+          <p:nvPr/>
+        </p:nvCxnSpPr>
+        <p:spPr>
+          <a:xfrm>
+            <a:off x="3566160" y="3634740"/>
+            <a:ext cx="228600" cy="0"/>
+          </a:xfrm>
+          <a:prstGeom prst="line">
+            <a:avLst/>
+          </a:prstGeom>
+          <a:ln w="15875">
+            <a:solidFill>
+              <a:srgbClr val="0A0A0A"/>
+            </a:solidFill>
+          </a:ln>
+        </p:spPr>
+        <p:style>
+          <a:lnRef idx="2">
+            <a:schemeClr val="accent1"/>
+          </a:lnRef>
+          <a:fillRef idx="0">
+            <a:schemeClr val="accent1"/>
+          </a:fillRef>
+          <a:effectRef idx="1">
+            <a:schemeClr val="accent1"/>
+          </a:effectRef>
+          <a:fontRef idx="minor">
+            <a:schemeClr val="tx1"/>
+          </a:fontRef>
+        </p:style>
+      </p:cxnSp>
+      <p:sp>
+        <p:nvSpPr>
+          <p:cNvPr id="13" name="Rounded Rectangle 12"/>
+          <p:cNvSpPr/>
+          <p:nvPr/>
+        </p:nvSpPr>
+        <p:spPr>
+          <a:xfrm>
+            <a:off x="822960" y="4206240"/>
+            <a:ext cx="2743200" cy="685800"/>
+          </a:xfrm>
+          <a:prstGeom prst="roundRect">
+            <a:avLst>
+              <a:gd name="adj" fmla="val 12000"/>
+            </a:avLst>
+          </a:prstGeom>
+          <a:noFill/>
+          <a:ln w="12700">
+            <a:solidFill>
+              <a:srgbClr val="0A0A0A"/>
+            </a:solidFill>
+          </a:ln>
+          <a:effectLst/>
+        </p:spPr>
+        <p:style>
+          <a:lnRef idx="1">
+            <a:schemeClr val="accent1"/>
+          </a:lnRef>
+          <a:fillRef idx="3">
+            <a:schemeClr val="accent1"/>
+          </a:fillRef>
+          <a:effectRef idx="2">
+            <a:schemeClr val="accent1"/>
+          </a:effectRef>
+          <a:fontRef idx="minor">
+            <a:schemeClr val="lt1"/>
+          </a:fontRef>
+        </p:style>
+        <p:txBody>
+          <a:bodyPr rtlCol="0" anchor="ctr" wrap="square" lIns="73152" rIns="73152"/>
+          <a:lstStyle/>
+          <a:p>
+            <a:pPr algn="ctr"/>
+            <a:r>
+              <a:rPr b="1" sz="1400">
+                <a:solidFill>
+                  <a:srgbClr val="0A0A0A"/>
+                </a:solidFill>
+              </a:rPr>
+              <a:t>Initial concentrations</a:t>
+            </a:r>
+          </a:p>
+          <a:p>
+            <a:pPr algn="ctr"/>
+            <a:r>
+              <a:rPr sz="1100">
+                <a:solidFill>
+                  <a:srgbClr val="6F6F6F"/>
+                </a:solidFill>
+              </a:rPr>
+              <a:t>what was in each reaction at t = 0</a:t>
+            </a:r>
+          </a:p>
+        </p:txBody>
+      </p:sp>
+      <p:cxnSp>
+        <p:nvCxnSpPr>
+          <p:cNvPr id="14" name="Connector 13"/>
+          <p:cNvCxnSpPr/>
+          <p:nvPr/>
+        </p:nvCxnSpPr>
+        <p:spPr>
+          <a:xfrm>
+            <a:off x="3566160" y="4549140"/>
+            <a:ext cx="228600" cy="0"/>
+          </a:xfrm>
+          <a:prstGeom prst="line">
+            <a:avLst/>
+          </a:prstGeom>
+          <a:ln w="15875">
+            <a:solidFill>
+              <a:srgbClr val="0A0A0A"/>
+            </a:solidFill>
+          </a:ln>
+        </p:spPr>
+        <p:style>
+          <a:lnRef idx="2">
+            <a:schemeClr val="accent1"/>
+          </a:lnRef>
+          <a:fillRef idx="0">
+            <a:schemeClr val="accent1"/>
+          </a:fillRef>
+          <a:effectRef idx="1">
+            <a:schemeClr val="accent1"/>
+          </a:effectRef>
+          <a:fontRef idx="minor">
+            <a:schemeClr val="tx1"/>
+          </a:fontRef>
+        </p:style>
+      </p:cxnSp>
+      <p:cxnSp>
+        <p:nvCxnSpPr>
+          <p:cNvPr id="15" name="Connector 14"/>
+          <p:cNvCxnSpPr/>
+          <p:nvPr/>
+        </p:nvCxnSpPr>
+        <p:spPr>
+          <a:xfrm>
+            <a:off x="3794760" y="2642616"/>
+            <a:ext cx="0" cy="1906524"/>
+          </a:xfrm>
+          <a:prstGeom prst="line">
+            <a:avLst/>
+          </a:prstGeom>
+          <a:ln w="15875">
+            <a:solidFill>
+              <a:srgbClr val="0A0A0A"/>
+            </a:solidFill>
+          </a:ln>
+        </p:spPr>
+        <p:style>
+          <a:lnRef idx="2">
+            <a:schemeClr val="accent1"/>
+          </a:lnRef>
+          <a:fillRef idx="0">
+            <a:schemeClr val="accent1"/>
+          </a:fillRef>
+          <a:effectRef idx="1">
+            <a:schemeClr val="accent1"/>
+          </a:effectRef>
+          <a:fontRef idx="minor">
+            <a:schemeClr val="tx1"/>
+          </a:fontRef>
+        </p:style>
+      </p:cxnSp>
+      <p:cxnSp>
+        <p:nvCxnSpPr>
+          <p:cNvPr id="16" name="Connector 15"/>
+          <p:cNvCxnSpPr/>
+          <p:nvPr/>
+        </p:nvCxnSpPr>
+        <p:spPr>
+          <a:xfrm>
+            <a:off x="3794760" y="2642616"/>
+            <a:ext cx="237744" cy="0"/>
+          </a:xfrm>
+          <a:prstGeom prst="line">
+            <a:avLst/>
+          </a:prstGeom>
+          <a:ln w="15875">
+            <a:solidFill>
+              <a:srgbClr val="0A0A0A"/>
+            </a:solidFill>
+            <a:tailEnd type="triangle" w="med" len="med"/>
+          </a:ln>
+        </p:spPr>
+        <p:style>
+          <a:lnRef idx="2">
+            <a:schemeClr val="accent1"/>
+          </a:lnRef>
+          <a:fillRef idx="0">
+            <a:schemeClr val="accent1"/>
+          </a:fillRef>
+          <a:effectRef idx="1">
+            <a:schemeClr val="accent1"/>
+          </a:effectRef>
+          <a:fontRef idx="minor">
+            <a:schemeClr val="tx1"/>
+          </a:fontRef>
+        </p:style>
+      </p:cxnSp>
+      <p:sp>
+        <p:nvSpPr>
+          <p:cNvPr id="17" name="Rounded Rectangle 16"/>
+          <p:cNvSpPr/>
+          <p:nvPr/>
+        </p:nvSpPr>
+        <p:spPr>
+          <a:xfrm>
+            <a:off x="4087368" y="2377440"/>
+            <a:ext cx="4023360" cy="530352"/>
+          </a:xfrm>
+          <a:prstGeom prst="roundRect">
+            <a:avLst>
+              <a:gd name="adj" fmla="val 12000"/>
+            </a:avLst>
+          </a:prstGeom>
+          <a:noFill/>
+          <a:ln w="12700">
+            <a:solidFill>
+              <a:srgbClr val="0A0A0A"/>
+            </a:solidFill>
+          </a:ln>
+          <a:effectLst/>
+        </p:spPr>
+        <p:style>
+          <a:lnRef idx="1">
+            <a:schemeClr val="accent1"/>
+          </a:lnRef>
+          <a:fillRef idx="3">
+            <a:schemeClr val="accent1"/>
+          </a:fillRef>
+          <a:effectRef idx="2">
+            <a:schemeClr val="accent1"/>
+          </a:effectRef>
+          <a:fontRef idx="minor">
+            <a:schemeClr val="lt1"/>
+          </a:fontRef>
+        </p:style>
+        <p:txBody>
+          <a:bodyPr rtlCol="0" anchor="ctr" wrap="square" lIns="73152" rIns="73152"/>
+          <a:lstStyle/>
+          <a:p>
+            <a:pPr algn="ctr"/>
+            <a:r>
+              <a:rPr b="1" sz="1400">
+                <a:solidFill>
+                  <a:srgbClr val="0A0A0A"/>
+                </a:solidFill>
+              </a:rPr>
+              <a:t>Read the exports</a:t>
+            </a:r>
+          </a:p>
+          <a:p>
+            <a:pPr algn="ctr"/>
+            <a:r>
+              <a:rPr sz="1100">
+                <a:solidFill>
+                  <a:srgbClr val="6F6F6F"/>
+                </a:solidFill>
+              </a:rPr>
+              <a:t>read_shimadzu, reaction or calibration mode</a:t>
+            </a:r>
+          </a:p>
+        </p:txBody>
+      </p:sp>
+      <p:sp>
+        <p:nvSpPr>
+          <p:cNvPr id="18" name="Rounded Rectangle 17"/>
+          <p:cNvSpPr/>
+          <p:nvPr/>
+        </p:nvSpPr>
+        <p:spPr>
+          <a:xfrm>
+            <a:off x="4087368" y="3054096"/>
+            <a:ext cx="4023360" cy="530352"/>
+          </a:xfrm>
+          <a:prstGeom prst="roundRect">
+            <a:avLst>
+              <a:gd name="adj" fmla="val 12000"/>
+            </a:avLst>
+          </a:prstGeom>
+          <a:noFill/>
+          <a:ln w="12700">
+            <a:solidFill>
+              <a:srgbClr val="0A0A0A"/>
+            </a:solidFill>
+          </a:ln>
+          <a:effectLst/>
+        </p:spPr>
+        <p:style>
+          <a:lnRef idx="1">
+            <a:schemeClr val="accent1"/>
+          </a:lnRef>
+          <a:fillRef idx="3">
+            <a:schemeClr val="accent1"/>
+          </a:fillRef>
+          <a:effectRef idx="2">
+            <a:schemeClr val="accent1"/>
+          </a:effectRef>
+          <a:fontRef idx="minor">
+            <a:schemeClr val="lt1"/>
+          </a:fontRef>
+        </p:style>
+        <p:txBody>
+          <a:bodyPr rtlCol="0" anchor="ctr" wrap="square" lIns="73152" rIns="73152"/>
+          <a:lstStyle/>
+          <a:p>
+            <a:pPr algn="ctr"/>
+            <a:r>
+              <a:rPr b="1" sz="1400">
+                <a:solidFill>
+                  <a:srgbClr val="0A0A0A"/>
+                </a:solidFill>
+              </a:rPr>
+              <a:t>Set the retention window</a:t>
+            </a:r>
+          </a:p>
+          <a:p>
+            <a:pPr algn="ctr"/>
+            <a:r>
+              <a:rPr sz="1100">
+                <a:solidFill>
+                  <a:srgbClr val="6F6F6F"/>
+                </a:solidFill>
+              </a:rPr>
+              <a:t>your decision, per measurement session</a:t>
+            </a:r>
+          </a:p>
+        </p:txBody>
+      </p:sp>
+      <p:sp>
+        <p:nvSpPr>
+          <p:cNvPr id="19" name="Rounded Rectangle 18"/>
+          <p:cNvSpPr/>
+          <p:nvPr/>
+        </p:nvSpPr>
+        <p:spPr>
+          <a:xfrm>
+            <a:off x="4087368" y="3730752"/>
+            <a:ext cx="4023360" cy="530352"/>
+          </a:xfrm>
+          <a:prstGeom prst="roundRect">
+            <a:avLst>
+              <a:gd name="adj" fmla="val 12000"/>
+            </a:avLst>
+          </a:prstGeom>
+          <a:noFill/>
+          <a:ln w="12700">
+            <a:solidFill>
+              <a:srgbClr val="0A0A0A"/>
+            </a:solidFill>
+          </a:ln>
+          <a:effectLst/>
+        </p:spPr>
+        <p:style>
+          <a:lnRef idx="1">
+            <a:schemeClr val="accent1"/>
+          </a:lnRef>
+          <a:fillRef idx="3">
+            <a:schemeClr val="accent1"/>
+          </a:fillRef>
+          <a:effectRef idx="2">
+            <a:schemeClr val="accent1"/>
+          </a:effectRef>
+          <a:fontRef idx="minor">
+            <a:schemeClr val="lt1"/>
+          </a:fontRef>
+        </p:style>
+        <p:txBody>
+          <a:bodyPr rtlCol="0" anchor="ctr" wrap="square" lIns="73152" rIns="73152"/>
+          <a:lstStyle/>
+          <a:p>
+            <a:pPr algn="ctr"/>
+            <a:r>
+              <a:rPr b="1" sz="1400">
+                <a:solidFill>
+                  <a:srgbClr val="0A0A0A"/>
+                </a:solidFill>
+              </a:rPr>
+              <a:t>Assign the peak</a:t>
+            </a:r>
+          </a:p>
+          <a:p>
+            <a:pPr algn="ctr"/>
+            <a:r>
+              <a:rPr sz="1100">
+                <a:solidFill>
+                  <a:srgbClr val="6F6F6F"/>
+                </a:solidFill>
+              </a:rPr>
+              <a:t>auto_assign: the peak inside the window</a:t>
+            </a:r>
+          </a:p>
+        </p:txBody>
+      </p:sp>
+      <p:sp>
+        <p:nvSpPr>
+          <p:cNvPr id="20" name="Rounded Rectangle 19"/>
+          <p:cNvSpPr/>
+          <p:nvPr/>
+        </p:nvSpPr>
+        <p:spPr>
+          <a:xfrm>
+            <a:off x="4087368" y="4407408"/>
+            <a:ext cx="4023360" cy="530352"/>
+          </a:xfrm>
+          <a:prstGeom prst="roundRect">
+            <a:avLst>
+              <a:gd name="adj" fmla="val 12000"/>
+            </a:avLst>
+          </a:prstGeom>
+          <a:noFill/>
+          <a:ln w="12700">
+            <a:solidFill>
+              <a:srgbClr val="0A0A0A"/>
+            </a:solidFill>
+          </a:ln>
+          <a:effectLst/>
+        </p:spPr>
+        <p:style>
+          <a:lnRef idx="1">
+            <a:schemeClr val="accent1"/>
+          </a:lnRef>
+          <a:fillRef idx="3">
+            <a:schemeClr val="accent1"/>
+          </a:fillRef>
+          <a:effectRef idx="2">
+            <a:schemeClr val="accent1"/>
+          </a:effectRef>
+          <a:fontRef idx="minor">
+            <a:schemeClr val="lt1"/>
+          </a:fontRef>
+        </p:style>
+        <p:txBody>
+          <a:bodyPr rtlCol="0" anchor="ctr" wrap="square" lIns="73152" rIns="73152"/>
+          <a:lstStyle/>
+          <a:p>
+            <a:pPr algn="ctr"/>
+            <a:r>
+              <a:rPr b="1" sz="1400">
+                <a:solidFill>
+                  <a:srgbClr val="0A0A0A"/>
+                </a:solidFill>
+              </a:rPr>
+              <a:t>Calibrate</a:t>
+            </a:r>
+          </a:p>
+          <a:p>
+            <a:pPr algn="ctr"/>
+            <a:r>
+              <a:rPr sz="1100">
+                <a:solidFill>
+                  <a:srgbClr val="6F6F6F"/>
+                </a:solidFill>
+              </a:rPr>
+              <a:t>add_standard, area against concentration; you accept R²</a:t>
+            </a:r>
+          </a:p>
+        </p:txBody>
+      </p:sp>
+      <p:sp>
+        <p:nvSpPr>
+          <p:cNvPr id="21" name="Rounded Rectangle 20"/>
+          <p:cNvSpPr/>
+          <p:nvPr/>
+        </p:nvSpPr>
+        <p:spPr>
+          <a:xfrm>
+            <a:off x="4087368" y="5084064"/>
+            <a:ext cx="4023360" cy="530352"/>
+          </a:xfrm>
+          <a:prstGeom prst="roundRect">
+            <a:avLst>
+              <a:gd name="adj" fmla="val 12000"/>
+            </a:avLst>
+          </a:prstGeom>
+          <a:noFill/>
+          <a:ln w="12700">
+            <a:solidFill>
+              <a:srgbClr val="0A0A0A"/>
+            </a:solidFill>
+          </a:ln>
+          <a:effectLst/>
+        </p:spPr>
+        <p:style>
+          <a:lnRef idx="1">
+            <a:schemeClr val="accent1"/>
+          </a:lnRef>
+          <a:fillRef idx="3">
+            <a:schemeClr val="accent1"/>
+          </a:fillRef>
+          <a:effectRef idx="2">
+            <a:schemeClr val="accent1"/>
+          </a:effectRef>
+          <a:fontRef idx="minor">
+            <a:schemeClr val="lt1"/>
+          </a:fontRef>
+        </p:style>
+        <p:txBody>
+          <a:bodyPr rtlCol="0" anchor="ctr" wrap="square" lIns="73152" rIns="73152"/>
+          <a:lstStyle/>
+          <a:p>
+            <a:pPr algn="ctr"/>
+            <a:r>
+              <a:rPr b="1" sz="1400">
+                <a:solidFill>
+                  <a:srgbClr val="0A0A0A"/>
+                </a:solidFill>
+              </a:rPr>
+              <a:t>Export</a:t>
+            </a:r>
+          </a:p>
+          <a:p>
+            <a:pPr algn="ctr"/>
+            <a:r>
+              <a:rPr sz="1100">
+                <a:solidFill>
+                  <a:srgbClr val="6F6F6F"/>
+                </a:solidFill>
+              </a:rPr>
+              <a:t>to_enzymeml: areas become concentrations</a:t>
+            </a:r>
+          </a:p>
+        </p:txBody>
+      </p:sp>
+      <p:cxnSp>
+        <p:nvCxnSpPr>
+          <p:cNvPr id="22" name="Connector 21"/>
+          <p:cNvCxnSpPr/>
+          <p:nvPr/>
+        </p:nvCxnSpPr>
+        <p:spPr>
+          <a:xfrm>
+            <a:off x="6099048" y="2926080"/>
+            <a:ext cx="0" cy="109728"/>
+          </a:xfrm>
+          <a:prstGeom prst="line">
+            <a:avLst/>
+          </a:prstGeom>
+          <a:ln w="15875">
+            <a:solidFill>
+              <a:srgbClr val="0A0A0A"/>
+            </a:solidFill>
+            <a:tailEnd type="triangle" w="med" len="med"/>
+          </a:ln>
+        </p:spPr>
+        <p:style>
+          <a:lnRef idx="2">
+            <a:schemeClr val="accent1"/>
+          </a:lnRef>
+          <a:fillRef idx="0">
+            <a:schemeClr val="accent1"/>
+          </a:fillRef>
+          <a:effectRef idx="1">
+            <a:schemeClr val="accent1"/>
+          </a:effectRef>
+          <a:fontRef idx="minor">
+            <a:schemeClr val="tx1"/>
+          </a:fontRef>
+        </p:style>
+      </p:cxnSp>
+      <p:cxnSp>
+        <p:nvCxnSpPr>
+          <p:cNvPr id="23" name="Connector 22"/>
+          <p:cNvCxnSpPr/>
+          <p:nvPr/>
+        </p:nvCxnSpPr>
+        <p:spPr>
+          <a:xfrm>
+            <a:off x="6099048" y="3602736"/>
+            <a:ext cx="0" cy="109728"/>
+          </a:xfrm>
+          <a:prstGeom prst="line">
+            <a:avLst/>
+          </a:prstGeom>
+          <a:ln w="15875">
+            <a:solidFill>
+              <a:srgbClr val="0A0A0A"/>
+            </a:solidFill>
+            <a:tailEnd type="triangle" w="med" len="med"/>
+          </a:ln>
+        </p:spPr>
+        <p:style>
+          <a:lnRef idx="2">
+            <a:schemeClr val="accent1"/>
+          </a:lnRef>
+          <a:fillRef idx="0">
+            <a:schemeClr val="accent1"/>
+          </a:fillRef>
+          <a:effectRef idx="1">
+            <a:schemeClr val="accent1"/>
+          </a:effectRef>
+          <a:fontRef idx="minor">
+            <a:schemeClr val="tx1"/>
+          </a:fontRef>
+        </p:style>
+      </p:cxnSp>
+      <p:cxnSp>
+        <p:nvCxnSpPr>
+          <p:cNvPr id="24" name="Connector 23"/>
+          <p:cNvCxnSpPr/>
+          <p:nvPr/>
+        </p:nvCxnSpPr>
+        <p:spPr>
+          <a:xfrm>
+            <a:off x="6099048" y="4279392"/>
+            <a:ext cx="0" cy="109728"/>
+          </a:xfrm>
+          <a:prstGeom prst="line">
+            <a:avLst/>
+          </a:prstGeom>
+          <a:ln w="15875">
+            <a:solidFill>
+              <a:srgbClr val="0A0A0A"/>
+            </a:solidFill>
+            <a:tailEnd type="triangle" w="med" len="med"/>
+          </a:ln>
+        </p:spPr>
+        <p:style>
+          <a:lnRef idx="2">
+            <a:schemeClr val="accent1"/>
+          </a:lnRef>
+          <a:fillRef idx="0">
+            <a:schemeClr val="accent1"/>
+          </a:fillRef>
+          <a:effectRef idx="1">
+            <a:schemeClr val="accent1"/>
+          </a:effectRef>
+          <a:fontRef idx="minor">
+            <a:schemeClr val="tx1"/>
+          </a:fontRef>
+        </p:style>
+      </p:cxnSp>
+      <p:cxnSp>
+        <p:nvCxnSpPr>
+          <p:cNvPr id="25" name="Connector 24"/>
+          <p:cNvCxnSpPr/>
+          <p:nvPr/>
+        </p:nvCxnSpPr>
+        <p:spPr>
+          <a:xfrm>
+            <a:off x="6099048" y="4956048"/>
+            <a:ext cx="0" cy="109728"/>
+          </a:xfrm>
+          <a:prstGeom prst="line">
+            <a:avLst/>
+          </a:prstGeom>
+          <a:ln w="15875">
+            <a:solidFill>
+              <a:srgbClr val="0A0A0A"/>
+            </a:solidFill>
+            <a:tailEnd type="triangle" w="med" len="med"/>
+          </a:ln>
+        </p:spPr>
+        <p:style>
+          <a:lnRef idx="2">
+            <a:schemeClr val="accent1"/>
+          </a:lnRef>
+          <a:fillRef idx="0">
+            <a:schemeClr val="accent1"/>
+          </a:fillRef>
+          <a:effectRef idx="1">
+            <a:schemeClr val="accent1"/>
+          </a:effectRef>
+          <a:fontRef idx="minor">
+            <a:schemeClr val="tx1"/>
+          </a:fontRef>
+        </p:style>
+      </p:cxnSp>
+      <p:cxnSp>
+        <p:nvCxnSpPr>
+          <p:cNvPr id="26" name="Connector 25"/>
+          <p:cNvCxnSpPr/>
+          <p:nvPr/>
+        </p:nvCxnSpPr>
+        <p:spPr>
+          <a:xfrm>
+            <a:off x="8110728" y="5349240"/>
+            <a:ext cx="283464" cy="0"/>
+          </a:xfrm>
+          <a:prstGeom prst="line">
+            <a:avLst/>
+          </a:prstGeom>
+          <a:ln w="15875">
+            <a:solidFill>
+              <a:srgbClr val="0A0A0A"/>
+            </a:solidFill>
+          </a:ln>
+        </p:spPr>
+        <p:style>
+          <a:lnRef idx="2">
+            <a:schemeClr val="accent1"/>
+          </a:lnRef>
+          <a:fillRef idx="0">
+            <a:schemeClr val="accent1"/>
+          </a:fillRef>
+          <a:effectRef idx="1">
+            <a:schemeClr val="accent1"/>
+          </a:effectRef>
+          <a:fontRef idx="minor">
+            <a:schemeClr val="tx1"/>
+          </a:fontRef>
+        </p:style>
+      </p:cxnSp>
+      <p:cxnSp>
+        <p:nvCxnSpPr>
+          <p:cNvPr id="27" name="Connector 26"/>
+          <p:cNvCxnSpPr/>
+          <p:nvPr/>
+        </p:nvCxnSpPr>
+        <p:spPr>
+          <a:xfrm>
+            <a:off x="8394192" y="2720340"/>
+            <a:ext cx="0" cy="2628900"/>
+          </a:xfrm>
+          <a:prstGeom prst="line">
+            <a:avLst/>
+          </a:prstGeom>
+          <a:ln w="15875">
+            <a:solidFill>
+              <a:srgbClr val="0A0A0A"/>
+            </a:solidFill>
+          </a:ln>
+        </p:spPr>
+        <p:style>
+          <a:lnRef idx="2">
+            <a:schemeClr val="accent1"/>
+          </a:lnRef>
+          <a:fillRef idx="0">
+            <a:schemeClr val="accent1"/>
+          </a:fillRef>
+          <a:effectRef idx="1">
+            <a:schemeClr val="accent1"/>
+          </a:effectRef>
+          <a:fontRef idx="minor">
+            <a:schemeClr val="tx1"/>
+          </a:fontRef>
+        </p:style>
+      </p:cxnSp>
+      <p:sp>
+        <p:nvSpPr>
+          <p:cNvPr id="28" name="Rounded Rectangle 27"/>
+          <p:cNvSpPr/>
+          <p:nvPr/>
+        </p:nvSpPr>
+        <p:spPr>
+          <a:xfrm>
+            <a:off x="8622792" y="2377440"/>
+            <a:ext cx="2743200" cy="685800"/>
+          </a:xfrm>
+          <a:prstGeom prst="roundRect">
+            <a:avLst>
+              <a:gd name="adj" fmla="val 12000"/>
+            </a:avLst>
+          </a:prstGeom>
+          <a:noFill/>
+          <a:ln w="12700">
+            <a:solidFill>
+              <a:srgbClr val="0A0A0A"/>
+            </a:solidFill>
+          </a:ln>
+          <a:effectLst/>
+        </p:spPr>
+        <p:style>
+          <a:lnRef idx="1">
+            <a:schemeClr val="accent1"/>
+          </a:lnRef>
+          <a:fillRef idx="3">
+            <a:schemeClr val="accent1"/>
+          </a:fillRef>
+          <a:effectRef idx="2">
+            <a:schemeClr val="accent1"/>
+          </a:effectRef>
+          <a:fontRef idx="minor">
+            <a:schemeClr val="lt1"/>
+          </a:fontRef>
+        </p:style>
+        <p:txBody>
+          <a:bodyPr rtlCol="0" anchor="ctr" wrap="square" lIns="73152" rIns="73152"/>
+          <a:lstStyle/>
+          <a:p>
+            <a:pPr algn="ctr"/>
+            <a:r>
+              <a:rPr b="1" sz="1400">
+                <a:solidFill>
+                  <a:srgbClr val="0A0A0A"/>
+                </a:solidFill>
+              </a:rPr>
+              <a:t>EnzymeML document</a:t>
+            </a:r>
+          </a:p>
+          <a:p>
+            <a:pPr algn="ctr"/>
+            <a:r>
+              <a:rPr sz="1100">
+                <a:solidFill>
+                  <a:srgbClr val="6F6F6F"/>
+                </a:solidFill>
+              </a:rPr>
+              <a:t>time courses with their initial conditions</a:t>
+            </a:r>
+          </a:p>
+        </p:txBody>
+      </p:sp>
+      <p:cxnSp>
+        <p:nvCxnSpPr>
+          <p:cNvPr id="29" name="Connector 28"/>
+          <p:cNvCxnSpPr/>
+          <p:nvPr/>
+        </p:nvCxnSpPr>
+        <p:spPr>
+          <a:xfrm>
+            <a:off x="8394192" y="2720340"/>
+            <a:ext cx="173736" cy="0"/>
+          </a:xfrm>
+          <a:prstGeom prst="line">
+            <a:avLst/>
+          </a:prstGeom>
+          <a:ln w="15875">
+            <a:solidFill>
+              <a:srgbClr val="0A0A0A"/>
+            </a:solidFill>
+            <a:tailEnd type="triangle" w="med" len="med"/>
+          </a:ln>
+        </p:spPr>
+        <p:style>
+          <a:lnRef idx="2">
+            <a:schemeClr val="accent1"/>
+          </a:lnRef>
+          <a:fillRef idx="0">
+            <a:schemeClr val="accent1"/>
+          </a:fillRef>
+          <a:effectRef idx="1">
+            <a:schemeClr val="accent1"/>
+          </a:effectRef>
+          <a:fontRef idx="minor">
+            <a:schemeClr val="tx1"/>
+          </a:fontRef>
+        </p:style>
+      </p:cxnSp>
+      <p:sp>
+        <p:nvSpPr>
+          <p:cNvPr id="30" name="Rounded Rectangle 29"/>
+          <p:cNvSpPr/>
+          <p:nvPr/>
+        </p:nvSpPr>
+        <p:spPr>
+          <a:xfrm>
+            <a:off x="8622792" y="3291840"/>
+            <a:ext cx="2743200" cy="685800"/>
+          </a:xfrm>
+          <a:prstGeom prst="roundRect">
+            <a:avLst>
+              <a:gd name="adj" fmla="val 12000"/>
+            </a:avLst>
+          </a:prstGeom>
+          <a:noFill/>
+          <a:ln w="12700">
+            <a:solidFill>
+              <a:srgbClr val="0A0A0A"/>
+            </a:solidFill>
+          </a:ln>
+          <a:effectLst/>
+        </p:spPr>
+        <p:style>
+          <a:lnRef idx="1">
+            <a:schemeClr val="accent1"/>
+          </a:lnRef>
+          <a:fillRef idx="3">
+            <a:schemeClr val="accent1"/>
+          </a:fillRef>
+          <a:effectRef idx="2">
+            <a:schemeClr val="accent1"/>
+          </a:effectRef>
+          <a:fontRef idx="minor">
+            <a:schemeClr val="lt1"/>
+          </a:fontRef>
+        </p:style>
+        <p:txBody>
+          <a:bodyPr rtlCol="0" anchor="ctr" wrap="square" lIns="73152" rIns="73152"/>
+          <a:lstStyle/>
+          <a:p>
+            <a:pPr algn="ctr"/>
+            <a:r>
+              <a:rPr b="1" sz="1400">
+                <a:solidFill>
+                  <a:srgbClr val="0A0A0A"/>
+                </a:solidFill>
+              </a:rPr>
+              <a:t>Checks</a:t>
+            </a:r>
+          </a:p>
+          <a:p>
+            <a:pPr algn="ctr"/>
+            <a:r>
+              <a:rPr sz="1100">
+                <a:solidFill>
+                  <a:srgbClr val="6F6F6F"/>
+                </a:solidFill>
+              </a:rPr>
+              <a:t>one peak per chromatogram, R², values per reaction</a:t>
+            </a:r>
+          </a:p>
+        </p:txBody>
+      </p:sp>
+      <p:cxnSp>
+        <p:nvCxnSpPr>
+          <p:cNvPr id="31" name="Connector 30"/>
+          <p:cNvCxnSpPr/>
+          <p:nvPr/>
+        </p:nvCxnSpPr>
+        <p:spPr>
+          <a:xfrm>
+            <a:off x="8394192" y="3634740"/>
+            <a:ext cx="173736" cy="0"/>
+          </a:xfrm>
+          <a:prstGeom prst="line">
+            <a:avLst/>
+          </a:prstGeom>
+          <a:ln w="15875">
+            <a:solidFill>
+              <a:srgbClr val="0A0A0A"/>
+            </a:solidFill>
+            <a:tailEnd type="triangle" w="med" len="med"/>
+          </a:ln>
+        </p:spPr>
+        <p:style>
+          <a:lnRef idx="2">
+            <a:schemeClr val="accent1"/>
+          </a:lnRef>
+          <a:fillRef idx="0">
+            <a:schemeClr val="accent1"/>
+          </a:fillRef>
+          <a:effectRef idx="1">
+            <a:schemeClr val="accent1"/>
+          </a:effectRef>
+          <a:fontRef idx="minor">
+            <a:schemeClr val="tx1"/>
+          </a:fontRef>
+        </p:style>
+      </p:cxnSp>
+    </p:spTree>
+  </p:cSld>
+  <p:clrMapOvr>
+    <a:masterClrMapping/>
+  </p:clrMapOvr>
+</p:sld>
+</file>
+
+<file path=ppt/slides/slide7.xml><?xml version="1.0" encoding="utf-8"?>
+<p:sld xmlns:a="http://schemas.openxmlformats.org/drawingml/2006/main" xmlns:p="http://schemas.openxmlformats.org/presentationml/2006/main" xmlns:r="http://schemas.openxmlformats.org/officeDocument/2006/relationships">
+  <p:cSld>
+    <p:spTree>
+      <p:nvGrpSpPr>
+        <p:cNvPr id="1" name=""/>
+        <p:cNvGrpSpPr/>
+        <p:nvPr/>
+      </p:nvGrpSpPr>
+      <p:grpSpPr/>
+      <p:sp>
+        <p:nvSpPr>
+          <p:cNvPr id="2" name="Title 1"/>
+          <p:cNvSpPr>
+            <a:spLocks noGrp="1"/>
+          </p:cNvSpPr>
+          <p:nvPr>
+            <p:ph type="title"/>
+          </p:nvPr>
+        </p:nvSpPr>
+        <p:spPr/>
+        <p:txBody>
+          <a:bodyPr/>
+          <a:lstStyle/>
+          <a:p>
+            <a:r>
+              <a:rPr/>
+              <a:t>Catalax: from time courses to kinetic parameters</a:t>
+            </a:r>
+          </a:p>
+        </p:txBody>
+      </p:sp>
+      <p:sp>
+        <p:nvSpPr>
+          <p:cNvPr id="3" name="Text Placeholder 2"/>
+          <p:cNvSpPr>
+            <a:spLocks noGrp="1"/>
+          </p:cNvSpPr>
+          <p:nvPr>
+            <p:ph type="body" idx="13" sz="quarter"/>
+          </p:nvPr>
+        </p:nvSpPr>
+        <p:spPr/>
+        <p:txBody>
+          <a:bodyPr/>
+          <a:lstStyle/>
+          <a:p>
+            <a:r>
+              <a:rPr/>
+              <a:t>Tool 2 · Catalax</a:t>
+            </a:r>
+          </a:p>
+        </p:txBody>
+      </p:sp>
+      <p:sp>
+        <p:nvSpPr>
+          <p:cNvPr id="4" name="Text Placeholder 3"/>
+          <p:cNvSpPr>
+            <a:spLocks noGrp="1"/>
+          </p:cNvSpPr>
+          <p:nvPr>
+            <p:ph type="body" idx="15" sz="quarter"/>
+          </p:nvPr>
+        </p:nvSpPr>
+        <p:spPr/>
+        <p:txBody>
+          <a:bodyPr/>
+          <a:lstStyle/>
+          <a:p>
+            <a:r>
+              <a:rPr/>
+              <a:t>Builds the ODE model from a rate law and samples the posterior of its parameters</a:t>
+            </a:r>
+          </a:p>
+        </p:txBody>
+      </p:sp>
+      <p:sp>
+        <p:nvSpPr>
+          <p:cNvPr id="6" name="TextBox 5"/>
+          <p:cNvSpPr txBox="1"/>
+          <p:nvPr/>
+        </p:nvSpPr>
+        <p:spPr>
+          <a:xfrm>
+            <a:off x="822960" y="2057400"/>
+            <a:ext cx="2743200" cy="274320"/>
+          </a:xfrm>
+          <a:prstGeom prst="rect">
+            <a:avLst/>
+          </a:prstGeom>
+          <a:noFill/>
+        </p:spPr>
+        <p:txBody>
+          <a:bodyPr wrap="square" lIns="0" rIns="0" tIns="0" bIns="0">
+            <a:spAutoFit/>
+          </a:bodyPr>
+          <a:lstStyle/>
+          <a:p>
+            <a:pPr algn="ctr"/>
+            <a:r>
+              <a:rPr sz="1200">
+                <a:solidFill>
+                  <a:srgbClr val="6F6F6F"/>
+                </a:solidFill>
+              </a:rPr>
+              <a:t>Input</a:t>
+            </a:r>
+          </a:p>
+        </p:txBody>
+      </p:sp>
+      <p:sp>
+        <p:nvSpPr>
+          <p:cNvPr id="7" name="TextBox 6"/>
+          <p:cNvSpPr txBox="1"/>
+          <p:nvPr/>
+        </p:nvSpPr>
+        <p:spPr>
+          <a:xfrm>
+            <a:off x="4087368" y="2057400"/>
+            <a:ext cx="4023360" cy="274320"/>
+          </a:xfrm>
+          <a:prstGeom prst="rect">
+            <a:avLst/>
+          </a:prstGeom>
+          <a:noFill/>
+        </p:spPr>
+        <p:txBody>
+          <a:bodyPr wrap="square" lIns="0" rIns="0" tIns="0" bIns="0">
+            <a:spAutoFit/>
+          </a:bodyPr>
+          <a:lstStyle/>
+          <a:p>
+            <a:pPr algn="ctr"/>
+            <a:r>
+              <a:rPr sz="1200">
+                <a:solidFill>
+                  <a:srgbClr val="6F6F6F"/>
+                </a:solidFill>
+              </a:rPr>
+              <a:t>Steps</a:t>
+            </a:r>
+          </a:p>
+        </p:txBody>
+      </p:sp>
+      <p:sp>
+        <p:nvSpPr>
+          <p:cNvPr id="8" name="TextBox 7"/>
+          <p:cNvSpPr txBox="1"/>
+          <p:nvPr/>
+        </p:nvSpPr>
+        <p:spPr>
+          <a:xfrm>
+            <a:off x="8622792" y="2057400"/>
+            <a:ext cx="2743200" cy="274320"/>
+          </a:xfrm>
+          <a:prstGeom prst="rect">
+            <a:avLst/>
+          </a:prstGeom>
+          <a:noFill/>
+        </p:spPr>
+        <p:txBody>
+          <a:bodyPr wrap="square" lIns="0" rIns="0" tIns="0" bIns="0">
+            <a:spAutoFit/>
+          </a:bodyPr>
+          <a:lstStyle/>
+          <a:p>
+            <a:pPr algn="ctr"/>
+            <a:r>
+              <a:rPr sz="1200">
+                <a:solidFill>
+                  <a:srgbClr val="6F6F6F"/>
+                </a:solidFill>
+              </a:rPr>
+              <a:t>Output</a:t>
+            </a:r>
+          </a:p>
+        </p:txBody>
+      </p:sp>
+      <p:sp>
+        <p:nvSpPr>
+          <p:cNvPr id="9" name="Rounded Rectangle 8"/>
+          <p:cNvSpPr/>
+          <p:nvPr/>
+        </p:nvSpPr>
+        <p:spPr>
+          <a:xfrm>
+            <a:off x="822960" y="2377440"/>
+            <a:ext cx="2743200" cy="685800"/>
+          </a:xfrm>
+          <a:prstGeom prst="roundRect">
+            <a:avLst>
+              <a:gd name="adj" fmla="val 12000"/>
+            </a:avLst>
+          </a:prstGeom>
+          <a:noFill/>
+          <a:ln w="12700">
+            <a:solidFill>
+              <a:srgbClr val="0A0A0A"/>
+            </a:solidFill>
+          </a:ln>
+          <a:effectLst/>
+        </p:spPr>
+        <p:style>
+          <a:lnRef idx="1">
+            <a:schemeClr val="accent1"/>
+          </a:lnRef>
+          <a:fillRef idx="3">
+            <a:schemeClr val="accent1"/>
+          </a:fillRef>
+          <a:effectRef idx="2">
+            <a:schemeClr val="accent1"/>
+          </a:effectRef>
+          <a:fontRef idx="minor">
+            <a:schemeClr val="lt1"/>
+          </a:fontRef>
+        </p:style>
+        <p:txBody>
+          <a:bodyPr rtlCol="0" anchor="ctr" wrap="square" lIns="73152" rIns="73152"/>
+          <a:lstStyle/>
+          <a:p>
+            <a:pPr algn="ctr"/>
+            <a:r>
+              <a:rPr b="1" sz="1400">
+                <a:solidFill>
+                  <a:srgbClr val="0A0A0A"/>
+                </a:solidFill>
+              </a:rPr>
+              <a:t>EnzymeML document</a:t>
+            </a:r>
+          </a:p>
+          <a:p>
+            <a:pPr algn="ctr"/>
+            <a:r>
+              <a:rPr sz="1100">
+                <a:solidFill>
+                  <a:srgbClr val="6F6F6F"/>
+                </a:solidFill>
+              </a:rPr>
+              <a:t>time courses and initial conditions</a:t>
+            </a:r>
+          </a:p>
+        </p:txBody>
+      </p:sp>
+      <p:cxnSp>
+        <p:nvCxnSpPr>
+          <p:cNvPr id="10" name="Connector 9"/>
+          <p:cNvCxnSpPr/>
+          <p:nvPr/>
+        </p:nvCxnSpPr>
+        <p:spPr>
+          <a:xfrm>
+            <a:off x="3566160" y="2720340"/>
+            <a:ext cx="228600" cy="0"/>
+          </a:xfrm>
+          <a:prstGeom prst="line">
+            <a:avLst/>
+          </a:prstGeom>
+          <a:ln w="15875">
+            <a:solidFill>
+              <a:srgbClr val="0A0A0A"/>
+            </a:solidFill>
+          </a:ln>
+        </p:spPr>
+        <p:style>
+          <a:lnRef idx="2">
+            <a:schemeClr val="accent1"/>
+          </a:lnRef>
+          <a:fillRef idx="0">
+            <a:schemeClr val="accent1"/>
+          </a:fillRef>
+          <a:effectRef idx="1">
+            <a:schemeClr val="accent1"/>
+          </a:effectRef>
+          <a:fontRef idx="minor">
+            <a:schemeClr val="tx1"/>
+          </a:fontRef>
+        </p:style>
+      </p:cxnSp>
+      <p:sp>
+        <p:nvSpPr>
+          <p:cNvPr id="11" name="Rounded Rectangle 10"/>
+          <p:cNvSpPr/>
+          <p:nvPr/>
+        </p:nvSpPr>
+        <p:spPr>
+          <a:xfrm>
+            <a:off x="822960" y="3291840"/>
+            <a:ext cx="2743200" cy="685800"/>
+          </a:xfrm>
+          <a:prstGeom prst="roundRect">
+            <a:avLst>
+              <a:gd name="adj" fmla="val 12000"/>
+            </a:avLst>
+          </a:prstGeom>
+          <a:noFill/>
+          <a:ln w="12700">
+            <a:solidFill>
+              <a:srgbClr val="0A0A0A"/>
+            </a:solidFill>
+          </a:ln>
+          <a:effectLst/>
+        </p:spPr>
+        <p:style>
+          <a:lnRef idx="1">
+            <a:schemeClr val="accent1"/>
+          </a:lnRef>
+          <a:fillRef idx="3">
+            <a:schemeClr val="accent1"/>
+          </a:fillRef>
+          <a:effectRef idx="2">
+            <a:schemeClr val="accent1"/>
+          </a:effectRef>
+          <a:fontRef idx="minor">
+            <a:schemeClr val="lt1"/>
+          </a:fontRef>
+        </p:style>
+        <p:txBody>
+          <a:bodyPr rtlCol="0" anchor="ctr" wrap="square" lIns="73152" rIns="73152"/>
+          <a:lstStyle/>
+          <a:p>
+            <a:pPr algn="ctr"/>
+            <a:r>
+              <a:rPr b="1" sz="1400">
+                <a:solidFill>
+                  <a:srgbClr val="0A0A0A"/>
+                </a:solidFill>
+              </a:rPr>
+              <a:t>Rate law</a:t>
+            </a:r>
+          </a:p>
+          <a:p>
+            <a:pPr algn="ctr"/>
+            <a:r>
+              <a:rPr sz="1100">
+                <a:solidFill>
+                  <a:srgbClr val="6F6F6F"/>
+                </a:solidFill>
+              </a:rPr>
+              <a:t>one equation; states and ODEs follow from it</a:t>
+            </a:r>
+          </a:p>
+        </p:txBody>
+      </p:sp>
+      <p:cxnSp>
+        <p:nvCxnSpPr>
+          <p:cNvPr id="12" name="Connector 11"/>
+          <p:cNvCxnSpPr/>
+          <p:nvPr/>
+        </p:nvCxnSpPr>
+        <p:spPr>
+          <a:xfrm>
+            <a:off x="3566160" y="3634740"/>
+            <a:ext cx="228600" cy="0"/>
+          </a:xfrm>
+          <a:prstGeom prst="line">
+            <a:avLst/>
+          </a:prstGeom>
+          <a:ln w="15875">
+            <a:solidFill>
+              <a:srgbClr val="0A0A0A"/>
+            </a:solidFill>
+          </a:ln>
+        </p:spPr>
+        <p:style>
+          <a:lnRef idx="2">
+            <a:schemeClr val="accent1"/>
+          </a:lnRef>
+          <a:fillRef idx="0">
+            <a:schemeClr val="accent1"/>
+          </a:fillRef>
+          <a:effectRef idx="1">
+            <a:schemeClr val="accent1"/>
+          </a:effectRef>
+          <a:fontRef idx="minor">
+            <a:schemeClr val="tx1"/>
+          </a:fontRef>
+        </p:style>
+      </p:cxnSp>
+      <p:sp>
+        <p:nvSpPr>
+          <p:cNvPr id="13" name="Rounded Rectangle 12"/>
+          <p:cNvSpPr/>
+          <p:nvPr/>
+        </p:nvSpPr>
+        <p:spPr>
+          <a:xfrm>
+            <a:off x="822960" y="4206240"/>
+            <a:ext cx="2743200" cy="685800"/>
+          </a:xfrm>
+          <a:prstGeom prst="roundRect">
+            <a:avLst>
+              <a:gd name="adj" fmla="val 12000"/>
+            </a:avLst>
+          </a:prstGeom>
+          <a:noFill/>
+          <a:ln w="12700">
+            <a:solidFill>
+              <a:srgbClr val="0A0A0A"/>
+            </a:solidFill>
+          </a:ln>
+          <a:effectLst/>
+        </p:spPr>
+        <p:style>
+          <a:lnRef idx="1">
+            <a:schemeClr val="accent1"/>
+          </a:lnRef>
+          <a:fillRef idx="3">
+            <a:schemeClr val="accent1"/>
+          </a:fillRef>
+          <a:effectRef idx="2">
+            <a:schemeClr val="accent1"/>
+          </a:effectRef>
+          <a:fontRef idx="minor">
+            <a:schemeClr val="lt1"/>
+          </a:fontRef>
+        </p:style>
+        <p:txBody>
+          <a:bodyPr rtlCol="0" anchor="ctr" wrap="square" lIns="73152" rIns="73152"/>
+          <a:lstStyle/>
+          <a:p>
+            <a:pPr algn="ctr"/>
+            <a:r>
+              <a:rPr b="1" sz="1400">
+                <a:solidFill>
+                  <a:srgbClr val="0A0A0A"/>
+                </a:solidFill>
+              </a:rPr>
+              <a:t>Priors and noise</a:t>
+            </a:r>
+          </a:p>
+          <a:p>
+            <a:pPr algn="ctr"/>
+            <a:r>
+              <a:rPr sz="1100">
+                <a:solidFill>
+                  <a:srgbClr val="6F6F6F"/>
+                </a:solidFill>
+              </a:rPr>
+              <a:t>what you assume before seeing the data</a:t>
+            </a:r>
+          </a:p>
+        </p:txBody>
+      </p:sp>
+      <p:cxnSp>
+        <p:nvCxnSpPr>
+          <p:cNvPr id="14" name="Connector 13"/>
+          <p:cNvCxnSpPr/>
+          <p:nvPr/>
+        </p:nvCxnSpPr>
+        <p:spPr>
+          <a:xfrm>
+            <a:off x="3566160" y="4549140"/>
+            <a:ext cx="228600" cy="0"/>
+          </a:xfrm>
+          <a:prstGeom prst="line">
+            <a:avLst/>
+          </a:prstGeom>
+          <a:ln w="15875">
+            <a:solidFill>
+              <a:srgbClr val="0A0A0A"/>
+            </a:solidFill>
+          </a:ln>
+        </p:spPr>
+        <p:style>
+          <a:lnRef idx="2">
+            <a:schemeClr val="accent1"/>
+          </a:lnRef>
+          <a:fillRef idx="0">
+            <a:schemeClr val="accent1"/>
+          </a:fillRef>
+          <a:effectRef idx="1">
+            <a:schemeClr val="accent1"/>
+          </a:effectRef>
+          <a:fontRef idx="minor">
+            <a:schemeClr val="tx1"/>
+          </a:fontRef>
+        </p:style>
+      </p:cxnSp>
+      <p:cxnSp>
+        <p:nvCxnSpPr>
+          <p:cNvPr id="15" name="Connector 14"/>
+          <p:cNvCxnSpPr/>
+          <p:nvPr/>
+        </p:nvCxnSpPr>
+        <p:spPr>
+          <a:xfrm>
+            <a:off x="3794760" y="2642616"/>
+            <a:ext cx="0" cy="1906524"/>
+          </a:xfrm>
+          <a:prstGeom prst="line">
+            <a:avLst/>
+          </a:prstGeom>
+          <a:ln w="15875">
+            <a:solidFill>
+              <a:srgbClr val="0A0A0A"/>
+            </a:solidFill>
+          </a:ln>
+        </p:spPr>
+        <p:style>
+          <a:lnRef idx="2">
+            <a:schemeClr val="accent1"/>
+          </a:lnRef>
+          <a:fillRef idx="0">
+            <a:schemeClr val="accent1"/>
+          </a:fillRef>
+          <a:effectRef idx="1">
+            <a:schemeClr val="accent1"/>
+          </a:effectRef>
+          <a:fontRef idx="minor">
+            <a:schemeClr val="tx1"/>
+          </a:fontRef>
+        </p:style>
+      </p:cxnSp>
+      <p:cxnSp>
+        <p:nvCxnSpPr>
+          <p:cNvPr id="16" name="Connector 15"/>
+          <p:cNvCxnSpPr/>
+          <p:nvPr/>
+        </p:nvCxnSpPr>
+        <p:spPr>
+          <a:xfrm>
+            <a:off x="3794760" y="2642616"/>
+            <a:ext cx="237744" cy="0"/>
+          </a:xfrm>
+          <a:prstGeom prst="line">
+            <a:avLst/>
+          </a:prstGeom>
+          <a:ln w="15875">
+            <a:solidFill>
+              <a:srgbClr val="0A0A0A"/>
+            </a:solidFill>
+            <a:tailEnd type="triangle" w="med" len="med"/>
+          </a:ln>
+        </p:spPr>
+        <p:style>
+          <a:lnRef idx="2">
+            <a:schemeClr val="accent1"/>
+          </a:lnRef>
+          <a:fillRef idx="0">
+            <a:schemeClr val="accent1"/>
+          </a:fillRef>
+          <a:effectRef idx="1">
+            <a:schemeClr val="accent1"/>
+          </a:effectRef>
+          <a:fontRef idx="minor">
+            <a:schemeClr val="tx1"/>
+          </a:fontRef>
+        </p:style>
+      </p:cxnSp>
+      <p:sp>
+        <p:nvSpPr>
+          <p:cNvPr id="17" name="Rounded Rectangle 16"/>
+          <p:cNvSpPr/>
+          <p:nvPr/>
+        </p:nvSpPr>
+        <p:spPr>
+          <a:xfrm>
+            <a:off x="4087368" y="2377440"/>
+            <a:ext cx="4023360" cy="530352"/>
+          </a:xfrm>
+          <a:prstGeom prst="roundRect">
+            <a:avLst>
+              <a:gd name="adj" fmla="val 12000"/>
+            </a:avLst>
+          </a:prstGeom>
+          <a:noFill/>
+          <a:ln w="12700">
+            <a:solidFill>
+              <a:srgbClr val="0A0A0A"/>
+            </a:solidFill>
+          </a:ln>
+          <a:effectLst/>
+        </p:spPr>
+        <p:style>
+          <a:lnRef idx="1">
+            <a:schemeClr val="accent1"/>
+          </a:lnRef>
+          <a:fillRef idx="3">
+            <a:schemeClr val="accent1"/>
+          </a:fillRef>
+          <a:effectRef idx="2">
+            <a:schemeClr val="accent1"/>
+          </a:effectRef>
+          <a:fontRef idx="minor">
+            <a:schemeClr val="lt1"/>
+          </a:fontRef>
+        </p:style>
+        <p:txBody>
+          <a:bodyPr rtlCol="0" anchor="ctr" wrap="square" lIns="73152" rIns="73152"/>
+          <a:lstStyle/>
+          <a:p>
+            <a:pPr algn="ctr"/>
+            <a:r>
+              <a:rPr b="1" sz="1400">
+                <a:solidFill>
+                  <a:srgbClr val="0A0A0A"/>
+                </a:solidFill>
+              </a:rPr>
+              <a:t>Load the dataset</a:t>
+            </a:r>
+          </a:p>
+          <a:p>
+            <a:pPr algn="ctr"/>
+            <a:r>
+              <a:rPr sz="1100">
+                <a:solidFill>
+                  <a:srgbClr val="6F6F6F"/>
+                </a:solidFill>
+              </a:rPr>
+              <a:t>Dataset.from_enzymeml</a:t>
+            </a:r>
+          </a:p>
+        </p:txBody>
+      </p:sp>
+      <p:sp>
+        <p:nvSpPr>
+          <p:cNvPr id="18" name="Rounded Rectangle 17"/>
+          <p:cNvSpPr/>
+          <p:nvPr/>
+        </p:nvSpPr>
+        <p:spPr>
+          <a:xfrm>
+            <a:off x="4087368" y="3054096"/>
+            <a:ext cx="4023360" cy="530352"/>
+          </a:xfrm>
+          <a:prstGeom prst="roundRect">
+            <a:avLst>
+              <a:gd name="adj" fmla="val 12000"/>
+            </a:avLst>
+          </a:prstGeom>
+          <a:noFill/>
+          <a:ln w="12700">
+            <a:solidFill>
+              <a:srgbClr val="0A0A0A"/>
+            </a:solidFill>
+          </a:ln>
+          <a:effectLst/>
+        </p:spPr>
+        <p:style>
+          <a:lnRef idx="1">
+            <a:schemeClr val="accent1"/>
+          </a:lnRef>
+          <a:fillRef idx="3">
+            <a:schemeClr val="accent1"/>
+          </a:fillRef>
+          <a:effectRef idx="2">
+            <a:schemeClr val="accent1"/>
+          </a:effectRef>
+          <a:fontRef idx="minor">
+            <a:schemeClr val="lt1"/>
+          </a:fontRef>
+        </p:style>
+        <p:txBody>
+          <a:bodyPr rtlCol="0" anchor="ctr" wrap="square" lIns="73152" rIns="73152"/>
+          <a:lstStyle/>
+          <a:p>
+            <a:pPr algn="ctr"/>
+            <a:r>
+              <a:rPr b="1" sz="1400">
+                <a:solidFill>
+                  <a:srgbClr val="0A0A0A"/>
+                </a:solidFill>
+              </a:rPr>
+              <a:t>Define the model</a:t>
+            </a:r>
+          </a:p>
+          <a:p>
+            <a:pPr algn="ctr"/>
+            <a:r>
+              <a:rPr sz="1100">
+                <a:solidFill>
+                  <a:srgbClr val="6F6F6F"/>
+                </a:solidFill>
+              </a:rPr>
+              <a:t>add_state, add_ode; your decision</a:t>
+            </a:r>
+          </a:p>
+        </p:txBody>
+      </p:sp>
+      <p:sp>
+        <p:nvSpPr>
+          <p:cNvPr id="19" name="Rounded Rectangle 18"/>
+          <p:cNvSpPr/>
+          <p:nvPr/>
+        </p:nvSpPr>
+        <p:spPr>
+          <a:xfrm>
+            <a:off x="4087368" y="3730752"/>
+            <a:ext cx="4023360" cy="530352"/>
+          </a:xfrm>
+          <a:prstGeom prst="roundRect">
+            <a:avLst>
+              <a:gd name="adj" fmla="val 12000"/>
+            </a:avLst>
+          </a:prstGeom>
+          <a:noFill/>
+          <a:ln w="12700">
+            <a:solidFill>
+              <a:srgbClr val="0A0A0A"/>
+            </a:solidFill>
+          </a:ln>
+          <a:effectLst/>
+        </p:spPr>
+        <p:style>
+          <a:lnRef idx="1">
+            <a:schemeClr val="accent1"/>
+          </a:lnRef>
+          <a:fillRef idx="3">
+            <a:schemeClr val="accent1"/>
+          </a:fillRef>
+          <a:effectRef idx="2">
+            <a:schemeClr val="accent1"/>
+          </a:effectRef>
+          <a:fontRef idx="minor">
+            <a:schemeClr val="lt1"/>
+          </a:fontRef>
+        </p:style>
+        <p:txBody>
+          <a:bodyPr rtlCol="0" anchor="ctr" wrap="square" lIns="73152" rIns="73152"/>
+          <a:lstStyle/>
+          <a:p>
+            <a:pPr algn="ctr"/>
+            <a:r>
+              <a:rPr b="1" sz="1400">
+                <a:solidFill>
+                  <a:srgbClr val="0A0A0A"/>
+                </a:solidFill>
+              </a:rPr>
+              <a:t>Set the priors</a:t>
+            </a:r>
+          </a:p>
+          <a:p>
+            <a:pPr algn="ctr"/>
+            <a:r>
+              <a:rPr sz="1100">
+                <a:solidFill>
+                  <a:srgbClr val="6F6F6F"/>
+                </a:solidFill>
+              </a:rPr>
+              <a:t>LogUniform per parameter, yerrs; your decision</a:t>
+            </a:r>
+          </a:p>
+        </p:txBody>
+      </p:sp>
+      <p:sp>
+        <p:nvSpPr>
+          <p:cNvPr id="20" name="Rounded Rectangle 19"/>
+          <p:cNvSpPr/>
+          <p:nvPr/>
+        </p:nvSpPr>
+        <p:spPr>
+          <a:xfrm>
+            <a:off x="4087368" y="4407408"/>
+            <a:ext cx="4023360" cy="530352"/>
+          </a:xfrm>
+          <a:prstGeom prst="roundRect">
+            <a:avLst>
+              <a:gd name="adj" fmla="val 12000"/>
+            </a:avLst>
+          </a:prstGeom>
+          <a:noFill/>
+          <a:ln w="12700">
+            <a:solidFill>
+              <a:srgbClr val="0A0A0A"/>
+            </a:solidFill>
+          </a:ln>
+          <a:effectLst/>
+        </p:spPr>
+        <p:style>
+          <a:lnRef idx="1">
+            <a:schemeClr val="accent1"/>
+          </a:lnRef>
+          <a:fillRef idx="3">
+            <a:schemeClr val="accent1"/>
+          </a:fillRef>
+          <a:effectRef idx="2">
+            <a:schemeClr val="accent1"/>
+          </a:effectRef>
+          <a:fontRef idx="minor">
+            <a:schemeClr val="lt1"/>
+          </a:fontRef>
+        </p:style>
+        <p:txBody>
+          <a:bodyPr rtlCol="0" anchor="ctr" wrap="square" lIns="73152" rIns="73152"/>
+          <a:lstStyle/>
+          <a:p>
+            <a:pPr algn="ctr"/>
+            <a:r>
+              <a:rPr b="1" sz="1400">
+                <a:solidFill>
+                  <a:srgbClr val="0A0A0A"/>
+                </a:solidFill>
+              </a:rPr>
+              <a:t>Sample</a:t>
+            </a:r>
+          </a:p>
+          <a:p>
+            <a:pPr algn="ctr"/>
+            <a:r>
+              <a:rPr sz="1100">
+                <a:solidFill>
+                  <a:srgbClr val="6F6F6F"/>
+                </a:solidFill>
+              </a:rPr>
+              <a:t>run_mcmc: chains, warmup, samples</a:t>
+            </a:r>
+          </a:p>
+        </p:txBody>
+      </p:sp>
+      <p:sp>
+        <p:nvSpPr>
+          <p:cNvPr id="21" name="Rounded Rectangle 20"/>
+          <p:cNvSpPr/>
+          <p:nvPr/>
+        </p:nvSpPr>
+        <p:spPr>
+          <a:xfrm>
+            <a:off x="4087368" y="5084064"/>
+            <a:ext cx="4023360" cy="530352"/>
+          </a:xfrm>
+          <a:prstGeom prst="roundRect">
+            <a:avLst>
+              <a:gd name="adj" fmla="val 12000"/>
+            </a:avLst>
+          </a:prstGeom>
+          <a:noFill/>
+          <a:ln w="12700">
+            <a:solidFill>
+              <a:srgbClr val="0A0A0A"/>
+            </a:solidFill>
+          </a:ln>
+          <a:effectLst/>
+        </p:spPr>
+        <p:style>
+          <a:lnRef idx="1">
+            <a:schemeClr val="accent1"/>
+          </a:lnRef>
+          <a:fillRef idx="3">
+            <a:schemeClr val="accent1"/>
+          </a:fillRef>
+          <a:effectRef idx="2">
+            <a:schemeClr val="accent1"/>
+          </a:effectRef>
+          <a:fontRef idx="minor">
+            <a:schemeClr val="lt1"/>
+          </a:fontRef>
+        </p:style>
+        <p:txBody>
+          <a:bodyPr rtlCol="0" anchor="ctr" wrap="square" lIns="73152" rIns="73152"/>
+          <a:lstStyle/>
+          <a:p>
+            <a:pPr algn="ctr"/>
+            <a:r>
+              <a:rPr b="1" sz="1400">
+                <a:solidFill>
+                  <a:srgbClr val="0A0A0A"/>
+                </a:solidFill>
+              </a:rPr>
+              <a:t>Check and plot</a:t>
+            </a:r>
+          </a:p>
+          <a:p>
+            <a:pPr algn="ctr"/>
+            <a:r>
+              <a:rPr sz="1100">
+                <a:solidFill>
+                  <a:srgbClr val="6F6F6F"/>
+                </a:solidFill>
+              </a:rPr>
+              <a:t>r-hat, divergences, bounds, correlations</a:t>
+            </a:r>
+          </a:p>
+        </p:txBody>
+      </p:sp>
+      <p:cxnSp>
+        <p:nvCxnSpPr>
+          <p:cNvPr id="22" name="Connector 21"/>
+          <p:cNvCxnSpPr/>
+          <p:nvPr/>
+        </p:nvCxnSpPr>
+        <p:spPr>
+          <a:xfrm>
+            <a:off x="6099048" y="2926080"/>
+            <a:ext cx="0" cy="109728"/>
+          </a:xfrm>
+          <a:prstGeom prst="line">
+            <a:avLst/>
+          </a:prstGeom>
+          <a:ln w="15875">
+            <a:solidFill>
+              <a:srgbClr val="0A0A0A"/>
+            </a:solidFill>
+            <a:tailEnd type="triangle" w="med" len="med"/>
+          </a:ln>
+        </p:spPr>
+        <p:style>
+          <a:lnRef idx="2">
+            <a:schemeClr val="accent1"/>
+          </a:lnRef>
+          <a:fillRef idx="0">
+            <a:schemeClr val="accent1"/>
+          </a:fillRef>
+          <a:effectRef idx="1">
+            <a:schemeClr val="accent1"/>
+          </a:effectRef>
+          <a:fontRef idx="minor">
+            <a:schemeClr val="tx1"/>
+          </a:fontRef>
+        </p:style>
+      </p:cxnSp>
+      <p:cxnSp>
+        <p:nvCxnSpPr>
+          <p:cNvPr id="23" name="Connector 22"/>
+          <p:cNvCxnSpPr/>
+          <p:nvPr/>
+        </p:nvCxnSpPr>
+        <p:spPr>
+          <a:xfrm>
+            <a:off x="6099048" y="3602736"/>
+            <a:ext cx="0" cy="109728"/>
+          </a:xfrm>
+          <a:prstGeom prst="line">
+            <a:avLst/>
+          </a:prstGeom>
+          <a:ln w="15875">
+            <a:solidFill>
+              <a:srgbClr val="0A0A0A"/>
+            </a:solidFill>
+            <a:tailEnd type="triangle" w="med" len="med"/>
+          </a:ln>
+        </p:spPr>
+        <p:style>
+          <a:lnRef idx="2">
+            <a:schemeClr val="accent1"/>
+          </a:lnRef>
+          <a:fillRef idx="0">
+            <a:schemeClr val="accent1"/>
+          </a:fillRef>
+          <a:effectRef idx="1">
+            <a:schemeClr val="accent1"/>
+          </a:effectRef>
+          <a:fontRef idx="minor">
+            <a:schemeClr val="tx1"/>
+          </a:fontRef>
+        </p:style>
+      </p:cxnSp>
+      <p:cxnSp>
+        <p:nvCxnSpPr>
+          <p:cNvPr id="24" name="Connector 23"/>
+          <p:cNvCxnSpPr/>
+          <p:nvPr/>
+        </p:nvCxnSpPr>
+        <p:spPr>
+          <a:xfrm>
+            <a:off x="6099048" y="4279392"/>
+            <a:ext cx="0" cy="109728"/>
+          </a:xfrm>
+          <a:prstGeom prst="line">
+            <a:avLst/>
+          </a:prstGeom>
+          <a:ln w="15875">
+            <a:solidFill>
+              <a:srgbClr val="0A0A0A"/>
+            </a:solidFill>
+            <a:tailEnd type="triangle" w="med" len="med"/>
+          </a:ln>
+        </p:spPr>
+        <p:style>
+          <a:lnRef idx="2">
+            <a:schemeClr val="accent1"/>
+          </a:lnRef>
+          <a:fillRef idx="0">
+            <a:schemeClr val="accent1"/>
+          </a:fillRef>
+          <a:effectRef idx="1">
+            <a:schemeClr val="accent1"/>
+          </a:effectRef>
+          <a:fontRef idx="minor">
+            <a:schemeClr val="tx1"/>
+          </a:fontRef>
+        </p:style>
+      </p:cxnSp>
+      <p:cxnSp>
+        <p:nvCxnSpPr>
+          <p:cNvPr id="25" name="Connector 24"/>
+          <p:cNvCxnSpPr/>
+          <p:nvPr/>
+        </p:nvCxnSpPr>
+        <p:spPr>
+          <a:xfrm>
+            <a:off x="6099048" y="4956048"/>
+            <a:ext cx="0" cy="109728"/>
+          </a:xfrm>
+          <a:prstGeom prst="line">
+            <a:avLst/>
+          </a:prstGeom>
+          <a:ln w="15875">
+            <a:solidFill>
+              <a:srgbClr val="0A0A0A"/>
+            </a:solidFill>
+            <a:tailEnd type="triangle" w="med" len="med"/>
+          </a:ln>
+        </p:spPr>
+        <p:style>
+          <a:lnRef idx="2">
+            <a:schemeClr val="accent1"/>
+          </a:lnRef>
+          <a:fillRef idx="0">
+            <a:schemeClr val="accent1"/>
+          </a:fillRef>
+          <a:effectRef idx="1">
+            <a:schemeClr val="accent1"/>
+          </a:effectRef>
+          <a:fontRef idx="minor">
+            <a:schemeClr val="tx1"/>
+          </a:fontRef>
+        </p:style>
+      </p:cxnSp>
+      <p:cxnSp>
+        <p:nvCxnSpPr>
+          <p:cNvPr id="26" name="Connector 25"/>
+          <p:cNvCxnSpPr/>
+          <p:nvPr/>
+        </p:nvCxnSpPr>
+        <p:spPr>
+          <a:xfrm>
+            <a:off x="8110728" y="5349240"/>
+            <a:ext cx="283464" cy="0"/>
+          </a:xfrm>
+          <a:prstGeom prst="line">
+            <a:avLst/>
+          </a:prstGeom>
+          <a:ln w="15875">
+            <a:solidFill>
+              <a:srgbClr val="0A0A0A"/>
+            </a:solidFill>
+          </a:ln>
+        </p:spPr>
+        <p:style>
+          <a:lnRef idx="2">
+            <a:schemeClr val="accent1"/>
+          </a:lnRef>
+          <a:fillRef idx="0">
+            <a:schemeClr val="accent1"/>
+          </a:fillRef>
+          <a:effectRef idx="1">
+            <a:schemeClr val="accent1"/>
+          </a:effectRef>
+          <a:fontRef idx="minor">
+            <a:schemeClr val="tx1"/>
+          </a:fontRef>
+        </p:style>
+      </p:cxnSp>
+      <p:cxnSp>
+        <p:nvCxnSpPr>
+          <p:cNvPr id="27" name="Connector 26"/>
+          <p:cNvCxnSpPr/>
+          <p:nvPr/>
+        </p:nvCxnSpPr>
+        <p:spPr>
+          <a:xfrm>
+            <a:off x="8394192" y="2720340"/>
+            <a:ext cx="0" cy="2628900"/>
+          </a:xfrm>
+          <a:prstGeom prst="line">
+            <a:avLst/>
+          </a:prstGeom>
+          <a:ln w="15875">
+            <a:solidFill>
+              <a:srgbClr val="0A0A0A"/>
+            </a:solidFill>
+          </a:ln>
+        </p:spPr>
+        <p:style>
+          <a:lnRef idx="2">
+            <a:schemeClr val="accent1"/>
+          </a:lnRef>
+          <a:fillRef idx="0">
+            <a:schemeClr val="accent1"/>
+          </a:fillRef>
+          <a:effectRef idx="1">
+            <a:schemeClr val="accent1"/>
+          </a:effectRef>
+          <a:fontRef idx="minor">
+            <a:schemeClr val="tx1"/>
+          </a:fontRef>
+        </p:style>
+      </p:cxnSp>
+      <p:sp>
+        <p:nvSpPr>
+          <p:cNvPr id="28" name="Rounded Rectangle 27"/>
+          <p:cNvSpPr/>
+          <p:nvPr/>
+        </p:nvSpPr>
+        <p:spPr>
+          <a:xfrm>
+            <a:off x="8622792" y="2377440"/>
+            <a:ext cx="2743200" cy="685800"/>
+          </a:xfrm>
+          <a:prstGeom prst="roundRect">
+            <a:avLst>
+              <a:gd name="adj" fmla="val 12000"/>
+            </a:avLst>
+          </a:prstGeom>
+          <a:noFill/>
+          <a:ln w="12700">
+            <a:solidFill>
+              <a:srgbClr val="0A0A0A"/>
+            </a:solidFill>
+          </a:ln>
+          <a:effectLst/>
+        </p:spPr>
+        <p:style>
+          <a:lnRef idx="1">
+            <a:schemeClr val="accent1"/>
+          </a:lnRef>
+          <a:fillRef idx="3">
+            <a:schemeClr val="accent1"/>
+          </a:fillRef>
+          <a:effectRef idx="2">
+            <a:schemeClr val="accent1"/>
+          </a:effectRef>
+          <a:fontRef idx="minor">
+            <a:schemeClr val="lt1"/>
+          </a:fontRef>
+        </p:style>
+        <p:txBody>
+          <a:bodyPr rtlCol="0" anchor="ctr" wrap="square" lIns="73152" rIns="73152"/>
+          <a:lstStyle/>
+          <a:p>
+            <a:pPr algn="ctr"/>
+            <a:r>
+              <a:rPr b="1" sz="1400">
+                <a:solidFill>
+                  <a:srgbClr val="0A0A0A"/>
+                </a:solidFill>
+              </a:rPr>
+              <a:t>Posterior</a:t>
+            </a:r>
+          </a:p>
+          <a:p>
+            <a:pPr algn="ctr"/>
+            <a:r>
+              <a:rPr i="1" sz="1100">
+                <a:solidFill>
+                  <a:srgbClr val="6F6F6F"/>
+                </a:solidFill>
+              </a:rPr>
+              <a:t>k</a:t>
+            </a:r>
+            <a:r>
+              <a:rPr sz="1100" baseline="-25000">
+                <a:solidFill>
+                  <a:srgbClr val="6F6F6F"/>
+                </a:solidFill>
+              </a:rPr>
+              <a:t>cat</a:t>
+            </a:r>
+            <a:r>
+              <a:rPr sz="1100">
+                <a:solidFill>
+                  <a:srgbClr val="6F6F6F"/>
+                </a:solidFill>
+              </a:rPr>
+              <a:t>, </a:t>
+            </a:r>
+            <a:r>
+              <a:rPr i="1" sz="1100">
+                <a:solidFill>
+                  <a:srgbClr val="6F6F6F"/>
+                </a:solidFill>
+              </a:rPr>
+              <a:t>K</a:t>
+            </a:r>
+            <a:r>
+              <a:rPr i="1" sz="1100" baseline="-25000">
+                <a:solidFill>
+                  <a:srgbClr val="6F6F6F"/>
+                </a:solidFill>
+              </a:rPr>
+              <a:t>M</a:t>
+            </a:r>
+            <a:r>
+              <a:rPr sz="1100" baseline="30000">
+                <a:solidFill>
+                  <a:srgbClr val="6F6F6F"/>
+                </a:solidFill>
+              </a:rPr>
+              <a:t>ManNAc</a:t>
+            </a:r>
+            <a:r>
+              <a:rPr sz="1100">
+                <a:solidFill>
+                  <a:srgbClr val="6F6F6F"/>
+                </a:solidFill>
+              </a:rPr>
+              <a:t>, </a:t>
+            </a:r>
+            <a:r>
+              <a:rPr i="1" sz="1100">
+                <a:solidFill>
+                  <a:srgbClr val="6F6F6F"/>
+                </a:solidFill>
+              </a:rPr>
+              <a:t>K</a:t>
+            </a:r>
+            <a:r>
+              <a:rPr i="1" sz="1100" baseline="-25000">
+                <a:solidFill>
+                  <a:srgbClr val="6F6F6F"/>
+                </a:solidFill>
+              </a:rPr>
+              <a:t>M</a:t>
+            </a:r>
+            <a:r>
+              <a:rPr sz="1100" baseline="30000">
+                <a:solidFill>
+                  <a:srgbClr val="6F6F6F"/>
+                </a:solidFill>
+              </a:rPr>
+              <a:t>PEP</a:t>
+            </a:r>
+            <a:r>
+              <a:rPr sz="1100">
+                <a:solidFill>
+                  <a:srgbClr val="6F6F6F"/>
+                </a:solidFill>
+              </a:rPr>
+              <a:t>: mean ± sd, intervals</a:t>
+            </a:r>
+          </a:p>
+        </p:txBody>
+      </p:sp>
+      <p:cxnSp>
+        <p:nvCxnSpPr>
+          <p:cNvPr id="29" name="Connector 28"/>
+          <p:cNvCxnSpPr/>
+          <p:nvPr/>
+        </p:nvCxnSpPr>
+        <p:spPr>
+          <a:xfrm>
+            <a:off x="8394192" y="2720340"/>
+            <a:ext cx="173736" cy="0"/>
+          </a:xfrm>
+          <a:prstGeom prst="line">
+            <a:avLst/>
+          </a:prstGeom>
+          <a:ln w="15875">
+            <a:solidFill>
+              <a:srgbClr val="0A0A0A"/>
+            </a:solidFill>
+            <a:tailEnd type="triangle" w="med" len="med"/>
+          </a:ln>
+        </p:spPr>
+        <p:style>
+          <a:lnRef idx="2">
+            <a:schemeClr val="accent1"/>
+          </a:lnRef>
+          <a:fillRef idx="0">
+            <a:schemeClr val="accent1"/>
+          </a:fillRef>
+          <a:effectRef idx="1">
+            <a:schemeClr val="accent1"/>
+          </a:effectRef>
+          <a:fontRef idx="minor">
+            <a:schemeClr val="tx1"/>
+          </a:fontRef>
+        </p:style>
+      </p:cxnSp>
+      <p:sp>
+        <p:nvSpPr>
+          <p:cNvPr id="30" name="Rounded Rectangle 29"/>
+          <p:cNvSpPr/>
+          <p:nvPr/>
+        </p:nvSpPr>
+        <p:spPr>
+          <a:xfrm>
+            <a:off x="8622792" y="3291840"/>
+            <a:ext cx="2743200" cy="685800"/>
+          </a:xfrm>
+          <a:prstGeom prst="roundRect">
+            <a:avLst>
+              <a:gd name="adj" fmla="val 12000"/>
+            </a:avLst>
+          </a:prstGeom>
+          <a:noFill/>
+          <a:ln w="12700">
+            <a:solidFill>
+              <a:srgbClr val="0A0A0A"/>
+            </a:solidFill>
+          </a:ln>
+          <a:effectLst/>
+        </p:spPr>
+        <p:style>
+          <a:lnRef idx="1">
+            <a:schemeClr val="accent1"/>
+          </a:lnRef>
+          <a:fillRef idx="3">
+            <a:schemeClr val="accent1"/>
+          </a:fillRef>
+          <a:effectRef idx="2">
+            <a:schemeClr val="accent1"/>
+          </a:effectRef>
+          <a:fontRef idx="minor">
+            <a:schemeClr val="lt1"/>
+          </a:fontRef>
+        </p:style>
+        <p:txBody>
+          <a:bodyPr rtlCol="0" anchor="ctr" wrap="square" lIns="73152" rIns="73152"/>
+          <a:lstStyle/>
+          <a:p>
+            <a:pPr algn="ctr"/>
+            <a:r>
+              <a:rPr b="1" sz="1400">
+                <a:solidFill>
+                  <a:srgbClr val="0A0A0A"/>
+                </a:solidFill>
+              </a:rPr>
+              <a:t>Plots</a:t>
+            </a:r>
+          </a:p>
+          <a:p>
+            <a:pPr algn="ctr"/>
+            <a:r>
+              <a:rPr sz="1100">
+                <a:solidFill>
+                  <a:srgbClr val="6F6F6F"/>
+                </a:solidFill>
+              </a:rPr>
+              <a:t>corner plot; data with the model on top</a:t>
+            </a:r>
+          </a:p>
+        </p:txBody>
+      </p:sp>
+      <p:cxnSp>
+        <p:nvCxnSpPr>
+          <p:cNvPr id="31" name="Connector 30"/>
+          <p:cNvCxnSpPr/>
+          <p:nvPr/>
+        </p:nvCxnSpPr>
+        <p:spPr>
+          <a:xfrm>
+            <a:off x="8394192" y="3634740"/>
+            <a:ext cx="173736" cy="0"/>
+          </a:xfrm>
+          <a:prstGeom prst="line">
+            <a:avLst/>
+          </a:prstGeom>
+          <a:ln w="15875">
+            <a:solidFill>
+              <a:srgbClr val="0A0A0A"/>
+            </a:solidFill>
+            <a:tailEnd type="triangle" w="med" len="med"/>
+          </a:ln>
+        </p:spPr>
+        <p:style>
+          <a:lnRef idx="2">
+            <a:schemeClr val="accent1"/>
+          </a:lnRef>
+          <a:fillRef idx="0">
+            <a:schemeClr val="accent1"/>
+          </a:fillRef>
+          <a:effectRef idx="1">
+            <a:schemeClr val="accent1"/>
+          </a:effectRef>
+          <a:fontRef idx="minor">
+            <a:schemeClr val="tx1"/>
+          </a:fontRef>
+        </p:style>
+      </p:cxnSp>
+    </p:spTree>
+  </p:cSld>
+  <p:clrMapOvr>
+    <a:masterClrMapping/>
+  </p:clrMapOvr>
+</p:sld>
+</file>
+
+<file path=ppt/slides/slide8.xml><?xml version="1.0" encoding="utf-8"?>
+<p:sld xmlns:a="http://schemas.openxmlformats.org/drawingml/2006/main" xmlns:p="http://schemas.openxmlformats.org/presentationml/2006/main" xmlns:r="http://schemas.openxmlformats.org/officeDocument/2006/relationships">
+  <p:cSld>
+    <p:spTree>
+      <p:nvGrpSpPr>
+        <p:cNvPr id="1" name=""/>
+        <p:cNvGrpSpPr/>
+        <p:nvPr/>
+      </p:nvGrpSpPr>
+      <p:grpSpPr/>
+      <p:sp>
+        <p:nvSpPr>
+          <p:cNvPr id="2" name="Title 1"/>
+          <p:cNvSpPr>
+            <a:spLocks noGrp="1"/>
+          </p:cNvSpPr>
+          <p:nvPr>
+            <p:ph type="title"/>
+          </p:nvPr>
+        </p:nvSpPr>
+        <p:spPr/>
+        <p:txBody>
+          <a:bodyPr/>
+          <a:lstStyle/>
+          <a:p>
+            <a:r>
+              <a:rPr/>
               <a:t>ManNAc + PEP → Neu5Ac + Pi, followed by HPLC</a:t>
             </a:r>
           </a:p>
@@ -6977,7 +10139,7 @@
 </p:sld>
 </file>
 
-<file path=ppt/slides/slide7.xml><?xml version="1.0" encoding="utf-8"?>
+<file path=ppt/slides/slide9.xml><?xml version="1.0" encoding="utf-8"?>
 <p:sld xmlns:a="http://schemas.openxmlformats.org/drawingml/2006/main" xmlns:p="http://schemas.openxmlformats.org/presentationml/2006/main" xmlns:r="http://schemas.openxmlformats.org/officeDocument/2006/relationships">
   <p:cSld>
     <p:spTree>
@@ -7309,350 +10471,6 @@
           </a:graphicData>
         </a:graphic>
       </p:graphicFrame>
-    </p:spTree>
-  </p:cSld>
-  <p:clrMapOvr>
-    <a:masterClrMapping/>
-  </p:clrMapOvr>
-</p:sld>
-</file>
-
-<file path=ppt/slides/slide8.xml><?xml version="1.0" encoding="utf-8"?>
-<p:sld xmlns:a="http://schemas.openxmlformats.org/drawingml/2006/main" xmlns:p="http://schemas.openxmlformats.org/presentationml/2006/main" xmlns:r="http://schemas.openxmlformats.org/officeDocument/2006/relationships">
-  <p:cSld>
-    <p:spTree>
-      <p:nvGrpSpPr>
-        <p:cNvPr id="1" name=""/>
-        <p:cNvGrpSpPr/>
-        <p:nvPr/>
-      </p:nvGrpSpPr>
-      <p:grpSpPr/>
-      <p:sp>
-        <p:nvSpPr>
-          <p:cNvPr id="2" name="Title 1"/>
-          <p:cNvSpPr>
-            <a:spLocks noGrp="1"/>
-          </p:cNvSpPr>
-          <p:nvPr>
-            <p:ph type="title"/>
-          </p:nvPr>
-        </p:nvSpPr>
-        <p:spPr/>
-        <p:txBody>
-          <a:bodyPr/>
-          <a:lstStyle/>
-          <a:p>
-            <a:r>
-              <a:rPr/>
-              <a:t>What we do today</a:t>
-            </a:r>
-          </a:p>
-        </p:txBody>
-      </p:sp>
-      <p:sp>
-        <p:nvSpPr>
-          <p:cNvPr id="3" name="Content Placeholder 2"/>
-          <p:cNvSpPr>
-            <a:spLocks noGrp="1"/>
-          </p:cNvSpPr>
-          <p:nvPr>
-            <p:ph idx="1"/>
-          </p:nvPr>
-        </p:nvSpPr>
-        <p:spPr/>
-        <p:txBody>
-          <a:bodyPr/>
-          <a:lstStyle/>
-          <a:p>
-            <a:r>
-              <a:rPr b="1"/>
-              <a:t>Task 1: </a:t>
-            </a:r>
-            <a:r>
-              <a:rPr/>
-              <a:t>from the peak tables to an EnzymeML document (Chromhandler)</a:t>
-            </a:r>
-          </a:p>
-          <a:p>
-            <a:r>
-              <a:rPr b="1"/>
-              <a:t>Task 2: </a:t>
-            </a:r>
-            <a:r>
-              <a:rPr/>
-              <a:t>from the EnzymeML document to </a:t>
-            </a:r>
-            <a:r>
-              <a:rPr i="1"/>
-              <a:t>k</a:t>
-            </a:r>
-            <a:r>
-              <a:rPr baseline="-25000"/>
-              <a:t>cat</a:t>
-            </a:r>
-            <a:r>
-              <a:rPr/>
-              <a:t> and </a:t>
-            </a:r>
-            <a:r>
-              <a:rPr i="1"/>
-              <a:t>K</a:t>
-            </a:r>
-            <a:r>
-              <a:rPr i="1" baseline="-25000"/>
-              <a:t>M</a:t>
-            </a:r>
-            <a:r>
-              <a:rPr/>
-              <a:t> by Bayesian inference (Catalax)</a:t>
-            </a:r>
-          </a:p>
-          <a:p>
-            <a:r>
-              <a:rPr/>
-              <a:t>A live demo of each task first, then you work in pairs</a:t>
-            </a:r>
-          </a:p>
-          <a:p>
-            <a:r>
-              <a:rPr/>
-              <a:t>The checks in the task card say when you are done</a:t>
-            </a:r>
-          </a:p>
-          <a:p>
-            <a:r>
-              <a:rPr/>
-              <a:t>At the end we compare everybody's parameters and discuss</a:t>
-            </a:r>
-          </a:p>
-        </p:txBody>
-      </p:sp>
-      <p:sp>
-        <p:nvSpPr>
-          <p:cNvPr id="4" name="Text Placeholder 3"/>
-          <p:cNvSpPr>
-            <a:spLocks noGrp="1"/>
-          </p:cNvSpPr>
-          <p:nvPr>
-            <p:ph type="body" idx="13" sz="quarter"/>
-          </p:nvPr>
-        </p:nvSpPr>
-        <p:spPr/>
-        <p:txBody>
-          <a:bodyPr/>
-          <a:lstStyle/>
-          <a:p>
-            <a:r>
-              <a:rPr/>
-              <a:t>Today</a:t>
-            </a:r>
-          </a:p>
-        </p:txBody>
-      </p:sp>
-    </p:spTree>
-  </p:cSld>
-  <p:clrMapOvr>
-    <a:masterClrMapping/>
-  </p:clrMapOvr>
-</p:sld>
-</file>
-
-<file path=ppt/slides/slide9.xml><?xml version="1.0" encoding="utf-8"?>
-<p:sld xmlns:a="http://schemas.openxmlformats.org/drawingml/2006/main" xmlns:p="http://schemas.openxmlformats.org/presentationml/2006/main" xmlns:r="http://schemas.openxmlformats.org/officeDocument/2006/relationships">
-  <p:cSld>
-    <p:spTree>
-      <p:nvGrpSpPr>
-        <p:cNvPr id="1" name=""/>
-        <p:cNvGrpSpPr/>
-        <p:nvPr/>
-      </p:nvGrpSpPr>
-      <p:grpSpPr/>
-      <p:sp>
-        <p:nvSpPr>
-          <p:cNvPr id="2" name="Title 1"/>
-          <p:cNvSpPr>
-            <a:spLocks noGrp="1"/>
-          </p:cNvSpPr>
-          <p:nvPr>
-            <p:ph type="title"/>
-          </p:nvPr>
-        </p:nvSpPr>
-        <p:spPr/>
-        <p:txBody>
-          <a:bodyPr/>
-          <a:lstStyle/>
-          <a:p>
-            <a:r>
-              <a:rPr/>
-              <a:t>One repository, two ways to work</a:t>
-            </a:r>
-          </a:p>
-        </p:txBody>
-      </p:sp>
-      <p:sp>
-        <p:nvSpPr>
-          <p:cNvPr id="3" name="Content Placeholder 2"/>
-          <p:cNvSpPr>
-            <a:spLocks noGrp="1"/>
-          </p:cNvSpPr>
-          <p:nvPr>
-            <p:ph idx="1" sz="half"/>
-          </p:nvPr>
-        </p:nvSpPr>
-        <p:spPr/>
-        <p:txBody>
-          <a:bodyPr/>
-          <a:lstStyle/>
-          <a:p>
-            <a:pPr marL="0" indent="0">
-              <a:buNone/>
-            </a:pPr>
-            <a:r>
-              <a:rPr b="1"/>
-              <a:t>With a language model</a:t>
-            </a:r>
-          </a:p>
-          <a:p>
-            <a:r>
-              <a:rPr b="1"/>
-              <a:t>Any chat model, </a:t>
-            </a:r>
-            <a:r>
-              <a:rPr/>
-              <a:t>free or by subscription: ChatGPT, Claude, Gemini, …</a:t>
-            </a:r>
-          </a:p>
-          <a:p>
-            <a:r>
-              <a:rPr b="1"/>
-              <a:t>Paste </a:t>
-            </a:r>
-            <a:r>
-              <a:rPr/>
-              <a:t>the tool card and the task card; run the code, paste errors back</a:t>
-            </a:r>
-          </a:p>
-          <a:p>
-            <a:r>
-              <a:rPr b="1"/>
-              <a:t>The checks </a:t>
-            </a:r>
-            <a:r>
-              <a:rPr/>
-              <a:t>decide when you are done</a:t>
-            </a:r>
-          </a:p>
-          <a:p>
-            <a:r>
-              <a:rPr b="1"/>
-              <a:t>notebooks/ </a:t>
-            </a:r>
-            <a:r>
-              <a:rPr/>
-              <a:t>are the reference solutions, checkpoints/ the result of task 1</a:t>
-            </a:r>
-          </a:p>
-        </p:txBody>
-      </p:sp>
-      <p:sp>
-        <p:nvSpPr>
-          <p:cNvPr id="4" name="Content Placeholder 3"/>
-          <p:cNvSpPr>
-            <a:spLocks noGrp="1"/>
-          </p:cNvSpPr>
-          <p:nvPr>
-            <p:ph idx="2" sz="half"/>
-          </p:nvPr>
-        </p:nvSpPr>
-        <p:spPr/>
-        <p:txBody>
-          <a:bodyPr/>
-          <a:lstStyle/>
-          <a:p>
-            <a:pPr marL="0" indent="0">
-              <a:buNone/>
-            </a:pPr>
-            <a:r>
-              <a:rPr b="1"/>
-              <a:t>Without writing code</a:t>
-            </a:r>
-          </a:p>
-          <a:p>
-            <a:r>
-              <a:rPr b="1"/>
-              <a:t>Open the Colab link: </a:t>
-            </a:r>
-            <a:r>
-              <a:rPr/>
-              <a:t>a prepared notebook, tools installed, data loaded</a:t>
-            </a:r>
-          </a:p>
-          <a:p>
-            <a:r>
-              <a:rPr b="1"/>
-              <a:t>Run it cell by cell; </a:t>
-            </a:r>
-            <a:r>
-              <a:rPr/>
-              <a:t>change a window, a prior, a series</a:t>
-            </a:r>
-          </a:p>
-          <a:p>
-            <a:r>
-              <a:rPr b="1"/>
-              <a:t>Ask the model in Colab </a:t>
-            </a:r>
-            <a:r>
-              <a:rPr/>
-              <a:t>to explain any cell</a:t>
-            </a:r>
-          </a:p>
-        </p:txBody>
-      </p:sp>
-      <p:sp>
-        <p:nvSpPr>
-          <p:cNvPr id="5" name="Text Placeholder 4"/>
-          <p:cNvSpPr>
-            <a:spLocks noGrp="1"/>
-          </p:cNvSpPr>
-          <p:nvPr>
-            <p:ph type="body" idx="13" sz="quarter"/>
-          </p:nvPr>
-        </p:nvSpPr>
-        <p:spPr/>
-        <p:txBody>
-          <a:bodyPr/>
-          <a:lstStyle/>
-          <a:p>
-            <a:r>
-              <a:rPr/>
-              <a:t>Toolkit</a:t>
-            </a:r>
-          </a:p>
-        </p:txBody>
-      </p:sp>
-      <p:sp>
-        <p:nvSpPr>
-          <p:cNvPr id="6" name="Text Placeholder 5"/>
-          <p:cNvSpPr>
-            <a:spLocks noGrp="1"/>
-          </p:cNvSpPr>
-          <p:nvPr>
-            <p:ph type="body" idx="15" sz="quarter"/>
-          </p:nvPr>
-        </p:nvSpPr>
-        <p:spPr/>
-        <p:txBody>
-          <a:bodyPr/>
-          <a:lstStyle/>
-          <a:p>
-            <a:r>
-              <a:rPr/>
-              <a:t>github.com/haeussma/enzymeml-workshop-modelling-2026 · start with the README</a:t>
-            </a:r>
-          </a:p>
-        </p:txBody>
-      </p:sp>
     </p:spTree>
   </p:cSld>
   <p:clrMapOvr>

</xml_diff>

<commit_message>
Deck: spacing on the looking-back slide
Co-Authored-By: Claude Fable 5.1 <noreply@anthropic.com>
</commit_message>
<xml_diff>
--- a/slides/workshop.pptx
+++ b/slides/workshop.pptx
@@ -5357,8 +5357,8 @@
         </p:nvSpPr>
         <p:spPr>
           <a:xfrm>
-            <a:off x="822960" y="4160520"/>
-            <a:ext cx="10545775" cy="1463040"/>
+            <a:off x="822960" y="4480560"/>
+            <a:ext cx="10545775" cy="1188720"/>
           </a:xfrm>
         </p:spPr>
         <p:txBody>

</xml_diff>

<commit_message>
Deck: drop the hurdles bracket on the looking-back slide
Co-Authored-By: Claude Fable 5.1 <noreply@anthropic.com>
</commit_message>
<xml_diff>
--- a/slides/workshop.pptx
+++ b/slides/workshop.pptx
@@ -5357,7 +5357,7 @@
         </p:nvSpPr>
         <p:spPr>
           <a:xfrm>
-            <a:off x="822960" y="4480560"/>
+            <a:off x="822960" y="4114800"/>
             <a:ext cx="10545775" cy="1188720"/>
           </a:xfrm>
         </p:spPr>
@@ -5901,145 +5901,6 @@
           </a:fontRef>
         </p:style>
       </p:cxnSp>
-      <p:cxnSp>
-        <p:nvCxnSpPr>
-          <p:cNvPr id="17" name="Connector 16"/>
-          <p:cNvCxnSpPr/>
-          <p:nvPr/>
-        </p:nvCxnSpPr>
-        <p:spPr>
-          <a:xfrm>
-            <a:off x="822960" y="3840480"/>
-            <a:ext cx="8330184" cy="0"/>
-          </a:xfrm>
-          <a:prstGeom prst="line">
-            <a:avLst/>
-          </a:prstGeom>
-          <a:ln w="15875">
-            <a:solidFill>
-              <a:srgbClr val="0A0A0A"/>
-            </a:solidFill>
-          </a:ln>
-        </p:spPr>
-        <p:style>
-          <a:lnRef idx="2">
-            <a:schemeClr val="accent1"/>
-          </a:lnRef>
-          <a:fillRef idx="0">
-            <a:schemeClr val="accent1"/>
-          </a:fillRef>
-          <a:effectRef idx="1">
-            <a:schemeClr val="accent1"/>
-          </a:effectRef>
-          <a:fontRef idx="minor">
-            <a:schemeClr val="tx1"/>
-          </a:fontRef>
-        </p:style>
-      </p:cxnSp>
-      <p:cxnSp>
-        <p:nvCxnSpPr>
-          <p:cNvPr id="18" name="Connector 17"/>
-          <p:cNvCxnSpPr/>
-          <p:nvPr/>
-        </p:nvCxnSpPr>
-        <p:spPr>
-          <a:xfrm>
-            <a:off x="822960" y="3730752"/>
-            <a:ext cx="0" cy="109728"/>
-          </a:xfrm>
-          <a:prstGeom prst="line">
-            <a:avLst/>
-          </a:prstGeom>
-          <a:ln w="15875">
-            <a:solidFill>
-              <a:srgbClr val="0A0A0A"/>
-            </a:solidFill>
-          </a:ln>
-        </p:spPr>
-        <p:style>
-          <a:lnRef idx="2">
-            <a:schemeClr val="accent1"/>
-          </a:lnRef>
-          <a:fillRef idx="0">
-            <a:schemeClr val="accent1"/>
-          </a:fillRef>
-          <a:effectRef idx="1">
-            <a:schemeClr val="accent1"/>
-          </a:effectRef>
-          <a:fontRef idx="minor">
-            <a:schemeClr val="tx1"/>
-          </a:fontRef>
-        </p:style>
-      </p:cxnSp>
-      <p:cxnSp>
-        <p:nvCxnSpPr>
-          <p:cNvPr id="19" name="Connector 18"/>
-          <p:cNvCxnSpPr/>
-          <p:nvPr/>
-        </p:nvCxnSpPr>
-        <p:spPr>
-          <a:xfrm>
-            <a:off x="9153144" y="3730752"/>
-            <a:ext cx="0" cy="109728"/>
-          </a:xfrm>
-          <a:prstGeom prst="line">
-            <a:avLst/>
-          </a:prstGeom>
-          <a:ln w="15875">
-            <a:solidFill>
-              <a:srgbClr val="0A0A0A"/>
-            </a:solidFill>
-          </a:ln>
-        </p:spPr>
-        <p:style>
-          <a:lnRef idx="2">
-            <a:schemeClr val="accent1"/>
-          </a:lnRef>
-          <a:fillRef idx="0">
-            <a:schemeClr val="accent1"/>
-          </a:fillRef>
-          <a:effectRef idx="1">
-            <a:schemeClr val="accent1"/>
-          </a:effectRef>
-          <a:fontRef idx="minor">
-            <a:schemeClr val="tx1"/>
-          </a:fontRef>
-        </p:style>
-      </p:cxnSp>
-      <p:sp>
-        <p:nvSpPr>
-          <p:cNvPr id="20" name="TextBox 19"/>
-          <p:cNvSpPr txBox="1"/>
-          <p:nvPr/>
-        </p:nvSpPr>
-        <p:spPr>
-          <a:xfrm>
-            <a:off x="822960" y="3913632"/>
-            <a:ext cx="8330183" cy="274320"/>
-          </a:xfrm>
-          <a:prstGeom prst="rect">
-            <a:avLst/>
-          </a:prstGeom>
-          <a:noFill/>
-        </p:spPr>
-        <p:txBody>
-          <a:bodyPr wrap="square" lIns="0" rIns="0" tIns="0" bIns="0">
-            <a:spAutoFit/>
-          </a:bodyPr>
-          <a:lstStyle/>
-          <a:p>
-            <a:pPr algn="ctr"/>
-            <a:r>
-              <a:rPr sz="1200">
-                <a:solidFill>
-                  <a:srgbClr val="0A0A0A"/>
-                </a:solidFill>
-              </a:rPr>
-              <a:t>the hurdles</a:t>
-            </a:r>
-          </a:p>
-        </p:txBody>
-      </p:sp>
     </p:spTree>
   </p:cSld>
   <p:clrMapOvr>

</xml_diff>

<commit_message>
Deck: short link tinyurl.com/enzymeml2026 and QR code on the end slide, link on the toolkit slide
Co-Authored-By: Claude Fable 5.1 <noreply@anthropic.com>
</commit_message>
<xml_diff>
--- a/slides/workshop.pptx
+++ b/slides/workshop.pptx
@@ -1078,7 +1078,7 @@
           <a:lstStyle/>
           <a:p>
             <a:r>
-              <a:t>11:58 · Close. The repository stays up; questions in the break or by mail.</a:t>
+              <a:t>11:58 · Close. The repository stays up: tinyurl.com/enzymeml2026, or the QR code. Questions in the break or by mail.</a:t>
             </a:r>
           </a:p>
         </p:txBody>
@@ -4461,7 +4461,7 @@
           <a:p>
             <a:r>
               <a:rPr/>
-              <a:t>github.com/haeussma/enzymeml-workshop-modelling-2026 · start with the README</a:t>
+              <a:t>tinyurl.com/enzymeml2026 · github.com/haeussma/enzymeml-workshop-modelling-2026 · start with the README</a:t>
             </a:r>
           </a:p>
         </p:txBody>
@@ -5294,17 +5294,41 @@
           <a:lstStyle/>
           <a:p>
             <a:r>
-              <a:t>github.com/haeussma/enzymeml-workshop-modelling-2026</a:t>
+              <a:t>tinyurl.com/enzymeml2026</a:t>
             </a:r>
           </a:p>
           <a:p>
             <a:pPr lvl="1"/>
             <a:r>
-              <a:t>Max Häußler · University of Freiburg</a:t>
-            </a:r>
-          </a:p>
-        </p:txBody>
-      </p:sp>
+              <a:t>github.com/haeussma/enzymeml-workshop-modelling-2026  ·  Max Häußler · University of Freiburg</a:t>
+            </a:r>
+          </a:p>
+        </p:txBody>
+      </p:sp>
+      <p:pic>
+        <p:nvPicPr>
+          <p:cNvPr id="4" name="Picture 3" descr="qr_repository.png"/>
+          <p:cNvPicPr>
+            <a:picLocks noChangeAspect="1"/>
+          </p:cNvPicPr>
+          <p:nvPr/>
+        </p:nvPicPr>
+        <p:blipFill>
+          <a:blip r:embed="rId3"/>
+          <a:stretch>
+            <a:fillRect/>
+          </a:stretch>
+        </p:blipFill>
+        <p:spPr>
+          <a:xfrm>
+            <a:off x="10058400" y="2148840"/>
+            <a:ext cx="1371600" cy="1371600"/>
+          </a:xfrm>
+          <a:prstGeom prst="rect">
+            <a:avLst/>
+          </a:prstGeom>
+        </p:spPr>
+      </p:pic>
     </p:spTree>
   </p:cSld>
   <p:clrMapOvr>

</xml_diff>

<commit_message>
Deck: no design or data shown up front; task slides pose questions instead of checks
Co-Authored-By: Claude Fable 5.1 <noreply@anthropic.com>
</commit_message>
<xml_diff>
--- a/slides/workshop.pptx
+++ b/slides/workshop.pptx
@@ -21,7 +21,6 @@
     <p:sldId id="269" r:id="rId21"/>
     <p:sldId id="270" r:id="rId22"/>
     <p:sldId id="271" r:id="rId23"/>
-    <p:sldId id="272" r:id="rId24"/>
   </p:sldIdLst>
   <p:sldSz cx="12191695" cy="6858000" type="screen4x3"/>
   <p:notesSz cx="6858000" cy="9144000"/>
@@ -588,7 +587,7 @@
           <a:lstStyle/>
           <a:p>
             <a:r>
-              <a:t>9:14 · 1 min. Two series: ManNAc varied at fixed PEP (13 reactions), PEP varied at fixed ManNAc (11 reactions); six injections each, 144 chromatograms; five standards with 1–5 mM Neu5Ac that also contain the substrates, no enzyme. Participants do not get the raw traces: the instrument software exported a peak table per injection, and that is the input of task 1. Initial concentrations are in conditions.csv. Where Neu5Ac elutes is in the task card and comes up in the demo.</a:t>
+              <a:t>9:15 · 1 min. Task 1 with Chromhandler, task 2 with Catalax. Live demo first, then you work in pairs; the checks in the task card decide when you are done. Timing: demo 9:15, hands-on 9:30, break 10:15–10:30, demo 10:30, hands-on 10:40. At 11:25 we collect everybody's kcat and Km on one slide or the whiteboard, wrap-up 11:50.</a:t>
             </a:r>
           </a:p>
         </p:txBody>
@@ -658,7 +657,7 @@
           <a:lstStyle/>
           <a:p>
             <a:r>
-              <a:t>9:15 · 1 min. Task 1 with Chromhandler, task 2 with Catalax. Live demo first, then you work in pairs; the checks in the task card decide when you are done. Timing: demo 9:15, hands-on 9:30, break 10:15–10:30, demo 10:30, hands-on 10:40. At 11:25 we collect everybody's kcat and Km on one slide or the whiteboard, wrap-up 11:50.</a:t>
+              <a:t>9:16 · 3 min. README first. Two ways. With a language model: any chat model, free or by subscription (ChatGPT, Claude, Gemini, …); paste the tool card, then the task card; run the code it writes; paste errors back; the checks decide. Without writing code: the Colab link opens a prepared notebook with the tools installed and the data loaded; run it cell by cell, change a window, a prior, a series; ask the model inside Colab to explain any cell. notebooks/ are the reference solutions, open to everyone; checkpoints/ holds the result of task 1. Locally: uv sync.</a:t>
             </a:r>
           </a:p>
         </p:txBody>
@@ -728,7 +727,7 @@
           <a:lstStyle/>
           <a:p>
             <a:r>
-              <a:t>9:16 · 3 min. README first. Two ways. With a language model: any chat model, free or by subscription (ChatGPT, Claude, Gemini, …); paste the tool card, then the task card; run the code it writes; paste errors back; the checks decide. Without writing code: the Colab link opens a prepared notebook with the tools installed and the data loaded; run it cell by cell, change a window, a prior, a series; ask the model inside Colab to explain any cell. notebooks/ are the reference solutions, open to everyone; checkpoints/ holds the result of task 1. Locally: uv sync.</a:t>
+              <a:t>9:15 · Live demo 15 min, then hands-on 9:30–10:15. Demo: paste chromhandler.md, then the task card, then 'Let's start with task 1'. Let the assistant read the data and answer the first question; show the peak plot. Accept the calibration explicitly ('my decision, not the assistant's'). Deliberate mistake: when asked for the reaction window, say 'the same as the standards'; chromhandler warns 'No peaks found for Neu5Ac', the document has no Neu5Ac values. Say why (the shift on the peak plot), correct it, continue. The questions on the slide are what every pair answers; we compare at 11:25.</a:t>
             </a:r>
           </a:p>
         </p:txBody>
@@ -798,7 +797,7 @@
           <a:lstStyle/>
           <a:p>
             <a:r>
-              <a:t>9:15 · Live demo 15 min, then hands-on 9:30–10:15. Demo: paste chromhandler.md, then the task card, then 'Let's start with task 1'. Show the count (24 reactions, 5 standards) and the peak plot. Accept the calibration explicitly ('my decision, not the assistant's'). Deliberate mistake: when asked for the reaction window, say 'the same as the standards, 11.41 ± 0.05'; chromhandler warns 'No peaks found for Neu5Ac in 6 measurement(s)' per reaction, the document has 0 Neu5Ac values, the check '6 values per reaction' fails. Say why (the shift on the peak plot), correct to 10.05 ± 0.20, continue. Export, run the checks, show this plot.</a:t>
+              <a:t>10:30 · Live demo 10 min, then hands-on 10:40–11:25. Paste catalax.md, then the task card. enable_x64 first. Only Neu5Ac has data; in Catalax 0.5.5 every state stays observable and the unmeasured ones get NaN arrays (observable=False breaks the sampler in this version). The priors and the sampler settings are in the card; they are decisions, say so. Show the posterior table, the trace and the fit plot. Those who did not finish task 1 start from checkpoints/neus_enzymeml.json.</a:t>
             </a:r>
           </a:p>
         </p:txBody>
@@ -868,7 +867,7 @@
           <a:lstStyle/>
           <a:p>
             <a:r>
-              <a:t>10:30 · Live demo 10 min, then hands-on 10:40–11:25. Paste catalax.md, then the task card. enable_x64 first. Only Neu5Ac has data; in Catalax 0.5.5 every state stays observable and the unmeasured ones get NaN arrays (observable=False breaks the sampler in this version). The priors and the sampler settings are in the card; they are decisions, say so. Show the posterior table, the trace and the fit plot. Those who did not finish task 1 start from checkpoints/neus_enzymeml.json.</a:t>
+              <a:t>11:25 · 25 min. First collect everybody's kcat, Km_ManNAc, Km_PEP: how much do they differ and why (windows, priors, reactions used)? Then the misfit: one shared kcat over-predicts the ManNAc series and under-predicts the PEP series; the series were measured on different days and differ by roughly 25 % in activity. Ask: a per-day activity factor, a new experiment, both? Which decisions did the assistant try to make for you, and which did you take back?</a:t>
             </a:r>
           </a:p>
         </p:txBody>
@@ -938,7 +937,7 @@
           <a:lstStyle/>
           <a:p>
             <a:r>
-              <a:t>11:25 · 25 min. First collect everybody's kcat, Km_ManNAc, Km_PEP: how much do they differ and why (windows, priors, reactions used)? Then the misfit: one shared kcat over-predicts the ManNAc series and under-predicts the PEP series; the series were measured on different days and differ by roughly 25 % in activity. Ask: a per-day activity factor, a new experiment, both? Which decisions did the assistant try to make for you, and which did you take back?</a:t>
+              <a:t>11:50 · 10 min. Take-home and feedback round. Ask explicitly what did not work: that is what we need to improve the cards. The cards are reusable as SKILL.md / AGENTS.md for coding agents.</a:t>
             </a:r>
           </a:p>
         </p:txBody>
@@ -1008,76 +1007,6 @@
           <a:lstStyle/>
           <a:p>
             <a:r>
-              <a:t>11:50 · 10 min. Take-home and feedback round. Ask explicitly what did not work: that is what we need to improve the cards. The cards are reusable as SKILL.md / AGENTS.md for coding agents.</a:t>
-            </a:r>
-          </a:p>
-        </p:txBody>
-      </p:sp>
-      <p:sp>
-        <p:nvSpPr>
-          <p:cNvPr id="4" name="Slide Number Placeholder 3"/>
-          <p:cNvSpPr>
-            <a:spLocks noGrp="1"/>
-          </p:cNvSpPr>
-          <p:nvPr>
-            <p:ph type="sldNum" idx="5" sz="quarter"/>
-          </p:nvPr>
-        </p:nvSpPr>
-        <p:spPr/>
-      </p:sp>
-    </p:spTree>
-  </p:cSld>
-  <p:clrMapOvr>
-    <a:masterClrMapping/>
-  </p:clrMapOvr>
-</p:notes>
-</file>
-
-<file path=ppt/notesSlides/notesSlide17.xml><?xml version="1.0" encoding="utf-8"?>
-<p:notes xmlns:a="http://schemas.openxmlformats.org/drawingml/2006/main" xmlns:p="http://schemas.openxmlformats.org/presentationml/2006/main" xmlns:r="http://schemas.openxmlformats.org/officeDocument/2006/relationships">
-  <p:cSld>
-    <p:spTree>
-      <p:nvGrpSpPr>
-        <p:cNvPr id="1" name=""/>
-        <p:cNvGrpSpPr/>
-        <p:nvPr/>
-      </p:nvGrpSpPr>
-      <p:grpSpPr>
-        <a:xfrm>
-          <a:off x="0" y="0"/>
-          <a:ext cx="0" cy="0"/>
-          <a:chOff x="0" y="0"/>
-          <a:chExt cx="0" cy="0"/>
-        </a:xfrm>
-      </p:grpSpPr>
-      <p:sp>
-        <p:nvSpPr>
-          <p:cNvPr id="2" name="Slide Image Placeholder 1"/>
-          <p:cNvSpPr>
-            <a:spLocks noGrp="1"/>
-          </p:cNvSpPr>
-          <p:nvPr>
-            <p:ph type="sldImg" idx="2"/>
-          </p:nvPr>
-        </p:nvSpPr>
-        <p:spPr/>
-      </p:sp>
-      <p:sp>
-        <p:nvSpPr>
-          <p:cNvPr id="3" name="Notes Placeholder 2"/>
-          <p:cNvSpPr>
-            <a:spLocks noGrp="1"/>
-          </p:cNvSpPr>
-          <p:nvPr>
-            <p:ph type="body" idx="3" sz="quarter"/>
-          </p:nvPr>
-        </p:nvSpPr>
-        <p:spPr/>
-        <p:txBody>
-          <a:bodyPr/>
-          <a:lstStyle/>
-          <a:p>
-            <a:r>
               <a:t>11:58 · Close. The repository stays up: tinyurl.com/enzymeml2026, or the QR code. Questions in the break or by mail.</a:t>
             </a:r>
           </a:p>
@@ -1638,7 +1567,7 @@
           <a:lstStyle/>
           <a:p>
             <a:r>
-              <a:t>9:12 · 2 min. Neu5Ac synthase condenses ManNAc and PEP to Neu5Ac and phosphate (metal cofactor, water). HPLC-PDA at 215 nm. Two series: ManNAc varied at fixed PEP (13 reactions), PEP varied at fixed ManNAc (11 reactions); six injections each; five standards with 1–5 mM. Only the product is quantified; the substrates enter the model as their known initial values.</a:t>
+              <a:t>9:12 · 2 min. Neu5Ac synthase condenses ManNAc and PEP to Neu5Ac and phosphate (metal cofactor, water). HPLC-PDA at 215 nm; the instrument software exported one peak table per injection. Only the product is quantified; the substrates enter the model as their known initial values. Do not explain the design or the numbers: how many reactions there are, what was varied and what the data look like is what the participants find out with their assistant in task 1.</a:t>
             </a:r>
           </a:p>
         </p:txBody>
@@ -3817,7 +3746,7 @@
           <a:p>
             <a:r>
               <a:rPr/>
-              <a:t>Two series, one substrate varied at a time</a:t>
+              <a:t>What we do today</a:t>
             </a:r>
           </a:p>
         </p:txBody>
@@ -3832,31 +3761,70 @@
             <p:ph idx="1"/>
           </p:nvPr>
         </p:nvSpPr>
-        <p:spPr>
-          <a:xfrm>
-            <a:off x="822960" y="3520440"/>
-            <a:ext cx="10545775" cy="2240279"/>
-          </a:xfrm>
-        </p:spPr>
+        <p:spPr/>
         <p:txBody>
           <a:bodyPr/>
           <a:lstStyle/>
           <a:p>
             <a:r>
+              <a:rPr b="1"/>
+              <a:t>Task 1: </a:t>
+            </a:r>
+            <a:r>
               <a:rPr/>
-              <a:t>24 reactions sampled six times: 144 chromatograms</a:t>
-            </a:r>
-          </a:p>
-          <a:p>
+              <a:t>from the peak tables to an EnzymeML document (Chromhandler)</a:t>
+            </a:r>
+          </a:p>
+          <a:p>
+            <a:r>
+              <a:rPr b="1"/>
+              <a:t>Task 2: </a:t>
+            </a:r>
             <a:r>
               <a:rPr/>
-              <a:t>Per injection you get the instrument's peak table, not the raw trace</a:t>
-            </a:r>
-          </a:p>
-          <a:p>
+              <a:t>from the EnzymeML document to </a:t>
+            </a:r>
+            <a:r>
+              <a:rPr i="1"/>
+              <a:t>k</a:t>
+            </a:r>
+            <a:r>
+              <a:rPr baseline="-25000"/>
+              <a:t>cat</a:t>
+            </a:r>
             <a:r>
               <a:rPr/>
-              <a:t>Initial concentrations are in conditions.csv</a:t>
+              <a:t> and </a:t>
+            </a:r>
+            <a:r>
+              <a:rPr i="1"/>
+              <a:t>K</a:t>
+            </a:r>
+            <a:r>
+              <a:rPr i="1" baseline="-25000"/>
+              <a:t>M</a:t>
+            </a:r>
+            <a:r>
+              <a:rPr/>
+              <a:t> by Bayesian inference (Catalax)</a:t>
+            </a:r>
+          </a:p>
+          <a:p>
+            <a:r>
+              <a:rPr/>
+              <a:t>A live demo of each task first, then you work in pairs</a:t>
+            </a:r>
+          </a:p>
+          <a:p>
+            <a:r>
+              <a:rPr/>
+              <a:t>The checks in the task card say when you are done</a:t>
+            </a:r>
+          </a:p>
+          <a:p>
+            <a:r>
+              <a:rPr/>
+              <a:t>At the end we compare everybody's parameters and discuss</a:t>
             </a:r>
           </a:p>
         </p:txBody>
@@ -3878,250 +3846,11 @@
           <a:p>
             <a:r>
               <a:rPr/>
-              <a:t>The dataset</a:t>
-            </a:r>
-          </a:p>
-        </p:txBody>
-      </p:sp>
-      <p:graphicFrame>
-        <p:nvGraphicFramePr>
-          <p:cNvPr id="7" name="Table 6"/>
-          <p:cNvGraphicFramePr>
-            <a:graphicFrameLocks noGrp="1"/>
-          </p:cNvGraphicFramePr>
-          <p:nvPr/>
-        </p:nvGraphicFramePr>
-        <p:xfrm>
-          <a:off x="822960" y="1645920"/>
-          <a:ext cx="10545775" cy="1536192"/>
-        </p:xfrm>
-        <a:graphic>
-          <a:graphicData uri="http://schemas.openxmlformats.org/drawingml/2006/table">
-            <a:tbl>
-              <a:tblPr firstRow="1">
-                <a:tableStyleId>{9D7B26C5-4107-4FEC-AEDC-1716B250EE53}</a:tableStyleId>
-              </a:tblPr>
-              <a:tblGrid>
-                <a:gridCol w="2468880"/>
-                <a:gridCol w="1554480"/>
-                <a:gridCol w="3566160"/>
-                <a:gridCol w="2956255"/>
-              </a:tblGrid>
-              <a:tr h="384048">
-                <a:tc>
-                  <a:txBody>
-                    <a:bodyPr/>
-                    <a:lstStyle/>
-                    <a:p/>
-                  </a:txBody>
-                  <a:tcPr/>
-                </a:tc>
-                <a:tc>
-                  <a:txBody>
-                    <a:bodyPr/>
-                    <a:lstStyle/>
-                    <a:p>
-                      <a:r>
-                        <a:rPr b="1" sz="1400"/>
-                        <a:t>Samples</a:t>
-                      </a:r>
-                    </a:p>
-                  </a:txBody>
-                  <a:tcPr/>
-                </a:tc>
-                <a:tc>
-                  <a:txBody>
-                    <a:bodyPr/>
-                    <a:lstStyle/>
-                    <a:p>
-                      <a:r>
-                        <a:rPr b="1" sz="1400"/>
-                        <a:t>What varies</a:t>
-                      </a:r>
-                    </a:p>
-                  </a:txBody>
-                  <a:tcPr/>
-                </a:tc>
-                <a:tc>
-                  <a:txBody>
-                    <a:bodyPr/>
-                    <a:lstStyle/>
-                    <a:p>
-                      <a:r>
-                        <a:rPr b="1" sz="1400"/>
-                        <a:t>What is fixed</a:t>
-                      </a:r>
-                    </a:p>
-                  </a:txBody>
-                  <a:tcPr/>
-                </a:tc>
-              </a:tr>
-              <a:tr h="384048">
-                <a:tc>
-                  <a:txBody>
-                    <a:bodyPr/>
-                    <a:lstStyle/>
-                    <a:p>
-                      <a:r>
-                        <a:rPr b="1" sz="1400"/>
-                        <a:t>ManNAc series</a:t>
-                      </a:r>
-                    </a:p>
-                  </a:txBody>
-                  <a:tcPr/>
-                </a:tc>
-                <a:tc>
-                  <a:txBody>
-                    <a:bodyPr/>
-                    <a:lstStyle/>
-                    <a:p>
-                      <a:r>
-                        <a:rPr b="0" sz="1400"/>
-                        <a:t>13 reactions</a:t>
-                      </a:r>
-                    </a:p>
-                  </a:txBody>
-                  <a:tcPr/>
-                </a:tc>
-                <a:tc>
-                  <a:txBody>
-                    <a:bodyPr/>
-                    <a:lstStyle/>
-                    <a:p>
-                      <a:r>
-                        <a:rPr b="0" sz="1400"/>
-                        <a:t>ManNAc 0–100 mM</a:t>
-                      </a:r>
-                    </a:p>
-                  </a:txBody>
-                  <a:tcPr/>
-                </a:tc>
-                <a:tc>
-                  <a:txBody>
-                    <a:bodyPr/>
-                    <a:lstStyle/>
-                    <a:p>
-                      <a:r>
-                        <a:rPr b="0" sz="1400"/>
-                        <a:t>PEP 20 mM</a:t>
-                      </a:r>
-                    </a:p>
-                  </a:txBody>
-                  <a:tcPr/>
-                </a:tc>
-              </a:tr>
-              <a:tr h="384048">
-                <a:tc>
-                  <a:txBody>
-                    <a:bodyPr/>
-                    <a:lstStyle/>
-                    <a:p>
-                      <a:r>
-                        <a:rPr b="1" sz="1400"/>
-                        <a:t>PEP series</a:t>
-                      </a:r>
-                    </a:p>
-                  </a:txBody>
-                  <a:tcPr/>
-                </a:tc>
-                <a:tc>
-                  <a:txBody>
-                    <a:bodyPr/>
-                    <a:lstStyle/>
-                    <a:p>
-                      <a:r>
-                        <a:rPr b="0" sz="1400"/>
-                        <a:t>11 reactions</a:t>
-                      </a:r>
-                    </a:p>
-                  </a:txBody>
-                  <a:tcPr/>
-                </a:tc>
-                <a:tc>
-                  <a:txBody>
-                    <a:bodyPr/>
-                    <a:lstStyle/>
-                    <a:p>
-                      <a:r>
-                        <a:rPr b="0" sz="1400"/>
-                        <a:t>PEP 0–20 mM</a:t>
-                      </a:r>
-                    </a:p>
-                  </a:txBody>
-                  <a:tcPr/>
-                </a:tc>
-                <a:tc>
-                  <a:txBody>
-                    <a:bodyPr/>
-                    <a:lstStyle/>
-                    <a:p>
-                      <a:r>
-                        <a:rPr b="0" sz="1400"/>
-                        <a:t>ManNAc 50 mM</a:t>
-                      </a:r>
-                    </a:p>
-                  </a:txBody>
-                  <a:tcPr/>
-                </a:tc>
-              </a:tr>
-              <a:tr h="384048">
-                <a:tc>
-                  <a:txBody>
-                    <a:bodyPr/>
-                    <a:lstStyle/>
-                    <a:p>
-                      <a:r>
-                        <a:rPr b="1" sz="1400"/>
-                        <a:t>Calibration standards</a:t>
-                      </a:r>
-                    </a:p>
-                  </a:txBody>
-                  <a:tcPr/>
-                </a:tc>
-                <a:tc>
-                  <a:txBody>
-                    <a:bodyPr/>
-                    <a:lstStyle/>
-                    <a:p>
-                      <a:r>
-                        <a:rPr b="0" sz="1400"/>
-                        <a:t>5 standards</a:t>
-                      </a:r>
-                    </a:p>
-                  </a:txBody>
-                  <a:tcPr/>
-                </a:tc>
-                <a:tc>
-                  <a:txBody>
-                    <a:bodyPr/>
-                    <a:lstStyle/>
-                    <a:p>
-                      <a:r>
-                        <a:rPr b="0" sz="1400"/>
-                        <a:t>Neu5Ac 1–5 mM, with ManNAc and PEP</a:t>
-                      </a:r>
-                    </a:p>
-                  </a:txBody>
-                  <a:tcPr/>
-                </a:tc>
-                <a:tc>
-                  <a:txBody>
-                    <a:bodyPr/>
-                    <a:lstStyle/>
-                    <a:p>
-                      <a:r>
-                        <a:rPr b="0" sz="1400"/>
-                        <a:t>no enzyme</a:t>
-                      </a:r>
-                    </a:p>
-                  </a:txBody>
-                  <a:tcPr/>
-                </a:tc>
-              </a:tr>
-            </a:tbl>
-          </a:graphicData>
-        </a:graphic>
-      </p:graphicFrame>
+              <a:t>Today</a:t>
+            </a:r>
+          </a:p>
+        </p:txBody>
+      </p:sp>
     </p:spTree>
   </p:cSld>
   <p:clrMapOvr>
@@ -4157,7 +3886,7 @@
           <a:p>
             <a:r>
               <a:rPr/>
-              <a:t>What we do today</a:t>
+              <a:t>One repository, two ways to work</a:t>
             </a:r>
           </a:p>
         </p:txBody>
@@ -4169,7 +3898,7 @@
             <a:spLocks noGrp="1"/>
           </p:cNvSpPr>
           <p:nvPr>
-            <p:ph idx="1"/>
+            <p:ph idx="1" sz="half"/>
           </p:nvPr>
         </p:nvSpPr>
         <p:spPr/>
@@ -4177,72 +3906,114 @@
           <a:bodyPr/>
           <a:lstStyle/>
           <a:p>
+            <a:pPr marL="0" indent="0">
+              <a:buNone/>
+            </a:pPr>
             <a:r>
               <a:rPr b="1"/>
-              <a:t>Task 1: </a:t>
+              <a:t>With a language model</a:t>
+            </a:r>
+          </a:p>
+          <a:p>
+            <a:r>
+              <a:rPr b="1"/>
+              <a:t>Any chat model, </a:t>
             </a:r>
             <a:r>
               <a:rPr/>
-              <a:t>from the peak tables to an EnzymeML document (Chromhandler)</a:t>
+              <a:t>free or by subscription: ChatGPT, Claude, Gemini, …</a:t>
             </a:r>
           </a:p>
           <a:p>
             <a:r>
               <a:rPr b="1"/>
-              <a:t>Task 2: </a:t>
+              <a:t>Paste </a:t>
             </a:r>
             <a:r>
               <a:rPr/>
-              <a:t>from the EnzymeML document to </a:t>
-            </a:r>
-            <a:r>
-              <a:rPr i="1"/>
-              <a:t>k</a:t>
-            </a:r>
-            <a:r>
-              <a:rPr baseline="-25000"/>
-              <a:t>cat</a:t>
+              <a:t>the tool card and the task card; run the code, paste errors back</a:t>
+            </a:r>
+          </a:p>
+          <a:p>
+            <a:r>
+              <a:rPr b="1"/>
+              <a:t>The checks </a:t>
             </a:r>
             <a:r>
               <a:rPr/>
-              <a:t> and </a:t>
-            </a:r>
-            <a:r>
-              <a:rPr i="1"/>
-              <a:t>K</a:t>
-            </a:r>
-            <a:r>
-              <a:rPr i="1" baseline="-25000"/>
-              <a:t>M</a:t>
+              <a:t>decide when you are done</a:t>
+            </a:r>
+          </a:p>
+          <a:p>
+            <a:r>
+              <a:rPr b="1"/>
+              <a:t>notebooks/ </a:t>
             </a:r>
             <a:r>
               <a:rPr/>
-              <a:t> by Bayesian inference (Catalax)</a:t>
-            </a:r>
-          </a:p>
-          <a:p>
+              <a:t>are the reference solutions, checkpoints/ the result of task 1</a:t>
+            </a:r>
+          </a:p>
+        </p:txBody>
+      </p:sp>
+      <p:sp>
+        <p:nvSpPr>
+          <p:cNvPr id="4" name="Content Placeholder 3"/>
+          <p:cNvSpPr>
+            <a:spLocks noGrp="1"/>
+          </p:cNvSpPr>
+          <p:nvPr>
+            <p:ph idx="2" sz="half"/>
+          </p:nvPr>
+        </p:nvSpPr>
+        <p:spPr/>
+        <p:txBody>
+          <a:bodyPr/>
+          <a:lstStyle/>
+          <a:p>
+            <a:pPr marL="0" indent="0">
+              <a:buNone/>
+            </a:pPr>
+            <a:r>
+              <a:rPr b="1"/>
+              <a:t>Without writing code</a:t>
+            </a:r>
+          </a:p>
+          <a:p>
+            <a:r>
+              <a:rPr b="1"/>
+              <a:t>Open the Colab link: </a:t>
+            </a:r>
             <a:r>
               <a:rPr/>
-              <a:t>A live demo of each task first, then you work in pairs</a:t>
-            </a:r>
-          </a:p>
-          <a:p>
+              <a:t>a prepared notebook, tools installed, data loaded</a:t>
+            </a:r>
+          </a:p>
+          <a:p>
+            <a:r>
+              <a:rPr b="1"/>
+              <a:t>Run it cell by cell; </a:t>
+            </a:r>
             <a:r>
               <a:rPr/>
-              <a:t>The checks in the task card say when you are done</a:t>
-            </a:r>
-          </a:p>
-          <a:p>
+              <a:t>change a window, a prior, a series</a:t>
+            </a:r>
+          </a:p>
+          <a:p>
+            <a:r>
+              <a:rPr b="1"/>
+              <a:t>Ask the model in Colab </a:t>
+            </a:r>
             <a:r>
               <a:rPr/>
-              <a:t>At the end we compare everybody's parameters and discuss</a:t>
-            </a:r>
-          </a:p>
-        </p:txBody>
-      </p:sp>
-      <p:sp>
-        <p:nvSpPr>
-          <p:cNvPr id="4" name="Text Placeholder 3"/>
+              <a:t>to explain any cell</a:t>
+            </a:r>
+          </a:p>
+        </p:txBody>
+      </p:sp>
+      <p:sp>
+        <p:nvSpPr>
+          <p:cNvPr id="5" name="Text Placeholder 4"/>
           <p:cNvSpPr>
             <a:spLocks noGrp="1"/>
           </p:cNvSpPr>
@@ -4257,7 +4028,29 @@
           <a:p>
             <a:r>
               <a:rPr/>
-              <a:t>Today</a:t>
+              <a:t>Toolkit</a:t>
+            </a:r>
+          </a:p>
+        </p:txBody>
+      </p:sp>
+      <p:sp>
+        <p:nvSpPr>
+          <p:cNvPr id="6" name="Text Placeholder 5"/>
+          <p:cNvSpPr>
+            <a:spLocks noGrp="1"/>
+          </p:cNvSpPr>
+          <p:nvPr>
+            <p:ph type="body" idx="15" sz="quarter"/>
+          </p:nvPr>
+        </p:nvSpPr>
+        <p:spPr/>
+        <p:txBody>
+          <a:bodyPr/>
+          <a:lstStyle/>
+          <a:p>
+            <a:r>
+              <a:rPr/>
+              <a:t>tinyurl.com/enzymeml2026 · start with the README</a:t>
             </a:r>
           </a:p>
         </p:txBody>
@@ -4297,7 +4090,7 @@
           <a:p>
             <a:r>
               <a:rPr/>
-              <a:t>One repository, two ways to work</a:t>
+              <a:t>Task 1: from chromatograms to EnzymeML</a:t>
             </a:r>
           </a:p>
         </p:txBody>
@@ -4309,72 +4102,76 @@
             <a:spLocks noGrp="1"/>
           </p:cNvSpPr>
           <p:nvPr>
-            <p:ph idx="1" sz="half"/>
+            <p:ph idx="1"/>
           </p:nvPr>
         </p:nvSpPr>
         <p:spPr/>
         <p:txBody>
           <a:bodyPr/>
           <a:lstStyle/>
+          <a:p>
+            <a:r>
+              <a:rPr b="1"/>
+              <a:t>Goal: </a:t>
+            </a:r>
+            <a:r>
+              <a:rPr/>
+              <a:t>an EnzymeML document with the calibrated Neu5Ac time course of every reaction</a:t>
+            </a:r>
+          </a:p>
+          <a:p>
+            <a:r>
+              <a:rPr b="1"/>
+              <a:t>Your decision: </a:t>
+            </a:r>
+            <a:r>
+              <a:rPr/>
+              <a:t>the Neu5Ac retention window, different in standards and reactions</a:t>
+            </a:r>
+          </a:p>
           <a:p>
             <a:pPr marL="0" indent="0">
               <a:buNone/>
             </a:pPr>
             <a:r>
               <a:rPr b="1"/>
-              <a:t>With a language model</a:t>
-            </a:r>
-          </a:p>
-          <a:p>
-            <a:r>
-              <a:rPr b="1"/>
-              <a:t>Any chat model, </a:t>
-            </a:r>
+              <a:t>Questions to answer</a:t>
+            </a:r>
+          </a:p>
+          <a:p>
             <a:r>
               <a:rPr/>
-              <a:t>free or by subscription: ChatGPT, Claude, Gemini, …</a:t>
-            </a:r>
-          </a:p>
-          <a:p>
-            <a:r>
-              <a:rPr b="1"/>
-              <a:t>Paste </a:t>
-            </a:r>
+              <a:t>How many reactions and standards are in the data, and what was varied?</a:t>
+            </a:r>
+          </a:p>
+          <a:p>
             <a:r>
               <a:rPr/>
-              <a:t>the tool card and the task card; run the code, paste errors back</a:t>
-            </a:r>
-          </a:p>
-          <a:p>
-            <a:r>
-              <a:rPr b="1"/>
-              <a:t>The checks </a:t>
-            </a:r>
+              <a:t>Where does Neu5Ac elute, in the standards and in the reactions?</a:t>
+            </a:r>
+          </a:p>
+          <a:p>
             <a:r>
               <a:rPr/>
-              <a:t>decide when you are done</a:t>
-            </a:r>
-          </a:p>
-          <a:p>
-            <a:r>
-              <a:rPr b="1"/>
-              <a:t>notebooks/ </a:t>
-            </a:r>
+              <a:t>What is the calibration slope, and how well does the line fit?</a:t>
+            </a:r>
+          </a:p>
+          <a:p>
             <a:r>
               <a:rPr/>
-              <a:t>are the reference solutions, checkpoints/ the result of task 1</a:t>
-            </a:r>
-          </a:p>
-        </p:txBody>
-      </p:sp>
-      <p:sp>
-        <p:nvSpPr>
-          <p:cNvPr id="4" name="Content Placeholder 3"/>
-          <p:cNvSpPr>
-            <a:spLocks noGrp="1"/>
-          </p:cNvSpPr>
-          <p:nvPr>
-            <p:ph idx="2" sz="half"/>
+              <a:t>Does every reaction have all its time points, and which reactions form product?</a:t>
+            </a:r>
+          </a:p>
+        </p:txBody>
+      </p:sp>
+      <p:sp>
+        <p:nvSpPr>
+          <p:cNvPr id="4" name="Text Placeholder 3"/>
+          <p:cNvSpPr>
+            <a:spLocks noGrp="1"/>
+          </p:cNvSpPr>
+          <p:nvPr>
+            <p:ph type="body" idx="13" sz="quarter"/>
           </p:nvPr>
         </p:nvSpPr>
         <p:spPr/>
@@ -4382,86 +4179,9 @@
           <a:bodyPr/>
           <a:lstStyle/>
           <a:p>
-            <a:pPr marL="0" indent="0">
-              <a:buNone/>
-            </a:pPr>
-            <a:r>
-              <a:rPr b="1"/>
-              <a:t>Without writing code</a:t>
-            </a:r>
-          </a:p>
-          <a:p>
-            <a:r>
-              <a:rPr b="1"/>
-              <a:t>Open the Colab link: </a:t>
-            </a:r>
             <a:r>
               <a:rPr/>
-              <a:t>a prepared notebook, tools installed, data loaded</a:t>
-            </a:r>
-          </a:p>
-          <a:p>
-            <a:r>
-              <a:rPr b="1"/>
-              <a:t>Run it cell by cell; </a:t>
-            </a:r>
-            <a:r>
-              <a:rPr/>
-              <a:t>change a window, a prior, a series</a:t>
-            </a:r>
-          </a:p>
-          <a:p>
-            <a:r>
-              <a:rPr b="1"/>
-              <a:t>Ask the model in Colab </a:t>
-            </a:r>
-            <a:r>
-              <a:rPr/>
-              <a:t>to explain any cell</a:t>
-            </a:r>
-          </a:p>
-        </p:txBody>
-      </p:sp>
-      <p:sp>
-        <p:nvSpPr>
-          <p:cNvPr id="5" name="Text Placeholder 4"/>
-          <p:cNvSpPr>
-            <a:spLocks noGrp="1"/>
-          </p:cNvSpPr>
-          <p:nvPr>
-            <p:ph type="body" idx="13" sz="quarter"/>
-          </p:nvPr>
-        </p:nvSpPr>
-        <p:spPr/>
-        <p:txBody>
-          <a:bodyPr/>
-          <a:lstStyle/>
-          <a:p>
-            <a:r>
-              <a:rPr/>
-              <a:t>Toolkit</a:t>
-            </a:r>
-          </a:p>
-        </p:txBody>
-      </p:sp>
-      <p:sp>
-        <p:nvSpPr>
-          <p:cNvPr id="6" name="Text Placeholder 5"/>
-          <p:cNvSpPr>
-            <a:spLocks noGrp="1"/>
-          </p:cNvSpPr>
-          <p:nvPr>
-            <p:ph type="body" idx="15" sz="quarter"/>
-          </p:nvPr>
-        </p:nvSpPr>
-        <p:spPr/>
-        <p:txBody>
-          <a:bodyPr/>
-          <a:lstStyle/>
-          <a:p>
-            <a:r>
-              <a:rPr/>
-              <a:t>tinyurl.com/enzymeml2026 · start with the README</a:t>
+              <a:t>Task 1</a:t>
             </a:r>
           </a:p>
         </p:txBody>
@@ -4501,27 +4221,22 @@
           <a:p>
             <a:r>
               <a:rPr/>
-              <a:t>Task 1: from chromatograms to EnzymeML</a:t>
-            </a:r>
-          </a:p>
-        </p:txBody>
-      </p:sp>
-      <p:sp>
-        <p:nvSpPr>
-          <p:cNvPr id="4" name="Text Placeholder 3"/>
-          <p:cNvSpPr>
-            <a:spLocks noGrp="1"/>
-          </p:cNvSpPr>
-          <p:nvPr>
-            <p:ph type="body" idx="2" sz="half"/>
-          </p:nvPr>
-        </p:nvSpPr>
-        <p:spPr>
-          <a:xfrm>
-            <a:off x="822960" y="4663440"/>
-            <a:ext cx="10545775" cy="1097280"/>
-          </a:xfrm>
-        </p:spPr>
+              <a:t>Task 2: kinetic parameters by Bayesian inference</a:t>
+            </a:r>
+          </a:p>
+        </p:txBody>
+      </p:sp>
+      <p:sp>
+        <p:nvSpPr>
+          <p:cNvPr id="3" name="Content Placeholder 2"/>
+          <p:cNvSpPr>
+            <a:spLocks noGrp="1"/>
+          </p:cNvSpPr>
+          <p:nvPr>
+            <p:ph idx="1"/>
+          </p:nvPr>
+        </p:nvSpPr>
+        <p:spPr/>
         <p:txBody>
           <a:bodyPr/>
           <a:lstStyle/>
@@ -4532,37 +4247,170 @@
             </a:r>
             <a:r>
               <a:rPr/>
-              <a:t>an EnzymeML document with 24 calibrated Neu5Ac time courses</a:t>
+              <a:t>posterior distributions of </a:t>
+            </a:r>
+            <a:r>
+              <a:rPr i="1"/>
+              <a:t>k</a:t>
+            </a:r>
+            <a:r>
+              <a:rPr baseline="-25000"/>
+              <a:t>cat</a:t>
+            </a:r>
+            <a:r>
+              <a:rPr/>
+              <a:t>, </a:t>
+            </a:r>
+            <a:r>
+              <a:rPr i="1"/>
+              <a:t>K</a:t>
+            </a:r>
+            <a:r>
+              <a:rPr i="1" baseline="-25000"/>
+              <a:t>M</a:t>
+            </a:r>
+            <a:r>
+              <a:rPr baseline="30000"/>
+              <a:t>ManNAc</a:t>
+            </a:r>
+            <a:r>
+              <a:rPr/>
+              <a:t> and </a:t>
+            </a:r>
+            <a:r>
+              <a:rPr i="1"/>
+              <a:t>K</a:t>
+            </a:r>
+            <a:r>
+              <a:rPr i="1" baseline="-25000"/>
+              <a:t>M</a:t>
+            </a:r>
+            <a:r>
+              <a:rPr baseline="30000"/>
+              <a:t>PEP</a:t>
+            </a:r>
+            <a:r>
+              <a:rPr/>
+              <a:t>, with a fit plot</a:t>
             </a:r>
           </a:p>
           <a:p>
             <a:r>
               <a:rPr b="1"/>
-              <a:t>Your decision: </a:t>
+              <a:t>Model: </a:t>
             </a:r>
             <a:r>
               <a:rPr/>
-              <a:t>the Neu5Ac retention window, different in standards and reactions</a:t>
+              <a:t>the enzyme is in the rate law, only Neu5Ac is measured, the metal cofactor is left out (a simplification)</a:t>
             </a:r>
           </a:p>
           <a:p>
             <a:r>
               <a:rPr b="1"/>
-              <a:t>Checks: </a:t>
+              <a:t>Your decisions: </a:t>
             </a:r>
             <a:r>
               <a:rPr/>
-              <a:t>slope ≈ 239 000 area per mM, R² ≥ 0.99; 24 measurements, six increasing time points each</a:t>
-            </a:r>
-          </a:p>
-          <a:p>
+              <a:t>the priors, the assumed measurement noise, the sampler settings</a:t>
+            </a:r>
+          </a:p>
+          <a:p>
+            <a:pPr marL="0" indent="0">
+              <a:buNone/>
+            </a:pPr>
             <a:r>
               <a:rPr b="1"/>
-              <a:t>Live demo: </a:t>
-            </a:r>
+              <a:t>Questions to answer</a:t>
+            </a:r>
+          </a:p>
+          <a:p>
             <a:r>
               <a:rPr/>
-              <a:t>one deliberate mistake, the standards window used for the reactions</a:t>
+              <a:t>What are </a:t>
+            </a:r>
+            <a:r>
+              <a:rPr i="1"/>
+              <a:t>k</a:t>
+            </a:r>
+            <a:r>
+              <a:rPr baseline="-25000"/>
+              <a:t>cat</a:t>
+            </a:r>
+            <a:r>
+              <a:rPr/>
+              <a:t>, </a:t>
+            </a:r>
+            <a:r>
+              <a:rPr i="1"/>
+              <a:t>K</a:t>
+            </a:r>
+            <a:r>
+              <a:rPr i="1" baseline="-25000"/>
+              <a:t>M</a:t>
+            </a:r>
+            <a:r>
+              <a:rPr baseline="30000"/>
+              <a:t>ManNAc</a:t>
+            </a:r>
+            <a:r>
+              <a:rPr/>
+              <a:t> and </a:t>
+            </a:r>
+            <a:r>
+              <a:rPr i="1"/>
+              <a:t>K</a:t>
+            </a:r>
+            <a:r>
+              <a:rPr i="1" baseline="-25000"/>
+              <a:t>M</a:t>
+            </a:r>
+            <a:r>
+              <a:rPr baseline="30000"/>
+              <a:t>PEP</a:t>
+            </a:r>
+            <a:r>
+              <a:rPr/>
+              <a:t>, and how uncertain is each?</a:t>
+            </a:r>
+          </a:p>
+          <a:p>
+            <a:r>
+              <a:rPr/>
+              <a:t>Do the two chains agree, and were there divergences?</a:t>
+            </a:r>
+          </a:p>
+          <a:p>
+            <a:r>
+              <a:rPr/>
+              <a:t>Is the posterior clear of the prior bounds, or does a bound decide the answer?</a:t>
+            </a:r>
+          </a:p>
+          <a:p>
+            <a:r>
+              <a:rPr/>
+              <a:t>Does one model describe both series?</a:t>
+            </a:r>
+          </a:p>
+        </p:txBody>
+      </p:sp>
+      <p:sp>
+        <p:nvSpPr>
+          <p:cNvPr id="4" name="Text Placeholder 3"/>
+          <p:cNvSpPr>
+            <a:spLocks noGrp="1"/>
+          </p:cNvSpPr>
+          <p:nvPr>
+            <p:ph type="body" idx="13" sz="quarter"/>
+          </p:nvPr>
+        </p:nvSpPr>
+        <p:spPr/>
+        <p:txBody>
+          <a:bodyPr/>
+          <a:lstStyle/>
+          <a:p>
+            <a:r>
+              <a:rPr/>
+              <a:t>Task 2</a:t>
             </a:r>
           </a:p>
         </p:txBody>
@@ -4574,7 +4422,7 @@
             <a:spLocks noGrp="1"/>
           </p:cNvSpPr>
           <p:nvPr>
-            <p:ph type="body" idx="13" sz="quarter"/>
+            <p:ph type="body" idx="15" sz="quarter"/>
           </p:nvPr>
         </p:nvSpPr>
         <p:spPr/>
@@ -4584,35 +4432,55 @@
           <a:p>
             <a:r>
               <a:rPr/>
-              <a:t>Task 1</a:t>
-            </a:r>
-          </a:p>
-        </p:txBody>
-      </p:sp>
-      <p:pic>
-        <p:nvPicPr>
-          <p:cNvPr id="8" name="Picture 7" descr="time_courses.png"/>
-          <p:cNvPicPr>
-            <a:picLocks noChangeAspect="1"/>
-          </p:cNvPicPr>
-          <p:nvPr/>
-        </p:nvPicPr>
-        <p:blipFill>
-          <a:blip r:embed="rId3"/>
-          <a:stretch>
-            <a:fillRect/>
-          </a:stretch>
-        </p:blipFill>
-        <p:spPr>
-          <a:xfrm>
-            <a:off x="1928617" y="1645920"/>
-            <a:ext cx="8334461" cy="2880360"/>
-          </a:xfrm>
-          <a:prstGeom prst="rect">
-            <a:avLst/>
-          </a:prstGeom>
-        </p:spPr>
-      </p:pic>
+              <a:t>v = </a:t>
+            </a:r>
+            <a:r>
+              <a:rPr i="1"/>
+              <a:t>k</a:t>
+            </a:r>
+            <a:r>
+              <a:rPr baseline="-25000"/>
+              <a:t>cat</a:t>
+            </a:r>
+            <a:r>
+              <a:rPr/>
+              <a:t> · [NeuS] · [ManNAc] · [PEP] / ((</a:t>
+            </a:r>
+            <a:r>
+              <a:rPr i="1"/>
+              <a:t>K</a:t>
+            </a:r>
+            <a:r>
+              <a:rPr i="1" baseline="-25000"/>
+              <a:t>M</a:t>
+            </a:r>
+            <a:r>
+              <a:rPr baseline="30000"/>
+              <a:t>ManNAc</a:t>
+            </a:r>
+            <a:r>
+              <a:rPr/>
+              <a:t> + [ManNAc]) (</a:t>
+            </a:r>
+            <a:r>
+              <a:rPr i="1"/>
+              <a:t>K</a:t>
+            </a:r>
+            <a:r>
+              <a:rPr i="1" baseline="-25000"/>
+              <a:t>M</a:t>
+            </a:r>
+            <a:r>
+              <a:rPr baseline="30000"/>
+              <a:t>PEP</a:t>
+            </a:r>
+            <a:r>
+              <a:rPr/>
+              <a:t> + [PEP]))</a:t>
+            </a:r>
+          </a:p>
+        </p:txBody>
+      </p:sp>
     </p:spTree>
   </p:cSld>
   <p:clrMapOvr>
@@ -4622,234 +4490,6 @@
 </file>
 
 <file path=ppt/slides/slide14.xml><?xml version="1.0" encoding="utf-8"?>
-<p:sld xmlns:a="http://schemas.openxmlformats.org/drawingml/2006/main" xmlns:p="http://schemas.openxmlformats.org/presentationml/2006/main" xmlns:r="http://schemas.openxmlformats.org/officeDocument/2006/relationships">
-  <p:cSld>
-    <p:spTree>
-      <p:nvGrpSpPr>
-        <p:cNvPr id="1" name=""/>
-        <p:cNvGrpSpPr/>
-        <p:nvPr/>
-      </p:nvGrpSpPr>
-      <p:grpSpPr/>
-      <p:sp>
-        <p:nvSpPr>
-          <p:cNvPr id="2" name="Title 1"/>
-          <p:cNvSpPr>
-            <a:spLocks noGrp="1"/>
-          </p:cNvSpPr>
-          <p:nvPr>
-            <p:ph type="title"/>
-          </p:nvPr>
-        </p:nvSpPr>
-        <p:spPr/>
-        <p:txBody>
-          <a:bodyPr/>
-          <a:lstStyle/>
-          <a:p>
-            <a:r>
-              <a:rPr/>
-              <a:t>Task 2: kinetic parameters by Bayesian inference</a:t>
-            </a:r>
-          </a:p>
-        </p:txBody>
-      </p:sp>
-      <p:sp>
-        <p:nvSpPr>
-          <p:cNvPr id="3" name="Content Placeholder 2"/>
-          <p:cNvSpPr>
-            <a:spLocks noGrp="1"/>
-          </p:cNvSpPr>
-          <p:nvPr>
-            <p:ph idx="1"/>
-          </p:nvPr>
-        </p:nvSpPr>
-        <p:spPr/>
-        <p:txBody>
-          <a:bodyPr/>
-          <a:lstStyle/>
-          <a:p>
-            <a:r>
-              <a:rPr b="1"/>
-              <a:t>Goal: </a:t>
-            </a:r>
-            <a:r>
-              <a:rPr/>
-              <a:t>posterior distributions of </a:t>
-            </a:r>
-            <a:r>
-              <a:rPr i="1"/>
-              <a:t>k</a:t>
-            </a:r>
-            <a:r>
-              <a:rPr baseline="-25000"/>
-              <a:t>cat</a:t>
-            </a:r>
-            <a:r>
-              <a:rPr/>
-              <a:t>, </a:t>
-            </a:r>
-            <a:r>
-              <a:rPr i="1"/>
-              <a:t>K</a:t>
-            </a:r>
-            <a:r>
-              <a:rPr i="1" baseline="-25000"/>
-              <a:t>M</a:t>
-            </a:r>
-            <a:r>
-              <a:rPr baseline="30000"/>
-              <a:t>ManNAc</a:t>
-            </a:r>
-            <a:r>
-              <a:rPr/>
-              <a:t> and </a:t>
-            </a:r>
-            <a:r>
-              <a:rPr i="1"/>
-              <a:t>K</a:t>
-            </a:r>
-            <a:r>
-              <a:rPr i="1" baseline="-25000"/>
-              <a:t>M</a:t>
-            </a:r>
-            <a:r>
-              <a:rPr baseline="30000"/>
-              <a:t>PEP</a:t>
-            </a:r>
-            <a:r>
-              <a:rPr/>
-              <a:t>, with a fit plot</a:t>
-            </a:r>
-          </a:p>
-          <a:p>
-            <a:r>
-              <a:rPr b="1"/>
-              <a:t>Model: </a:t>
-            </a:r>
-            <a:r>
-              <a:rPr/>
-              <a:t>the enzyme is in the rate law, only Neu5Ac is measured, the metal cofactor is left out (a simplification)</a:t>
-            </a:r>
-          </a:p>
-          <a:p>
-            <a:r>
-              <a:rPr b="1"/>
-              <a:t>Your decisions: </a:t>
-            </a:r>
-            <a:r>
-              <a:rPr/>
-              <a:t>the priors, the assumed measurement noise, the sampler settings</a:t>
-            </a:r>
-          </a:p>
-          <a:p>
-            <a:r>
-              <a:rPr b="1"/>
-              <a:t>Checks: </a:t>
-            </a:r>
-            <a:r>
-              <a:rPr/>
-              <a:t>r-hat near 1, no divergences, posterior clear of the prior bounds</a:t>
-            </a:r>
-          </a:p>
-        </p:txBody>
-      </p:sp>
-      <p:sp>
-        <p:nvSpPr>
-          <p:cNvPr id="4" name="Text Placeholder 3"/>
-          <p:cNvSpPr>
-            <a:spLocks noGrp="1"/>
-          </p:cNvSpPr>
-          <p:nvPr>
-            <p:ph type="body" idx="13" sz="quarter"/>
-          </p:nvPr>
-        </p:nvSpPr>
-        <p:spPr/>
-        <p:txBody>
-          <a:bodyPr/>
-          <a:lstStyle/>
-          <a:p>
-            <a:r>
-              <a:rPr/>
-              <a:t>Task 2</a:t>
-            </a:r>
-          </a:p>
-        </p:txBody>
-      </p:sp>
-      <p:sp>
-        <p:nvSpPr>
-          <p:cNvPr id="5" name="Text Placeholder 4"/>
-          <p:cNvSpPr>
-            <a:spLocks noGrp="1"/>
-          </p:cNvSpPr>
-          <p:nvPr>
-            <p:ph type="body" idx="15" sz="quarter"/>
-          </p:nvPr>
-        </p:nvSpPr>
-        <p:spPr/>
-        <p:txBody>
-          <a:bodyPr/>
-          <a:lstStyle/>
-          <a:p>
-            <a:r>
-              <a:rPr/>
-              <a:t>v = </a:t>
-            </a:r>
-            <a:r>
-              <a:rPr i="1"/>
-              <a:t>k</a:t>
-            </a:r>
-            <a:r>
-              <a:rPr baseline="-25000"/>
-              <a:t>cat</a:t>
-            </a:r>
-            <a:r>
-              <a:rPr/>
-              <a:t> · [NeuS] · [ManNAc] · [PEP] / ((</a:t>
-            </a:r>
-            <a:r>
-              <a:rPr i="1"/>
-              <a:t>K</a:t>
-            </a:r>
-            <a:r>
-              <a:rPr i="1" baseline="-25000"/>
-              <a:t>M</a:t>
-            </a:r>
-            <a:r>
-              <a:rPr baseline="30000"/>
-              <a:t>ManNAc</a:t>
-            </a:r>
-            <a:r>
-              <a:rPr/>
-              <a:t> + [ManNAc]) (</a:t>
-            </a:r>
-            <a:r>
-              <a:rPr i="1"/>
-              <a:t>K</a:t>
-            </a:r>
-            <a:r>
-              <a:rPr i="1" baseline="-25000"/>
-              <a:t>M</a:t>
-            </a:r>
-            <a:r>
-              <a:rPr baseline="30000"/>
-              <a:t>PEP</a:t>
-            </a:r>
-            <a:r>
-              <a:rPr/>
-              <a:t> + [PEP]))</a:t>
-            </a:r>
-          </a:p>
-        </p:txBody>
-      </p:sp>
-    </p:spTree>
-  </p:cSld>
-  <p:clrMapOvr>
-    <a:masterClrMapping/>
-  </p:clrMapOvr>
-</p:sld>
-</file>
-
-<file path=ppt/slides/slide15.xml><?xml version="1.0" encoding="utf-8"?>
 <p:sld xmlns:a="http://schemas.openxmlformats.org/drawingml/2006/main" xmlns:p="http://schemas.openxmlformats.org/presentationml/2006/main" xmlns:r="http://schemas.openxmlformats.org/officeDocument/2006/relationships">
   <p:cSld>
     <p:spTree>
@@ -5144,7 +4784,7 @@
 </p:sld>
 </file>
 
-<file path=ppt/slides/slide16.xml><?xml version="1.0" encoding="utf-8"?>
+<file path=ppt/slides/slide15.xml><?xml version="1.0" encoding="utf-8"?>
 <p:sld xmlns:a="http://schemas.openxmlformats.org/drawingml/2006/main" xmlns:p="http://schemas.openxmlformats.org/presentationml/2006/main" xmlns:r="http://schemas.openxmlformats.org/officeDocument/2006/relationships">
   <p:cSld>
     <p:spTree>
@@ -5246,7 +4886,7 @@
 </p:sld>
 </file>
 
-<file path=ppt/slides/slide17.xml><?xml version="1.0" encoding="utf-8"?>
+<file path=ppt/slides/slide16.xml><?xml version="1.0" encoding="utf-8"?>
 <p:sld xmlns:a="http://schemas.openxmlformats.org/drawingml/2006/main" xmlns:p="http://schemas.openxmlformats.org/presentationml/2006/main" xmlns:r="http://schemas.openxmlformats.org/officeDocument/2006/relationships">
   <p:cSld>
     <p:spTree>
@@ -7556,7 +7196,7 @@
                   <a:srgbClr val="6F6F6F"/>
                 </a:solidFill>
               </a:rPr>
-              <a:t>24 reactions × 6 injections, 5 standards</a:t>
+              <a:t>one peak table per injection</a:t>
             </a:r>
           </a:p>
         </p:txBody>
@@ -7686,7 +7326,7 @@
                   <a:srgbClr val="6F6F6F"/>
                 </a:solidFill>
               </a:rPr>
-              <a:t>24 Neu5Ac time courses</a:t>
+              <a:t>Neu5Ac time courses</a:t>
             </a:r>
           </a:p>
         </p:txBody>
@@ -11093,25 +10733,25 @@
           <a:p>
             <a:r>
               <a:rPr/>
-              <a:t>HPLC-PDA at 215 nm; only the product Neu5Ac is quantified</a:t>
+              <a:t>Reactions sampled over time and followed by HPLC-PDA at 215 nm</a:t>
             </a:r>
           </a:p>
           <a:p>
             <a:r>
               <a:rPr/>
-              <a:t>ManNAc series: 13 reactions, ManNAc 0–100 mM at 20 mM PEP</a:t>
+              <a:t>What you get is the instrument's peak table per injection, not the raw trace</a:t>
             </a:r>
           </a:p>
           <a:p>
             <a:r>
               <a:rPr/>
-              <a:t>PEP series: 11 reactions, PEP 0–20 mM at 50 mM ManNAc</a:t>
+              <a:t>Only the product Neu5Ac is quantified; calibration standards with known concentrations</a:t>
             </a:r>
           </a:p>
           <a:p>
             <a:r>
               <a:rPr/>
-              <a:t>Six injections per reaction; five calibration standards, 1–5 mM</a:t>
+              <a:t>How many reactions, which conditions, how they were varied: that is in the data</a:t>
             </a:r>
           </a:p>
         </p:txBody>

</xml_diff>

<commit_message>
Deck: motivation slide as four icon pillars; icons drawn with matplotlib
Co-Authored-By: Claude Fable 5.1 <noreply@anthropic.com>
</commit_message>
<xml_diff>
--- a/slides/workshop.pptx
+++ b/slides/workshop.pptx
@@ -5770,46 +5770,6 @@
       </p:sp>
       <p:sp>
         <p:nvSpPr>
-          <p:cNvPr id="3" name="Content Placeholder 2"/>
-          <p:cNvSpPr>
-            <a:spLocks noGrp="1"/>
-          </p:cNvSpPr>
-          <p:nvPr>
-            <p:ph idx="1"/>
-          </p:nvPr>
-        </p:nvSpPr>
-        <p:spPr/>
-        <p:txBody>
-          <a:bodyPr/>
-          <a:lstStyle/>
-          <a:p>
-            <a:r>
-              <a:rPr/>
-              <a:t>Today's models write correct code against our Python APIs from a one-page card</a:t>
-            </a:r>
-          </a:p>
-          <a:p>
-            <a:r>
-              <a:rPr/>
-              <a:t>They do not know where the peak is, which model is right, when a result is wrong</a:t>
-            </a:r>
-          </a:p>
-          <a:p>
-            <a:r>
-              <a:rPr/>
-              <a:t>So the scientist decides and checks; the assistant executes</a:t>
-            </a:r>
-          </a:p>
-          <a:p>
-            <a:r>
-              <a:rPr/>
-              <a:t>EnzymeML is the document that travels between the steps and the tools</a:t>
-            </a:r>
-          </a:p>
-        </p:txBody>
-      </p:sp>
-      <p:sp>
-        <p:nvSpPr>
           <p:cNvPr id="4" name="Text Placeholder 3"/>
           <p:cNvSpPr>
             <a:spLocks noGrp="1"/>
@@ -5826,6 +5786,374 @@
             <a:r>
               <a:rPr/>
               <a:t>Motivation</a:t>
+            </a:r>
+          </a:p>
+        </p:txBody>
+      </p:sp>
+      <p:pic>
+        <p:nvPicPr>
+          <p:cNvPr id="7" name="Picture 6" descr="icon_card.png"/>
+          <p:cNvPicPr>
+            <a:picLocks noChangeAspect="1"/>
+          </p:cNvPicPr>
+          <p:nvPr/>
+        </p:nvPicPr>
+        <p:blipFill>
+          <a:blip r:embed="rId3"/>
+          <a:stretch>
+            <a:fillRect/>
+          </a:stretch>
+        </p:blipFill>
+        <p:spPr>
+          <a:xfrm>
+            <a:off x="1283931" y="1965960"/>
+            <a:ext cx="1371600" cy="1371600"/>
+          </a:xfrm>
+          <a:prstGeom prst="rect">
+            <a:avLst/>
+          </a:prstGeom>
+        </p:spPr>
+      </p:pic>
+      <p:sp>
+        <p:nvSpPr>
+          <p:cNvPr id="8" name="TextBox 7"/>
+          <p:cNvSpPr txBox="1"/>
+          <p:nvPr/>
+        </p:nvSpPr>
+        <p:spPr>
+          <a:xfrm>
+            <a:off x="822960" y="3611880"/>
+            <a:ext cx="2293543" cy="411480"/>
+          </a:xfrm>
+          <a:prstGeom prst="rect">
+            <a:avLst/>
+          </a:prstGeom>
+          <a:noFill/>
+        </p:spPr>
+        <p:txBody>
+          <a:bodyPr wrap="square" lIns="0" rIns="0" tIns="0" bIns="0">
+            <a:spAutoFit/>
+          </a:bodyPr>
+          <a:lstStyle/>
+          <a:p>
+            <a:pPr algn="ctr"/>
+            <a:r>
+              <a:rPr b="1" sz="1600">
+                <a:solidFill>
+                  <a:srgbClr val="0A0A0A"/>
+                </a:solidFill>
+              </a:rPr>
+              <a:t>One page is enough</a:t>
+            </a:r>
+          </a:p>
+        </p:txBody>
+      </p:sp>
+      <p:sp>
+        <p:nvSpPr>
+          <p:cNvPr id="9" name="TextBox 8"/>
+          <p:cNvSpPr txBox="1"/>
+          <p:nvPr/>
+        </p:nvSpPr>
+        <p:spPr>
+          <a:xfrm>
+            <a:off x="822960" y="4160520"/>
+            <a:ext cx="2293543" cy="1280160"/>
+          </a:xfrm>
+          <a:prstGeom prst="rect">
+            <a:avLst/>
+          </a:prstGeom>
+          <a:noFill/>
+        </p:spPr>
+        <p:txBody>
+          <a:bodyPr wrap="square" lIns="0" rIns="0" tIns="0" bIns="0">
+            <a:spAutoFit/>
+          </a:bodyPr>
+          <a:lstStyle/>
+          <a:p>
+            <a:pPr algn="ctr"/>
+            <a:r>
+              <a:rPr sz="1300">
+                <a:solidFill>
+                  <a:srgbClr val="6F6F6F"/>
+                </a:solidFill>
+              </a:rPr>
+              <a:t>From a one-page card, today's models write working code for our tools</a:t>
+            </a:r>
+          </a:p>
+        </p:txBody>
+      </p:sp>
+      <p:pic>
+        <p:nvPicPr>
+          <p:cNvPr id="10" name="Picture 9" descr="icon_peak.png"/>
+          <p:cNvPicPr>
+            <a:picLocks noChangeAspect="1"/>
+          </p:cNvPicPr>
+          <p:nvPr/>
+        </p:nvPicPr>
+        <p:blipFill>
+          <a:blip r:embed="rId4"/>
+          <a:stretch>
+            <a:fillRect/>
+          </a:stretch>
+        </p:blipFill>
+        <p:spPr>
+          <a:xfrm>
+            <a:off x="4034675" y="1965960"/>
+            <a:ext cx="1371600" cy="1371600"/>
+          </a:xfrm>
+          <a:prstGeom prst="rect">
+            <a:avLst/>
+          </a:prstGeom>
+        </p:spPr>
+      </p:pic>
+      <p:sp>
+        <p:nvSpPr>
+          <p:cNvPr id="11" name="TextBox 10"/>
+          <p:cNvSpPr txBox="1"/>
+          <p:nvPr/>
+        </p:nvSpPr>
+        <p:spPr>
+          <a:xfrm>
+            <a:off x="3573703" y="3611880"/>
+            <a:ext cx="2293543" cy="411480"/>
+          </a:xfrm>
+          <a:prstGeom prst="rect">
+            <a:avLst/>
+          </a:prstGeom>
+          <a:noFill/>
+        </p:spPr>
+        <p:txBody>
+          <a:bodyPr wrap="square" lIns="0" rIns="0" tIns="0" bIns="0">
+            <a:spAutoFit/>
+          </a:bodyPr>
+          <a:lstStyle/>
+          <a:p>
+            <a:pPr algn="ctr"/>
+            <a:r>
+              <a:rPr b="1" sz="1600">
+                <a:solidFill>
+                  <a:srgbClr val="0A0A0A"/>
+                </a:solidFill>
+              </a:rPr>
+              <a:t>Blind to your data</a:t>
+            </a:r>
+          </a:p>
+        </p:txBody>
+      </p:sp>
+      <p:sp>
+        <p:nvSpPr>
+          <p:cNvPr id="12" name="TextBox 11"/>
+          <p:cNvSpPr txBox="1"/>
+          <p:nvPr/>
+        </p:nvSpPr>
+        <p:spPr>
+          <a:xfrm>
+            <a:off x="3573703" y="4160520"/>
+            <a:ext cx="2293543" cy="1280160"/>
+          </a:xfrm>
+          <a:prstGeom prst="rect">
+            <a:avLst/>
+          </a:prstGeom>
+          <a:noFill/>
+        </p:spPr>
+        <p:txBody>
+          <a:bodyPr wrap="square" lIns="0" rIns="0" tIns="0" bIns="0">
+            <a:spAutoFit/>
+          </a:bodyPr>
+          <a:lstStyle/>
+          <a:p>
+            <a:pPr algn="ctr"/>
+            <a:r>
+              <a:rPr sz="1300">
+                <a:solidFill>
+                  <a:srgbClr val="6F6F6F"/>
+                </a:solidFill>
+              </a:rPr>
+              <a:t>Where the peak is, which model is right, when a result is wrong</a:t>
+            </a:r>
+          </a:p>
+        </p:txBody>
+      </p:sp>
+      <p:pic>
+        <p:nvPicPr>
+          <p:cNvPr id="13" name="Picture 12" descr="icon_person_check.png"/>
+          <p:cNvPicPr>
+            <a:picLocks noChangeAspect="1"/>
+          </p:cNvPicPr>
+          <p:nvPr/>
+        </p:nvPicPr>
+        <p:blipFill>
+          <a:blip r:embed="rId5"/>
+          <a:stretch>
+            <a:fillRect/>
+          </a:stretch>
+        </p:blipFill>
+        <p:spPr>
+          <a:xfrm>
+            <a:off x="6785419" y="1965960"/>
+            <a:ext cx="1371600" cy="1371600"/>
+          </a:xfrm>
+          <a:prstGeom prst="rect">
+            <a:avLst/>
+          </a:prstGeom>
+        </p:spPr>
+      </p:pic>
+      <p:sp>
+        <p:nvSpPr>
+          <p:cNvPr id="14" name="TextBox 13"/>
+          <p:cNvSpPr txBox="1"/>
+          <p:nvPr/>
+        </p:nvSpPr>
+        <p:spPr>
+          <a:xfrm>
+            <a:off x="6324447" y="3611880"/>
+            <a:ext cx="2293543" cy="411480"/>
+          </a:xfrm>
+          <a:prstGeom prst="rect">
+            <a:avLst/>
+          </a:prstGeom>
+          <a:noFill/>
+        </p:spPr>
+        <p:txBody>
+          <a:bodyPr wrap="square" lIns="0" rIns="0" tIns="0" bIns="0">
+            <a:spAutoFit/>
+          </a:bodyPr>
+          <a:lstStyle/>
+          <a:p>
+            <a:pPr algn="ctr"/>
+            <a:r>
+              <a:rPr b="1" sz="1600">
+                <a:solidFill>
+                  <a:srgbClr val="0A0A0A"/>
+                </a:solidFill>
+              </a:rPr>
+              <a:t>You decide and check</a:t>
+            </a:r>
+          </a:p>
+        </p:txBody>
+      </p:sp>
+      <p:sp>
+        <p:nvSpPr>
+          <p:cNvPr id="15" name="TextBox 14"/>
+          <p:cNvSpPr txBox="1"/>
+          <p:nvPr/>
+        </p:nvSpPr>
+        <p:spPr>
+          <a:xfrm>
+            <a:off x="6324447" y="4160520"/>
+            <a:ext cx="2293543" cy="1280160"/>
+          </a:xfrm>
+          <a:prstGeom prst="rect">
+            <a:avLst/>
+          </a:prstGeom>
+          <a:noFill/>
+        </p:spPr>
+        <p:txBody>
+          <a:bodyPr wrap="square" lIns="0" rIns="0" tIns="0" bIns="0">
+            <a:spAutoFit/>
+          </a:bodyPr>
+          <a:lstStyle/>
+          <a:p>
+            <a:pPr algn="ctr"/>
+            <a:r>
+              <a:rPr sz="1300">
+                <a:solidFill>
+                  <a:srgbClr val="6F6F6F"/>
+                </a:solidFill>
+              </a:rPr>
+              <a:t>The decisions and the checks stay with the scientist; the assistant executes</a:t>
+            </a:r>
+          </a:p>
+        </p:txBody>
+      </p:sp>
+      <p:pic>
+        <p:nvPicPr>
+          <p:cNvPr id="16" name="Picture 15" descr="icon_document_arrows.png"/>
+          <p:cNvPicPr>
+            <a:picLocks noChangeAspect="1"/>
+          </p:cNvPicPr>
+          <p:nvPr/>
+        </p:nvPicPr>
+        <p:blipFill>
+          <a:blip r:embed="rId6"/>
+          <a:stretch>
+            <a:fillRect/>
+          </a:stretch>
+        </p:blipFill>
+        <p:spPr>
+          <a:xfrm>
+            <a:off x="9536163" y="1965960"/>
+            <a:ext cx="1371600" cy="1371600"/>
+          </a:xfrm>
+          <a:prstGeom prst="rect">
+            <a:avLst/>
+          </a:prstGeom>
+        </p:spPr>
+      </p:pic>
+      <p:sp>
+        <p:nvSpPr>
+          <p:cNvPr id="17" name="TextBox 16"/>
+          <p:cNvSpPr txBox="1"/>
+          <p:nvPr/>
+        </p:nvSpPr>
+        <p:spPr>
+          <a:xfrm>
+            <a:off x="9075191" y="3611880"/>
+            <a:ext cx="2293543" cy="411480"/>
+          </a:xfrm>
+          <a:prstGeom prst="rect">
+            <a:avLst/>
+          </a:prstGeom>
+          <a:noFill/>
+        </p:spPr>
+        <p:txBody>
+          <a:bodyPr wrap="square" lIns="0" rIns="0" tIns="0" bIns="0">
+            <a:spAutoFit/>
+          </a:bodyPr>
+          <a:lstStyle/>
+          <a:p>
+            <a:pPr algn="ctr"/>
+            <a:r>
+              <a:rPr b="1" sz="1600">
+                <a:solidFill>
+                  <a:srgbClr val="0A0A0A"/>
+                </a:solidFill>
+              </a:rPr>
+              <a:t>EnzymeML in between</a:t>
+            </a:r>
+          </a:p>
+        </p:txBody>
+      </p:sp>
+      <p:sp>
+        <p:nvSpPr>
+          <p:cNvPr id="18" name="TextBox 17"/>
+          <p:cNvSpPr txBox="1"/>
+          <p:nvPr/>
+        </p:nvSpPr>
+        <p:spPr>
+          <a:xfrm>
+            <a:off x="9075191" y="4160520"/>
+            <a:ext cx="2293543" cy="1280160"/>
+          </a:xfrm>
+          <a:prstGeom prst="rect">
+            <a:avLst/>
+          </a:prstGeom>
+          <a:noFill/>
+        </p:spPr>
+        <p:txBody>
+          <a:bodyPr wrap="square" lIns="0" rIns="0" tIns="0" bIns="0">
+            <a:spAutoFit/>
+          </a:bodyPr>
+          <a:lstStyle/>
+          <a:p>
+            <a:pPr algn="ctr"/>
+            <a:r>
+              <a:rPr sz="1300">
+                <a:solidFill>
+                  <a:srgbClr val="6F6F6F"/>
+                </a:solidFill>
+              </a:rPr>
+              <a:t>One document carries the data between the steps and the tools</a:t>
             </a:r>
           </a:p>
         </p:txBody>

</xml_diff>

<commit_message>
Cite the source paper (Çakar et al. 2024) prominently in the README, the data README and the deck
Co-Authored-By: Claude Fable 5.1 <noreply@anthropic.com>
</commit_message>
<xml_diff>
--- a/slides/workshop.pptx
+++ b/slides/workshop.pptx
@@ -11102,6 +11102,28 @@
             <a:r>
               <a:rPr/>
               <a:t>The experiment</a:t>
+            </a:r>
+          </a:p>
+        </p:txBody>
+      </p:sp>
+      <p:sp>
+        <p:nvSpPr>
+          <p:cNvPr id="7" name="Text Placeholder 6"/>
+          <p:cNvSpPr>
+            <a:spLocks noGrp="1"/>
+          </p:cNvSpPr>
+          <p:nvPr>
+            <p:ph type="body" idx="16" sz="quarter"/>
+          </p:nvPr>
+        </p:nvSpPr>
+        <p:spPr/>
+        <p:txBody>
+          <a:bodyPr/>
+          <a:lstStyle/>
+          <a:p>
+            <a:r>
+              <a:rPr/>
+              <a:t>Data: Çakar et al. (2024) Kinetic characterization of two neuraminic acid synthases and evaluation of their application potential. Appl. Microbiol. Biotechnol. 108, 446 · doi:10.1007/s00253-024-13277-1</a:t>
             </a:r>
           </a:p>
         </p:txBody>

</xml_diff>

<commit_message>
Deck: Chromhandler slide boxes without sub text
Co-Authored-By: Claude Fable 5.1 <noreply@anthropic.com>
</commit_message>
<xml_diff>
--- a/slides/workshop.pptx
+++ b/slides/workshop.pptx
@@ -8561,17 +8561,6 @@
               <a:t>Peak tables</a:t>
             </a:r>
           </a:p>
-          <a:p>
-            <a:pPr algn="ctr"/>
-            <a:r>
-              <a:rPr sz="1100">
-                <a:solidFill>
-                  <a:srgbClr val="6F6F6F"/>
-                </a:solidFill>
-              </a:rPr>
-              <a:t>one export per injection, the time in the file name</a:t>
-            </a:r>
-          </a:p>
         </p:txBody>
       </p:sp>
       <p:cxnSp>
@@ -8661,17 +8650,6 @@
               <a:t>Calibration standards</a:t>
             </a:r>
           </a:p>
-          <a:p>
-            <a:pPr algn="ctr"/>
-            <a:r>
-              <a:rPr sz="1100">
-                <a:solidFill>
-                  <a:srgbClr val="6F6F6F"/>
-                </a:solidFill>
-              </a:rPr>
-              <a:t>exports with known concentrations</a:t>
-            </a:r>
-          </a:p>
         </p:txBody>
       </p:sp>
       <p:cxnSp>
@@ -8759,17 +8737,6 @@
                 </a:solidFill>
               </a:rPr>
               <a:t>Initial concentrations</a:t>
-            </a:r>
-          </a:p>
-          <a:p>
-            <a:pPr algn="ctr"/>
-            <a:r>
-              <a:rPr sz="1100">
-                <a:solidFill>
-                  <a:srgbClr val="6F6F6F"/>
-                </a:solidFill>
-              </a:rPr>
-              <a:t>what was in each reaction at t = 0</a:t>
             </a:r>
           </a:p>
         </p:txBody>
@@ -8932,17 +8899,6 @@
               <a:t>Read the exports</a:t>
             </a:r>
           </a:p>
-          <a:p>
-            <a:pPr algn="ctr"/>
-            <a:r>
-              <a:rPr sz="1100">
-                <a:solidFill>
-                  <a:srgbClr val="6F6F6F"/>
-                </a:solidFill>
-              </a:rPr>
-              <a:t>read_shimadzu, reaction or calibration mode</a:t>
-            </a:r>
-          </a:p>
         </p:txBody>
       </p:sp>
       <p:sp>
@@ -8997,17 +8953,6 @@
               <a:t>Set the retention window</a:t>
             </a:r>
           </a:p>
-          <a:p>
-            <a:pPr algn="ctr"/>
-            <a:r>
-              <a:rPr sz="1100">
-                <a:solidFill>
-                  <a:srgbClr val="6F6F6F"/>
-                </a:solidFill>
-              </a:rPr>
-              <a:t>your decision, per measurement session</a:t>
-            </a:r>
-          </a:p>
         </p:txBody>
       </p:sp>
       <p:sp>
@@ -9062,17 +9007,6 @@
               <a:t>Assign the peak</a:t>
             </a:r>
           </a:p>
-          <a:p>
-            <a:pPr algn="ctr"/>
-            <a:r>
-              <a:rPr sz="1100">
-                <a:solidFill>
-                  <a:srgbClr val="6F6F6F"/>
-                </a:solidFill>
-              </a:rPr>
-              <a:t>auto_assign: the peak inside the window</a:t>
-            </a:r>
-          </a:p>
         </p:txBody>
       </p:sp>
       <p:sp>
@@ -9127,17 +9061,6 @@
               <a:t>Calibrate</a:t>
             </a:r>
           </a:p>
-          <a:p>
-            <a:pPr algn="ctr"/>
-            <a:r>
-              <a:rPr sz="1100">
-                <a:solidFill>
-                  <a:srgbClr val="6F6F6F"/>
-                </a:solidFill>
-              </a:rPr>
-              <a:t>add_standard, area against concentration; you accept R²</a:t>
-            </a:r>
-          </a:p>
         </p:txBody>
       </p:sp>
       <p:sp>
@@ -9190,17 +9113,6 @@
                 </a:solidFill>
               </a:rPr>
               <a:t>Export</a:t>
-            </a:r>
-          </a:p>
-          <a:p>
-            <a:pPr algn="ctr"/>
-            <a:r>
-              <a:rPr sz="1100">
-                <a:solidFill>
-                  <a:srgbClr val="6F6F6F"/>
-                </a:solidFill>
-              </a:rPr>
-              <a:t>to_enzymeml: areas become concentrations</a:t>
             </a:r>
           </a:p>
         </p:txBody>
@@ -9471,17 +9383,6 @@
               <a:t>EnzymeML document</a:t>
             </a:r>
           </a:p>
-          <a:p>
-            <a:pPr algn="ctr"/>
-            <a:r>
-              <a:rPr sz="1100">
-                <a:solidFill>
-                  <a:srgbClr val="6F6F6F"/>
-                </a:solidFill>
-              </a:rPr>
-              <a:t>time courses with their initial conditions</a:t>
-            </a:r>
-          </a:p>
         </p:txBody>
       </p:sp>
       <p:cxnSp>
@@ -9570,17 +9471,6 @@
                 </a:solidFill>
               </a:rPr>
               <a:t>Checks</a:t>
-            </a:r>
-          </a:p>
-          <a:p>
-            <a:pPr algn="ctr"/>
-            <a:r>
-              <a:rPr sz="1100">
-                <a:solidFill>
-                  <a:srgbClr val="6F6F6F"/>
-                </a:solidFill>
-              </a:rPr>
-              <a:t>one peak per chromatogram, R², values per reaction</a:t>
             </a:r>
           </a:p>
         </p:txBody>

</xml_diff>

<commit_message>
Deck: Catalax slide boxes without sub text; workflow bracket 'infer the kinetic parameters'
Co-Authored-By: Claude Fable 5.1 <noreply@anthropic.com>
</commit_message>
<xml_diff>
--- a/slides/workshop.pptx
+++ b/slides/workshop.pptx
@@ -8278,47 +8278,7 @@
                   <a:srgbClr val="0A0A0A"/>
                 </a:solidFill>
               </a:rPr>
-              <a:t>Task 2 · EnzymeML to </a:t>
-            </a:r>
-            <a:r>
-              <a:rPr i="1" sz="1200">
-                <a:solidFill>
-                  <a:srgbClr val="0A0A0A"/>
-                </a:solidFill>
-              </a:rPr>
-              <a:t>k</a:t>
-            </a:r>
-            <a:r>
-              <a:rPr sz="1200" baseline="-25000">
-                <a:solidFill>
-                  <a:srgbClr val="0A0A0A"/>
-                </a:solidFill>
-              </a:rPr>
-              <a:t>cat</a:t>
-            </a:r>
-            <a:r>
-              <a:rPr sz="1200">
-                <a:solidFill>
-                  <a:srgbClr val="0A0A0A"/>
-                </a:solidFill>
-              </a:rPr>
-              <a:t> and </a:t>
-            </a:r>
-            <a:r>
-              <a:rPr i="1" sz="1200">
-                <a:solidFill>
-                  <a:srgbClr val="0A0A0A"/>
-                </a:solidFill>
-              </a:rPr>
-              <a:t>K</a:t>
-            </a:r>
-            <a:r>
-              <a:rPr i="1" sz="1200" baseline="-25000">
-                <a:solidFill>
-                  <a:srgbClr val="0A0A0A"/>
-                </a:solidFill>
-              </a:rPr>
-              <a:t>M</a:t>
+              <a:t>Task 2 · infer the kinetic parameters</a:t>
             </a:r>
           </a:p>
         </p:txBody>
@@ -9749,17 +9709,6 @@
               <a:t>EnzymeML document</a:t>
             </a:r>
           </a:p>
-          <a:p>
-            <a:pPr algn="ctr"/>
-            <a:r>
-              <a:rPr sz="1100">
-                <a:solidFill>
-                  <a:srgbClr val="6F6F6F"/>
-                </a:solidFill>
-              </a:rPr>
-              <a:t>time courses and initial conditions</a:t>
-            </a:r>
-          </a:p>
         </p:txBody>
       </p:sp>
       <p:cxnSp>
@@ -9849,17 +9798,6 @@
               <a:t>Rate law</a:t>
             </a:r>
           </a:p>
-          <a:p>
-            <a:pPr algn="ctr"/>
-            <a:r>
-              <a:rPr sz="1100">
-                <a:solidFill>
-                  <a:srgbClr val="6F6F6F"/>
-                </a:solidFill>
-              </a:rPr>
-              <a:t>one equation; states and ODEs follow from it</a:t>
-            </a:r>
-          </a:p>
         </p:txBody>
       </p:sp>
       <p:cxnSp>
@@ -9947,17 +9885,6 @@
                 </a:solidFill>
               </a:rPr>
               <a:t>Priors and noise</a:t>
-            </a:r>
-          </a:p>
-          <a:p>
-            <a:pPr algn="ctr"/>
-            <a:r>
-              <a:rPr sz="1100">
-                <a:solidFill>
-                  <a:srgbClr val="6F6F6F"/>
-                </a:solidFill>
-              </a:rPr>
-              <a:t>what you assume before seeing the data</a:t>
             </a:r>
           </a:p>
         </p:txBody>
@@ -10120,17 +10047,6 @@
               <a:t>Load the dataset</a:t>
             </a:r>
           </a:p>
-          <a:p>
-            <a:pPr algn="ctr"/>
-            <a:r>
-              <a:rPr sz="1100">
-                <a:solidFill>
-                  <a:srgbClr val="6F6F6F"/>
-                </a:solidFill>
-              </a:rPr>
-              <a:t>Dataset.from_enzymeml</a:t>
-            </a:r>
-          </a:p>
         </p:txBody>
       </p:sp>
       <p:sp>
@@ -10185,17 +10101,6 @@
               <a:t>Define the model</a:t>
             </a:r>
           </a:p>
-          <a:p>
-            <a:pPr algn="ctr"/>
-            <a:r>
-              <a:rPr sz="1100">
-                <a:solidFill>
-                  <a:srgbClr val="6F6F6F"/>
-                </a:solidFill>
-              </a:rPr>
-              <a:t>add_state, add_ode; your decision</a:t>
-            </a:r>
-          </a:p>
         </p:txBody>
       </p:sp>
       <p:sp>
@@ -10250,17 +10155,6 @@
               <a:t>Set the priors</a:t>
             </a:r>
           </a:p>
-          <a:p>
-            <a:pPr algn="ctr"/>
-            <a:r>
-              <a:rPr sz="1100">
-                <a:solidFill>
-                  <a:srgbClr val="6F6F6F"/>
-                </a:solidFill>
-              </a:rPr>
-              <a:t>LogUniform per parameter, yerrs; your decision</a:t>
-            </a:r>
-          </a:p>
         </p:txBody>
       </p:sp>
       <p:sp>
@@ -10315,17 +10209,6 @@
               <a:t>Sample</a:t>
             </a:r>
           </a:p>
-          <a:p>
-            <a:pPr algn="ctr"/>
-            <a:r>
-              <a:rPr sz="1100">
-                <a:solidFill>
-                  <a:srgbClr val="6F6F6F"/>
-                </a:solidFill>
-              </a:rPr>
-              <a:t>run_mcmc: chains, warmup, samples</a:t>
-            </a:r>
-          </a:p>
         </p:txBody>
       </p:sp>
       <p:sp>
@@ -10378,17 +10261,6 @@
                 </a:solidFill>
               </a:rPr>
               <a:t>Check and plot</a:t>
-            </a:r>
-          </a:p>
-          <a:p>
-            <a:pPr algn="ctr"/>
-            <a:r>
-              <a:rPr sz="1100">
-                <a:solidFill>
-                  <a:srgbClr val="6F6F6F"/>
-                </a:solidFill>
-              </a:rPr>
-              <a:t>r-hat, divergences, bounds, correlations</a:t>
             </a:r>
           </a:p>
         </p:txBody>
@@ -10659,97 +10531,6 @@
               <a:t>Posterior</a:t>
             </a:r>
           </a:p>
-          <a:p>
-            <a:pPr algn="ctr"/>
-            <a:r>
-              <a:rPr i="1" sz="1100">
-                <a:solidFill>
-                  <a:srgbClr val="6F6F6F"/>
-                </a:solidFill>
-              </a:rPr>
-              <a:t>k</a:t>
-            </a:r>
-            <a:r>
-              <a:rPr sz="1100" baseline="-25000">
-                <a:solidFill>
-                  <a:srgbClr val="6F6F6F"/>
-                </a:solidFill>
-              </a:rPr>
-              <a:t>cat</a:t>
-            </a:r>
-            <a:r>
-              <a:rPr sz="1100">
-                <a:solidFill>
-                  <a:srgbClr val="6F6F6F"/>
-                </a:solidFill>
-              </a:rPr>
-              <a:t>, </a:t>
-            </a:r>
-            <a:r>
-              <a:rPr i="1" sz="1100">
-                <a:solidFill>
-                  <a:srgbClr val="6F6F6F"/>
-                </a:solidFill>
-              </a:rPr>
-              <a:t>K</a:t>
-            </a:r>
-            <a:r>
-              <a:rPr i="1" sz="1100" baseline="-25000">
-                <a:solidFill>
-                  <a:srgbClr val="6F6F6F"/>
-                </a:solidFill>
-              </a:rPr>
-              <a:t>M</a:t>
-            </a:r>
-            <a:r>
-              <a:rPr sz="1100" baseline="30000">
-                <a:solidFill>
-                  <a:srgbClr val="6F6F6F"/>
-                </a:solidFill>
-              </a:rPr>
-              <a:t>ManNAc</a:t>
-            </a:r>
-            <a:r>
-              <a:rPr sz="1100">
-                <a:solidFill>
-                  <a:srgbClr val="6F6F6F"/>
-                </a:solidFill>
-              </a:rPr>
-              <a:t>, </a:t>
-            </a:r>
-            <a:r>
-              <a:rPr i="1" sz="1100">
-                <a:solidFill>
-                  <a:srgbClr val="6F6F6F"/>
-                </a:solidFill>
-              </a:rPr>
-              <a:t>K</a:t>
-            </a:r>
-            <a:r>
-              <a:rPr i="1" sz="1100" baseline="-25000">
-                <a:solidFill>
-                  <a:srgbClr val="6F6F6F"/>
-                </a:solidFill>
-              </a:rPr>
-              <a:t>M</a:t>
-            </a:r>
-            <a:r>
-              <a:rPr sz="1100" baseline="30000">
-                <a:solidFill>
-                  <a:srgbClr val="6F6F6F"/>
-                </a:solidFill>
-              </a:rPr>
-              <a:t>PEP</a:t>
-            </a:r>
-            <a:r>
-              <a:rPr sz="1100">
-                <a:solidFill>
-                  <a:srgbClr val="6F6F6F"/>
-                </a:solidFill>
-              </a:rPr>
-              <a:t>: mean ± sd, intervals</a:t>
-            </a:r>
-          </a:p>
         </p:txBody>
       </p:sp>
       <p:cxnSp>
@@ -10838,17 +10619,6 @@
                 </a:solidFill>
               </a:rPr>
               <a:t>Plots</a:t>
-            </a:r>
-          </a:p>
-          <a:p>
-            <a:pPr algn="ctr"/>
-            <a:r>
-              <a:rPr sz="1100">
-                <a:solidFill>
-                  <a:srgbClr val="6F6F6F"/>
-                </a:solidFill>
-              </a:rPr>
-              <a:t>corner plot; data with the model on top</a:t>
             </a:r>
           </a:p>
         </p:txBody>

</xml_diff>

<commit_message>
Deck: task slides as task lists (plot the data, assay design, calibration and kinetic parameters, their correlation)
Co-Authored-By: Claude Fable 5.1 <noreply@anthropic.com>
</commit_message>
<xml_diff>
--- a/slides/workshop.pptx
+++ b/slides/workshop.pptx
@@ -4112,54 +4112,51 @@
           <a:p>
             <a:r>
               <a:rPr b="1"/>
-              <a:t>Goal: </a:t>
+              <a:t>Plot the data: </a:t>
             </a:r>
             <a:r>
               <a:rPr/>
-              <a:t>an EnzymeML document with the calibrated Neu5Ac time course of every reaction</a:t>
+              <a:t>all peaks of all injections; where does Neu5Ac elute?</a:t>
             </a:r>
           </a:p>
           <a:p>
             <a:r>
               <a:rPr b="1"/>
-              <a:t>Your decision: </a:t>
+              <a:t>Check how the kinetic assay was designed: </a:t>
             </a:r>
             <a:r>
               <a:rPr/>
-              <a:t>the Neu5Ac retention window, different in standards and reactions</a:t>
-            </a:r>
-          </a:p>
-          <a:p>
-            <a:pPr marL="0" indent="0">
-              <a:buNone/>
-            </a:pPr>
+              <a:t>how many reactions, what was varied, what was fixed?</a:t>
+            </a:r>
+          </a:p>
+          <a:p>
             <a:r>
               <a:rPr b="1"/>
-              <a:t>Questions to answer</a:t>
-            </a:r>
-          </a:p>
-          <a:p>
+              <a:t>Calibrate: </a:t>
+            </a:r>
             <a:r>
               <a:rPr/>
-              <a:t>How many reactions and standards are in the data, and what was varied?</a:t>
-            </a:r>
-          </a:p>
-          <a:p>
+              <a:t>what are the calibration parameters, and how well does the line fit?</a:t>
+            </a:r>
+          </a:p>
+          <a:p>
+            <a:r>
+              <a:rPr b="1"/>
+              <a:t>Set the retention window </a:t>
+            </a:r>
             <a:r>
               <a:rPr/>
-              <a:t>Where does Neu5Ac elute, in the standards and in the reactions?</a:t>
-            </a:r>
-          </a:p>
-          <a:p>
+              <a:t>for the reactions (it differs from the standards) and assign the peak</a:t>
+            </a:r>
+          </a:p>
+          <a:p>
+            <a:r>
+              <a:rPr b="1"/>
+              <a:t>Export the EnzymeML document: </a:t>
+            </a:r>
             <a:r>
               <a:rPr/>
-              <a:t>What is the calibration slope, and how well does the line fit?</a:t>
-            </a:r>
-          </a:p>
-          <a:p>
-            <a:r>
-              <a:rPr/>
-              <a:t>Does every reaction have all its time points, and which reactions form product?</a:t>
+              <a:t>every reaction with all its time points; which reactions form product?</a:t>
             </a:r>
           </a:p>
         </p:txBody>
@@ -4182,6 +4179,28 @@
             <a:r>
               <a:rPr/>
               <a:t>Task 1</a:t>
+            </a:r>
+          </a:p>
+        </p:txBody>
+      </p:sp>
+      <p:sp>
+        <p:nvSpPr>
+          <p:cNvPr id="5" name="Text Placeholder 4"/>
+          <p:cNvSpPr>
+            <a:spLocks noGrp="1"/>
+          </p:cNvSpPr>
+          <p:nvPr>
+            <p:ph type="body" idx="15" sz="quarter"/>
+          </p:nvPr>
+        </p:nvSpPr>
+        <p:spPr/>
+        <p:txBody>
+          <a:bodyPr/>
+          <a:lstStyle/>
+          <a:p>
+            <a:r>
+              <a:rPr/>
+              <a:t>Result: an EnzymeML document with the Neu5Ac time course of every reaction</a:t>
             </a:r>
           </a:p>
         </p:txBody>
@@ -4243,11 +4262,27 @@
           <a:p>
             <a:r>
               <a:rPr b="1"/>
-              <a:t>Goal: </a:t>
+              <a:t>Plot the time courses </a:t>
             </a:r>
             <a:r>
               <a:rPr/>
-              <a:t>posterior distributions of </a:t>
+              <a:t>from the EnzymeML document</a:t>
+            </a:r>
+          </a:p>
+          <a:p>
+            <a:r>
+              <a:rPr b="1"/>
+              <a:t>Define the model and the priors: </a:t>
+            </a:r>
+            <a:r>
+              <a:rPr/>
+              <a:t>the enzyme is in the rate law, only Neu5Ac is measured</a:t>
+            </a:r>
+          </a:p>
+          <a:p>
+            <a:r>
+              <a:rPr b="1"/>
+              <a:t>Infer the kinetic parameters: </a:t>
             </a:r>
             <a:r>
               <a:rPr i="1"/>
@@ -4291,104 +4326,33 @@
             </a:r>
             <a:r>
               <a:rPr/>
-              <a:t>, with a fit plot</a:t>
+              <a:t>, each with its uncertainty</a:t>
             </a:r>
           </a:p>
           <a:p>
             <a:r>
               <a:rPr b="1"/>
-              <a:t>Model: </a:t>
+              <a:t>Check the sampler: </a:t>
             </a:r>
             <a:r>
               <a:rPr/>
-              <a:t>the enzyme is in the rate law, only Neu5Ac is measured, the metal cofactor is left out (a simplification)</a:t>
+              <a:t>do the chains agree, divergences, posterior clear of the prior bounds?</a:t>
             </a:r>
           </a:p>
           <a:p>
             <a:r>
               <a:rPr b="1"/>
-              <a:t>Your decisions: </a:t>
+              <a:t>What is the correlation between the kinetic parameters?</a:t>
+            </a:r>
+          </a:p>
+          <a:p>
+            <a:r>
+              <a:rPr b="1"/>
+              <a:t>Does one model describe both series? </a:t>
             </a:r>
             <a:r>
               <a:rPr/>
-              <a:t>the priors, the assumed measurement noise, the sampler settings</a:t>
-            </a:r>
-          </a:p>
-          <a:p>
-            <a:pPr marL="0" indent="0">
-              <a:buNone/>
-            </a:pPr>
-            <a:r>
-              <a:rPr b="1"/>
-              <a:t>Questions to answer</a:t>
-            </a:r>
-          </a:p>
-          <a:p>
-            <a:r>
-              <a:rPr/>
-              <a:t>What are </a:t>
-            </a:r>
-            <a:r>
-              <a:rPr i="1"/>
-              <a:t>k</a:t>
-            </a:r>
-            <a:r>
-              <a:rPr baseline="-25000"/>
-              <a:t>cat</a:t>
-            </a:r>
-            <a:r>
-              <a:rPr/>
-              <a:t>, </a:t>
-            </a:r>
-            <a:r>
-              <a:rPr i="1"/>
-              <a:t>K</a:t>
-            </a:r>
-            <a:r>
-              <a:rPr i="1" baseline="-25000"/>
-              <a:t>M</a:t>
-            </a:r>
-            <a:r>
-              <a:rPr baseline="30000"/>
-              <a:t>ManNAc</a:t>
-            </a:r>
-            <a:r>
-              <a:rPr/>
-              <a:t> and </a:t>
-            </a:r>
-            <a:r>
-              <a:rPr i="1"/>
-              <a:t>K</a:t>
-            </a:r>
-            <a:r>
-              <a:rPr i="1" baseline="-25000"/>
-              <a:t>M</a:t>
-            </a:r>
-            <a:r>
-              <a:rPr baseline="30000"/>
-              <a:t>PEP</a:t>
-            </a:r>
-            <a:r>
-              <a:rPr/>
-              <a:t>, and how uncertain is each?</a:t>
-            </a:r>
-          </a:p>
-          <a:p>
-            <a:r>
-              <a:rPr/>
-              <a:t>Do the two chains agree, and were there divergences?</a:t>
-            </a:r>
-          </a:p>
-          <a:p>
-            <a:r>
-              <a:rPr/>
-              <a:t>Is the posterior clear of the prior bounds, or does a bound decide the answer?</a:t>
-            </a:r>
-          </a:p>
-          <a:p>
-            <a:r>
-              <a:rPr/>
-              <a:t>Does one model describe both series?</a:t>
+              <a:t>plot data and model together</a:t>
             </a:r>
           </a:p>
         </p:txBody>

</xml_diff>

<commit_message>
Deck: task slides with the tasks on the left and how to do it (assistant options, short link) on the right
Co-Authored-By: Claude Fable 5.1 <noreply@anthropic.com>
</commit_message>
<xml_diff>
--- a/slides/workshop.pptx
+++ b/slides/workshop.pptx
@@ -4102,7 +4102,7 @@
             <a:spLocks noGrp="1"/>
           </p:cNvSpPr>
           <p:nvPr>
-            <p:ph idx="1"/>
+            <p:ph idx="1" sz="half"/>
           </p:nvPr>
         </p:nvSpPr>
         <p:spPr/>
@@ -4111,51 +4111,51 @@
           <a:lstStyle/>
           <a:p>
             <a:r>
-              <a:rPr b="1"/>
+              <a:rPr b="1" sz="1500"/>
               <a:t>Plot the data: </a:t>
             </a:r>
             <a:r>
-              <a:rPr/>
+              <a:rPr sz="1500"/>
               <a:t>all peaks of all injections; where does Neu5Ac elute?</a:t>
             </a:r>
           </a:p>
           <a:p>
             <a:r>
-              <a:rPr b="1"/>
+              <a:rPr b="1" sz="1500"/>
               <a:t>Check how the kinetic assay was designed: </a:t>
             </a:r>
             <a:r>
-              <a:rPr/>
+              <a:rPr sz="1500"/>
               <a:t>how many reactions, what was varied, what was fixed?</a:t>
             </a:r>
           </a:p>
           <a:p>
             <a:r>
-              <a:rPr b="1"/>
+              <a:rPr b="1" sz="1500"/>
               <a:t>Calibrate: </a:t>
             </a:r>
             <a:r>
-              <a:rPr/>
+              <a:rPr sz="1500"/>
               <a:t>what are the calibration parameters, and how well does the line fit?</a:t>
             </a:r>
           </a:p>
           <a:p>
             <a:r>
-              <a:rPr b="1"/>
+              <a:rPr b="1" sz="1500"/>
               <a:t>Set the retention window </a:t>
             </a:r>
             <a:r>
-              <a:rPr/>
+              <a:rPr sz="1500"/>
               <a:t>for the reactions (it differs from the standards) and assign the peak</a:t>
             </a:r>
           </a:p>
           <a:p>
             <a:r>
-              <a:rPr b="1"/>
+              <a:rPr b="1" sz="1500"/>
               <a:t>Export the EnzymeML document: </a:t>
             </a:r>
             <a:r>
-              <a:rPr/>
+              <a:rPr sz="1500"/>
               <a:t>every reaction with all its time points; which reactions form product?</a:t>
             </a:r>
           </a:p>
@@ -4163,7 +4163,72 @@
       </p:sp>
       <p:sp>
         <p:nvSpPr>
-          <p:cNvPr id="4" name="Text Placeholder 3"/>
+          <p:cNvPr id="4" name="Content Placeholder 3"/>
+          <p:cNvSpPr>
+            <a:spLocks noGrp="1"/>
+          </p:cNvSpPr>
+          <p:nvPr>
+            <p:ph idx="2" sz="half"/>
+          </p:nvPr>
+        </p:nvSpPr>
+        <p:spPr/>
+        <p:txBody>
+          <a:bodyPr/>
+          <a:lstStyle/>
+          <a:p>
+            <a:pPr marL="0" indent="0">
+              <a:buNone/>
+            </a:pPr>
+            <a:r>
+              <a:rPr b="1" sz="1500"/>
+              <a:t>How to do it</a:t>
+            </a:r>
+          </a:p>
+          <a:p>
+            <a:r>
+              <a:rPr b="1" sz="1500"/>
+              <a:t>Coding assistant on your machine </a:t>
+            </a:r>
+            <a:r>
+              <a:rPr sz="1500"/>
+              <a:t>(Claude Code, Codex, Cursor, …): open the repository, give it briefs/chromhandler.md and briefs/task_1_chromatograms_to_enzymeml.md, then say: let's start with task 1</a:t>
+            </a:r>
+          </a:p>
+          <a:p>
+            <a:r>
+              <a:rPr b="1" sz="1500"/>
+              <a:t>Chat assistant only </a:t>
+            </a:r>
+            <a:r>
+              <a:rPr sz="1500"/>
+              <a:t>(ChatGPT, Claude, Gemini, …): open the Colab starter notebook from the README, paste the two cards into the chat, run its code in the notebook</a:t>
+            </a:r>
+          </a:p>
+          <a:p>
+            <a:r>
+              <a:rPr b="1" sz="1500"/>
+              <a:t>No assistant that runs code? </a:t>
+            </a:r>
+            <a:r>
+              <a:rPr sz="1500"/>
+              <a:t>team up with someone who has one</a:t>
+            </a:r>
+          </a:p>
+          <a:p>
+            <a:r>
+              <a:rPr b="1" sz="1500"/>
+              <a:t>Repository, data and cards: </a:t>
+            </a:r>
+            <a:r>
+              <a:rPr sz="1500"/>
+              <a:t>tinyurl.com/enzymeml2026</a:t>
+            </a:r>
+          </a:p>
+        </p:txBody>
+      </p:sp>
+      <p:sp>
+        <p:nvSpPr>
+          <p:cNvPr id="5" name="Text Placeholder 4"/>
           <p:cNvSpPr>
             <a:spLocks noGrp="1"/>
           </p:cNvSpPr>
@@ -4185,7 +4250,7 @@
       </p:sp>
       <p:sp>
         <p:nvSpPr>
-          <p:cNvPr id="5" name="Text Placeholder 4"/>
+          <p:cNvPr id="6" name="Text Placeholder 5"/>
           <p:cNvSpPr>
             <a:spLocks noGrp="1"/>
           </p:cNvSpPr>
@@ -4252,7 +4317,7 @@
             <a:spLocks noGrp="1"/>
           </p:cNvSpPr>
           <p:nvPr>
-            <p:ph idx="1"/>
+            <p:ph idx="1" sz="half"/>
           </p:nvPr>
         </p:nvSpPr>
         <p:spPr/>
@@ -4261,97 +4326,97 @@
           <a:lstStyle/>
           <a:p>
             <a:r>
-              <a:rPr b="1"/>
+              <a:rPr b="1" sz="1500"/>
               <a:t>Plot the time courses </a:t>
             </a:r>
             <a:r>
-              <a:rPr/>
+              <a:rPr sz="1500"/>
               <a:t>from the EnzymeML document</a:t>
             </a:r>
           </a:p>
           <a:p>
             <a:r>
-              <a:rPr b="1"/>
+              <a:rPr b="1" sz="1500"/>
               <a:t>Define the model and the priors: </a:t>
             </a:r>
             <a:r>
-              <a:rPr/>
+              <a:rPr sz="1500"/>
               <a:t>the enzyme is in the rate law, only Neu5Ac is measured</a:t>
             </a:r>
           </a:p>
           <a:p>
             <a:r>
-              <a:rPr b="1"/>
+              <a:rPr b="1" sz="1500"/>
               <a:t>Infer the kinetic parameters: </a:t>
             </a:r>
             <a:r>
-              <a:rPr i="1"/>
+              <a:rPr i="1" sz="1500"/>
               <a:t>k</a:t>
             </a:r>
             <a:r>
-              <a:rPr baseline="-25000"/>
+              <a:rPr sz="1500" baseline="-25000"/>
               <a:t>cat</a:t>
             </a:r>
             <a:r>
-              <a:rPr/>
+              <a:rPr sz="1500"/>
               <a:t>, </a:t>
             </a:r>
             <a:r>
-              <a:rPr i="1"/>
+              <a:rPr i="1" sz="1500"/>
               <a:t>K</a:t>
             </a:r>
             <a:r>
-              <a:rPr i="1" baseline="-25000"/>
+              <a:rPr i="1" sz="1500" baseline="-25000"/>
               <a:t>M</a:t>
             </a:r>
             <a:r>
-              <a:rPr baseline="30000"/>
+              <a:rPr sz="1500" baseline="30000"/>
               <a:t>ManNAc</a:t>
             </a:r>
             <a:r>
-              <a:rPr/>
+              <a:rPr sz="1500"/>
               <a:t> and </a:t>
             </a:r>
             <a:r>
-              <a:rPr i="1"/>
+              <a:rPr i="1" sz="1500"/>
               <a:t>K</a:t>
             </a:r>
             <a:r>
-              <a:rPr i="1" baseline="-25000"/>
+              <a:rPr i="1" sz="1500" baseline="-25000"/>
               <a:t>M</a:t>
             </a:r>
             <a:r>
-              <a:rPr baseline="30000"/>
+              <a:rPr sz="1500" baseline="30000"/>
               <a:t>PEP</a:t>
             </a:r>
             <a:r>
-              <a:rPr/>
+              <a:rPr sz="1500"/>
               <a:t>, each with its uncertainty</a:t>
             </a:r>
           </a:p>
           <a:p>
             <a:r>
-              <a:rPr b="1"/>
+              <a:rPr b="1" sz="1500"/>
               <a:t>Check the sampler: </a:t>
             </a:r>
             <a:r>
-              <a:rPr/>
+              <a:rPr sz="1500"/>
               <a:t>do the chains agree, divergences, posterior clear of the prior bounds?</a:t>
             </a:r>
           </a:p>
           <a:p>
             <a:r>
-              <a:rPr b="1"/>
+              <a:rPr b="1" sz="1500"/>
               <a:t>What is the correlation between the kinetic parameters?</a:t>
             </a:r>
           </a:p>
           <a:p>
             <a:r>
-              <a:rPr b="1"/>
+              <a:rPr b="1" sz="1500"/>
               <a:t>Does one model describe both series? </a:t>
             </a:r>
             <a:r>
-              <a:rPr/>
+              <a:rPr sz="1500"/>
               <a:t>plot data and model together</a:t>
             </a:r>
           </a:p>
@@ -4359,7 +4424,82 @@
       </p:sp>
       <p:sp>
         <p:nvSpPr>
-          <p:cNvPr id="4" name="Text Placeholder 3"/>
+          <p:cNvPr id="4" name="Content Placeholder 3"/>
+          <p:cNvSpPr>
+            <a:spLocks noGrp="1"/>
+          </p:cNvSpPr>
+          <p:nvPr>
+            <p:ph idx="2" sz="half"/>
+          </p:nvPr>
+        </p:nvSpPr>
+        <p:spPr/>
+        <p:txBody>
+          <a:bodyPr/>
+          <a:lstStyle/>
+          <a:p>
+            <a:pPr marL="0" indent="0">
+              <a:buNone/>
+            </a:pPr>
+            <a:r>
+              <a:rPr b="1" sz="1500"/>
+              <a:t>How to do it</a:t>
+            </a:r>
+          </a:p>
+          <a:p>
+            <a:r>
+              <a:rPr b="1" sz="1500"/>
+              <a:t>Coding assistant on your machine </a:t>
+            </a:r>
+            <a:r>
+              <a:rPr sz="1500"/>
+              <a:t>(Claude Code, Codex, Cursor, …): open the repository, give it briefs/catalax.md and briefs/task_2_kinetic_model.md, then say: let's start with task 2</a:t>
+            </a:r>
+          </a:p>
+          <a:p>
+            <a:r>
+              <a:rPr b="1" sz="1500"/>
+              <a:t>Chat assistant only </a:t>
+            </a:r>
+            <a:r>
+              <a:rPr sz="1500"/>
+              <a:t>(ChatGPT, Claude, Gemini, …): open the Colab starter notebook from the README, paste the two cards into the chat, run its code in the notebook</a:t>
+            </a:r>
+          </a:p>
+          <a:p>
+            <a:r>
+              <a:rPr b="1" sz="1500"/>
+              <a:t>No assistant that runs code? </a:t>
+            </a:r>
+            <a:r>
+              <a:rPr sz="1500"/>
+              <a:t>team up with someone who has one</a:t>
+            </a:r>
+          </a:p>
+          <a:p>
+            <a:r>
+              <a:rPr b="1" sz="1500"/>
+              <a:t>No result from task 1? </a:t>
+            </a:r>
+            <a:r>
+              <a:rPr sz="1500"/>
+              <a:t>start from checkpoints/neus_enzymeml.json</a:t>
+            </a:r>
+          </a:p>
+          <a:p>
+            <a:r>
+              <a:rPr b="1" sz="1500"/>
+              <a:t>Repository, data and cards: </a:t>
+            </a:r>
+            <a:r>
+              <a:rPr sz="1500"/>
+              <a:t>tinyurl.com/enzymeml2026</a:t>
+            </a:r>
+          </a:p>
+        </p:txBody>
+      </p:sp>
+      <p:sp>
+        <p:nvSpPr>
+          <p:cNvPr id="5" name="Text Placeholder 4"/>
           <p:cNvSpPr>
             <a:spLocks noGrp="1"/>
           </p:cNvSpPr>
@@ -4381,7 +4521,7 @@
       </p:sp>
       <p:sp>
         <p:nvSpPr>
-          <p:cNvPr id="5" name="Text Placeholder 4"/>
+          <p:cNvPr id="6" name="Text Placeholder 5"/>
           <p:cNvSpPr>
             <a:spLocks noGrp="1"/>
           </p:cNvSpPr>

</xml_diff>

<commit_message>
Task slides: headlines only, details in the README (sections How to do it, Task 1, Task 2)
Co-Authored-By: Claude Fable 5.1 <noreply@anthropic.com>
</commit_message>
<xml_diff>
--- a/slides/workshop.pptx
+++ b/slides/workshop.pptx
@@ -4110,117 +4110,126 @@
           <a:bodyPr/>
           <a:lstStyle/>
           <a:p>
-            <a:r>
-              <a:rPr b="1" sz="1500"/>
-              <a:t>Plot the data: </a:t>
-            </a:r>
-            <a:r>
-              <a:rPr sz="1500"/>
-              <a:t>all peaks of all injections; where does Neu5Ac elute?</a:t>
-            </a:r>
-          </a:p>
-          <a:p>
-            <a:r>
-              <a:rPr b="1" sz="1500"/>
-              <a:t>Check how the kinetic assay was designed: </a:t>
-            </a:r>
-            <a:r>
-              <a:rPr sz="1500"/>
-              <a:t>how many reactions, what was varied, what was fixed?</a:t>
-            </a:r>
-          </a:p>
-          <a:p>
-            <a:r>
-              <a:rPr b="1" sz="1500"/>
-              <a:t>Calibrate: </a:t>
-            </a:r>
-            <a:r>
-              <a:rPr sz="1500"/>
-              <a:t>what are the calibration parameters, and how well does the line fit?</a:t>
-            </a:r>
-          </a:p>
-          <a:p>
-            <a:r>
-              <a:rPr b="1" sz="1500"/>
-              <a:t>Set the retention window </a:t>
-            </a:r>
-            <a:r>
-              <a:rPr sz="1500"/>
-              <a:t>for the reactions (it differs from the standards) and assign the peak</a:t>
-            </a:r>
-          </a:p>
-          <a:p>
-            <a:r>
-              <a:rPr b="1" sz="1500"/>
-              <a:t>Export the EnzymeML document: </a:t>
-            </a:r>
-            <a:r>
-              <a:rPr sz="1500"/>
-              <a:t>every reaction with all its time points; which reactions form product?</a:t>
-            </a:r>
-          </a:p>
-        </p:txBody>
-      </p:sp>
-      <p:sp>
-        <p:nvSpPr>
-          <p:cNvPr id="4" name="Content Placeholder 3"/>
-          <p:cNvSpPr>
-            <a:spLocks noGrp="1"/>
-          </p:cNvSpPr>
-          <p:nvPr>
-            <p:ph idx="2" sz="half"/>
-          </p:nvPr>
-        </p:nvSpPr>
-        <p:spPr/>
-        <p:txBody>
-          <a:bodyPr/>
-          <a:lstStyle/>
-          <a:p>
             <a:pPr marL="0" indent="0">
               <a:buNone/>
             </a:pPr>
             <a:r>
-              <a:rPr b="1" sz="1500"/>
+              <a:rPr b="1"/>
+              <a:t>Tasks</a:t>
+            </a:r>
+          </a:p>
+          <a:p>
+            <a:r>
+              <a:rPr/>
+              <a:t>Plot the data</a:t>
+            </a:r>
+          </a:p>
+          <a:p>
+            <a:r>
+              <a:rPr/>
+              <a:t>Check how the kinetic assay was designed</a:t>
+            </a:r>
+          </a:p>
+          <a:p>
+            <a:r>
+              <a:rPr/>
+              <a:t>Calibrate: the calibration parameters</a:t>
+            </a:r>
+          </a:p>
+          <a:p>
+            <a:r>
+              <a:rPr/>
+              <a:t>Assign the product peak in the reactions</a:t>
+            </a:r>
+          </a:p>
+          <a:p>
+            <a:r>
+              <a:rPr/>
+              <a:t>Export the EnzymeML document</a:t>
+            </a:r>
+          </a:p>
+          <a:p>
+            <a:r>
+              <a:rPr b="1"/>
+              <a:t>Details: </a:t>
+            </a:r>
+            <a:r>
+              <a:rPr/>
+              <a:t>README, section Task 1</a:t>
+            </a:r>
+          </a:p>
+        </p:txBody>
+      </p:sp>
+      <p:sp>
+        <p:nvSpPr>
+          <p:cNvPr id="4" name="Content Placeholder 3"/>
+          <p:cNvSpPr>
+            <a:spLocks noGrp="1"/>
+          </p:cNvSpPr>
+          <p:nvPr>
+            <p:ph idx="2" sz="half"/>
+          </p:nvPr>
+        </p:nvSpPr>
+        <p:spPr/>
+        <p:txBody>
+          <a:bodyPr/>
+          <a:lstStyle/>
+          <a:p>
+            <a:pPr marL="0" indent="0">
+              <a:buNone/>
+            </a:pPr>
+            <a:r>
+              <a:rPr b="1"/>
               <a:t>How to do it</a:t>
             </a:r>
           </a:p>
           <a:p>
             <a:r>
-              <a:rPr b="1" sz="1500"/>
-              <a:t>Coding assistant on your machine </a:t>
-            </a:r>
-            <a:r>
-              <a:rPr sz="1500"/>
-              <a:t>(Claude Code, Codex, Cursor, …): open the repository, give it briefs/chromhandler.md and briefs/task_1_chromatograms_to_enzymeml.md, then say: let's start with task 1</a:t>
-            </a:r>
-          </a:p>
-          <a:p>
-            <a:r>
-              <a:rPr b="1" sz="1500"/>
-              <a:t>Chat assistant only </a:t>
-            </a:r>
-            <a:r>
-              <a:rPr sz="1500"/>
-              <a:t>(ChatGPT, Claude, Gemini, …): open the Colab starter notebook from the README, paste the two cards into the chat, run its code in the notebook</a:t>
-            </a:r>
-          </a:p>
-          <a:p>
-            <a:r>
-              <a:rPr b="1" sz="1500"/>
+              <a:rPr b="1"/>
+              <a:t>Coding assistant on your computer: </a:t>
+            </a:r>
+            <a:r>
+              <a:rPr/>
+              <a:t>the cards in briefs/</a:t>
+            </a:r>
+          </a:p>
+          <a:p>
+            <a:r>
+              <a:rPr b="1"/>
+              <a:t>Chat assistant only: </a:t>
+            </a:r>
+            <a:r>
+              <a:rPr/>
+              <a:t>the Colab starter notebook</a:t>
+            </a:r>
+          </a:p>
+          <a:p>
+            <a:r>
+              <a:rPr b="1"/>
               <a:t>No assistant that runs code? </a:t>
             </a:r>
             <a:r>
-              <a:rPr sz="1500"/>
-              <a:t>team up with someone who has one</a:t>
-            </a:r>
-          </a:p>
-          <a:p>
-            <a:r>
-              <a:rPr b="1" sz="1500"/>
-              <a:t>Repository, data and cards: </a:t>
-            </a:r>
-            <a:r>
-              <a:rPr sz="1500"/>
+              <a:rPr/>
+              <a:t>team up</a:t>
+            </a:r>
+          </a:p>
+          <a:p>
+            <a:r>
+              <a:rPr b="1"/>
+              <a:t>Details: </a:t>
+            </a:r>
+            <a:r>
+              <a:rPr/>
+              <a:t>README, section How to do it</a:t>
+            </a:r>
+          </a:p>
+          <a:p>
+            <a:r>
+              <a:rPr b="1"/>
+              <a:t>Repository: </a:t>
+            </a:r>
+            <a:r>
+              <a:rPr/>
               <a:t>tinyurl.com/enzymeml2026</a:t>
             </a:r>
           </a:p>
@@ -4325,173 +4334,126 @@
           <a:bodyPr/>
           <a:lstStyle/>
           <a:p>
-            <a:r>
-              <a:rPr b="1" sz="1500"/>
-              <a:t>Plot the time courses </a:t>
-            </a:r>
-            <a:r>
-              <a:rPr sz="1500"/>
-              <a:t>from the EnzymeML document</a:t>
-            </a:r>
-          </a:p>
-          <a:p>
-            <a:r>
-              <a:rPr b="1" sz="1500"/>
-              <a:t>Define the model and the priors: </a:t>
-            </a:r>
-            <a:r>
-              <a:rPr sz="1500"/>
-              <a:t>the enzyme is in the rate law, only Neu5Ac is measured</a:t>
-            </a:r>
-          </a:p>
-          <a:p>
-            <a:r>
-              <a:rPr b="1" sz="1500"/>
-              <a:t>Infer the kinetic parameters: </a:t>
-            </a:r>
-            <a:r>
-              <a:rPr i="1" sz="1500"/>
-              <a:t>k</a:t>
-            </a:r>
-            <a:r>
-              <a:rPr sz="1500" baseline="-25000"/>
-              <a:t>cat</a:t>
-            </a:r>
-            <a:r>
-              <a:rPr sz="1500"/>
-              <a:t>, </a:t>
-            </a:r>
-            <a:r>
-              <a:rPr i="1" sz="1500"/>
-              <a:t>K</a:t>
-            </a:r>
-            <a:r>
-              <a:rPr i="1" sz="1500" baseline="-25000"/>
-              <a:t>M</a:t>
-            </a:r>
-            <a:r>
-              <a:rPr sz="1500" baseline="30000"/>
-              <a:t>ManNAc</a:t>
-            </a:r>
-            <a:r>
-              <a:rPr sz="1500"/>
-              <a:t> and </a:t>
-            </a:r>
-            <a:r>
-              <a:rPr i="1" sz="1500"/>
-              <a:t>K</a:t>
-            </a:r>
-            <a:r>
-              <a:rPr i="1" sz="1500" baseline="-25000"/>
-              <a:t>M</a:t>
-            </a:r>
-            <a:r>
-              <a:rPr sz="1500" baseline="30000"/>
-              <a:t>PEP</a:t>
-            </a:r>
-            <a:r>
-              <a:rPr sz="1500"/>
-              <a:t>, each with its uncertainty</a:t>
-            </a:r>
-          </a:p>
-          <a:p>
-            <a:r>
-              <a:rPr b="1" sz="1500"/>
-              <a:t>Check the sampler: </a:t>
-            </a:r>
-            <a:r>
-              <a:rPr sz="1500"/>
-              <a:t>do the chains agree, divergences, posterior clear of the prior bounds?</a:t>
-            </a:r>
-          </a:p>
-          <a:p>
-            <a:r>
-              <a:rPr b="1" sz="1500"/>
-              <a:t>What is the correlation between the kinetic parameters?</a:t>
-            </a:r>
-          </a:p>
-          <a:p>
-            <a:r>
-              <a:rPr b="1" sz="1500"/>
-              <a:t>Does one model describe both series? </a:t>
-            </a:r>
-            <a:r>
-              <a:rPr sz="1500"/>
-              <a:t>plot data and model together</a:t>
-            </a:r>
-          </a:p>
-        </p:txBody>
-      </p:sp>
-      <p:sp>
-        <p:nvSpPr>
-          <p:cNvPr id="4" name="Content Placeholder 3"/>
-          <p:cNvSpPr>
-            <a:spLocks noGrp="1"/>
-          </p:cNvSpPr>
-          <p:nvPr>
-            <p:ph idx="2" sz="half"/>
-          </p:nvPr>
-        </p:nvSpPr>
-        <p:spPr/>
-        <p:txBody>
-          <a:bodyPr/>
-          <a:lstStyle/>
-          <a:p>
             <a:pPr marL="0" indent="0">
               <a:buNone/>
             </a:pPr>
             <a:r>
-              <a:rPr b="1" sz="1500"/>
+              <a:rPr b="1"/>
+              <a:t>Tasks</a:t>
+            </a:r>
+          </a:p>
+          <a:p>
+            <a:r>
+              <a:rPr/>
+              <a:t>Plot the time courses</a:t>
+            </a:r>
+          </a:p>
+          <a:p>
+            <a:r>
+              <a:rPr/>
+              <a:t>Define the model and the priors</a:t>
+            </a:r>
+          </a:p>
+          <a:p>
+            <a:r>
+              <a:rPr/>
+              <a:t>Infer the kinetic parameters and their uncertainty</a:t>
+            </a:r>
+          </a:p>
+          <a:p>
+            <a:r>
+              <a:rPr/>
+              <a:t>The correlation between the kinetic parameters</a:t>
+            </a:r>
+          </a:p>
+          <a:p>
+            <a:r>
+              <a:rPr/>
+              <a:t>Does one model describe both series?</a:t>
+            </a:r>
+          </a:p>
+          <a:p>
+            <a:r>
+              <a:rPr b="1"/>
+              <a:t>Details: </a:t>
+            </a:r>
+            <a:r>
+              <a:rPr/>
+              <a:t>README, section Task 2</a:t>
+            </a:r>
+          </a:p>
+        </p:txBody>
+      </p:sp>
+      <p:sp>
+        <p:nvSpPr>
+          <p:cNvPr id="4" name="Content Placeholder 3"/>
+          <p:cNvSpPr>
+            <a:spLocks noGrp="1"/>
+          </p:cNvSpPr>
+          <p:nvPr>
+            <p:ph idx="2" sz="half"/>
+          </p:nvPr>
+        </p:nvSpPr>
+        <p:spPr/>
+        <p:txBody>
+          <a:bodyPr/>
+          <a:lstStyle/>
+          <a:p>
+            <a:pPr marL="0" indent="0">
+              <a:buNone/>
+            </a:pPr>
+            <a:r>
+              <a:rPr b="1"/>
               <a:t>How to do it</a:t>
             </a:r>
           </a:p>
           <a:p>
             <a:r>
-              <a:rPr b="1" sz="1500"/>
-              <a:t>Coding assistant on your machine </a:t>
-            </a:r>
-            <a:r>
-              <a:rPr sz="1500"/>
-              <a:t>(Claude Code, Codex, Cursor, …): open the repository, give it briefs/catalax.md and briefs/task_2_kinetic_model.md, then say: let's start with task 2</a:t>
-            </a:r>
-          </a:p>
-          <a:p>
-            <a:r>
-              <a:rPr b="1" sz="1500"/>
-              <a:t>Chat assistant only </a:t>
-            </a:r>
-            <a:r>
-              <a:rPr sz="1500"/>
-              <a:t>(ChatGPT, Claude, Gemini, …): open the Colab starter notebook from the README, paste the two cards into the chat, run its code in the notebook</a:t>
-            </a:r>
-          </a:p>
-          <a:p>
-            <a:r>
-              <a:rPr b="1" sz="1500"/>
+              <a:rPr b="1"/>
+              <a:t>Coding assistant on your computer: </a:t>
+            </a:r>
+            <a:r>
+              <a:rPr/>
+              <a:t>the cards in briefs/</a:t>
+            </a:r>
+          </a:p>
+          <a:p>
+            <a:r>
+              <a:rPr b="1"/>
+              <a:t>Chat assistant only: </a:t>
+            </a:r>
+            <a:r>
+              <a:rPr/>
+              <a:t>the Colab starter notebook</a:t>
+            </a:r>
+          </a:p>
+          <a:p>
+            <a:r>
+              <a:rPr b="1"/>
               <a:t>No assistant that runs code? </a:t>
             </a:r>
             <a:r>
-              <a:rPr sz="1500"/>
-              <a:t>team up with someone who has one</a:t>
-            </a:r>
-          </a:p>
-          <a:p>
-            <a:r>
-              <a:rPr b="1" sz="1500"/>
-              <a:t>No result from task 1? </a:t>
-            </a:r>
-            <a:r>
-              <a:rPr sz="1500"/>
-              <a:t>start from checkpoints/neus_enzymeml.json</a:t>
-            </a:r>
-          </a:p>
-          <a:p>
-            <a:r>
-              <a:rPr b="1" sz="1500"/>
-              <a:t>Repository, data and cards: </a:t>
-            </a:r>
-            <a:r>
-              <a:rPr sz="1500"/>
+              <a:rPr/>
+              <a:t>team up</a:t>
+            </a:r>
+          </a:p>
+          <a:p>
+            <a:r>
+              <a:rPr b="1"/>
+              <a:t>Details: </a:t>
+            </a:r>
+            <a:r>
+              <a:rPr/>
+              <a:t>README, section How to do it</a:t>
+            </a:r>
+          </a:p>
+          <a:p>
+            <a:r>
+              <a:rPr b="1"/>
+              <a:t>Repository: </a:t>
+            </a:r>
+            <a:r>
+              <a:rPr/>
               <a:t>tinyurl.com/enzymeml2026</a:t>
             </a:r>
           </a:p>

</xml_diff>

<commit_message>
Deck: one hands-on slide (two tasks, how to get started) replaces the four task and toolkit slides
Co-Authored-By: Claude Fable 5.1 <noreply@anthropic.com>
</commit_message>
<xml_diff>
--- a/slides/workshop.pptx
+++ b/slides/workshop.pptx
@@ -18,9 +18,6 @@
     <p:sldId id="266" r:id="rId18"/>
     <p:sldId id="267" r:id="rId19"/>
     <p:sldId id="268" r:id="rId20"/>
-    <p:sldId id="269" r:id="rId21"/>
-    <p:sldId id="270" r:id="rId22"/>
-    <p:sldId id="271" r:id="rId23"/>
   </p:sldIdLst>
   <p:sldSz cx="12191695" cy="6858000" type="screen4x3"/>
   <p:notesSz cx="6858000" cy="9144000"/>
@@ -587,7 +584,7 @@
           <a:lstStyle/>
           <a:p>
             <a:r>
-              <a:t>9:15 · 1 min. Task 1 with Chromhandler, task 2 with Catalax. Live demo first, then you work in pairs; the checks in the task card decide when you are done. Timing: demo 9:15, hands-on 9:30, break 10:15–10:30, demo 10:30, hands-on 10:40. At 11:25 we collect everybody's kcat and Km on one slide or the whiteboard, wrap-up 11:50.</a:t>
+              <a:t>9:15 · 2 min, then this slide stays on the projector. Task 1 with Chromhandler, task 2 with Catalax; the README has the detailed tasks (what to look for in the data) and the three ways to work. Live demo of task 1 first (9:15), hands-on from 9:30, break 10:15, demo of task 2 10:30, hands-on 10:40, comparison of everybody's parameters at 11:25. Those without an assistant that runs code team up; those stuck in task 1 start task 2 from the checkpoint.</a:t>
             </a:r>
           </a:p>
         </p:txBody>
@@ -657,7 +654,7 @@
           <a:lstStyle/>
           <a:p>
             <a:r>
-              <a:t>9:16 · 3 min. README first. Two ways. With a language model: any chat model, free or by subscription (ChatGPT, Claude, Gemini, …); paste the tool card, then the task card; run the code it writes; paste errors back; the checks decide. Without writing code: the Colab link opens a prepared notebook with the tools installed and the data loaded; run it cell by cell, change a window, a prior, a series; ask the model inside Colab to explain any cell. notebooks/ are the reference solutions, open to everyone; checkpoints/ holds the result of task 1. Locally: uv sync.</a:t>
+              <a:t>11:25 · 25 min. First collect everybody's kcat, Km_ManNAc, Km_PEP: how much do they differ and why (windows, priors, reactions used)? Then the misfit: one shared kcat over-predicts the ManNAc series and under-predicts the PEP series; the series were measured on different days and differ by roughly 25 % in activity. Ask: a per-day activity factor, a new experiment, both? Which decisions did the assistant try to make for you, and which did you take back?</a:t>
             </a:r>
           </a:p>
         </p:txBody>
@@ -727,7 +724,7 @@
           <a:lstStyle/>
           <a:p>
             <a:r>
-              <a:t>9:15 · Live demo 15 min, then hands-on 9:30–10:15. Demo: paste chromhandler.md, then the task card, then 'Let's start with task 1'. Let the assistant read the data and answer the first question; show the peak plot. Accept the calibration explicitly ('my decision, not the assistant's'). Deliberate mistake: when asked for the reaction window, say 'the same as the standards'; chromhandler warns 'No peaks found for Neu5Ac', the document has no Neu5Ac values. Say why (the shift on the peak plot), correct it, continue. The questions on the slide are what every pair answers; we compare at 11:25.</a:t>
+              <a:t>11:50 · 10 min. Take-home and feedback round. Ask explicitly what did not work: that is what we need to improve the cards. The cards are reusable as SKILL.md / AGENTS.md for coding agents.</a:t>
             </a:r>
           </a:p>
         </p:txBody>
@@ -753,216 +750,6 @@
 </file>
 
 <file path=ppt/notesSlides/notesSlide13.xml><?xml version="1.0" encoding="utf-8"?>
-<p:notes xmlns:a="http://schemas.openxmlformats.org/drawingml/2006/main" xmlns:p="http://schemas.openxmlformats.org/presentationml/2006/main" xmlns:r="http://schemas.openxmlformats.org/officeDocument/2006/relationships">
-  <p:cSld>
-    <p:spTree>
-      <p:nvGrpSpPr>
-        <p:cNvPr id="1" name=""/>
-        <p:cNvGrpSpPr/>
-        <p:nvPr/>
-      </p:nvGrpSpPr>
-      <p:grpSpPr>
-        <a:xfrm>
-          <a:off x="0" y="0"/>
-          <a:ext cx="0" cy="0"/>
-          <a:chOff x="0" y="0"/>
-          <a:chExt cx="0" cy="0"/>
-        </a:xfrm>
-      </p:grpSpPr>
-      <p:sp>
-        <p:nvSpPr>
-          <p:cNvPr id="2" name="Slide Image Placeholder 1"/>
-          <p:cNvSpPr>
-            <a:spLocks noGrp="1"/>
-          </p:cNvSpPr>
-          <p:nvPr>
-            <p:ph type="sldImg" idx="2"/>
-          </p:nvPr>
-        </p:nvSpPr>
-        <p:spPr/>
-      </p:sp>
-      <p:sp>
-        <p:nvSpPr>
-          <p:cNvPr id="3" name="Notes Placeholder 2"/>
-          <p:cNvSpPr>
-            <a:spLocks noGrp="1"/>
-          </p:cNvSpPr>
-          <p:nvPr>
-            <p:ph type="body" idx="3" sz="quarter"/>
-          </p:nvPr>
-        </p:nvSpPr>
-        <p:spPr/>
-        <p:txBody>
-          <a:bodyPr/>
-          <a:lstStyle/>
-          <a:p>
-            <a:r>
-              <a:t>10:30 · Live demo 10 min, then hands-on 10:40–11:25. Paste catalax.md, then the task card. enable_x64 first. Only Neu5Ac has data; in Catalax 0.5.5 every state stays observable and the unmeasured ones get NaN arrays (observable=False breaks the sampler in this version). The priors and the sampler settings are in the card; they are decisions, say so. Show the posterior table, the trace and the fit plot. Those who did not finish task 1 start from checkpoints/neus_enzymeml.json.</a:t>
-            </a:r>
-          </a:p>
-        </p:txBody>
-      </p:sp>
-      <p:sp>
-        <p:nvSpPr>
-          <p:cNvPr id="4" name="Slide Number Placeholder 3"/>
-          <p:cNvSpPr>
-            <a:spLocks noGrp="1"/>
-          </p:cNvSpPr>
-          <p:nvPr>
-            <p:ph type="sldNum" idx="5" sz="quarter"/>
-          </p:nvPr>
-        </p:nvSpPr>
-        <p:spPr/>
-      </p:sp>
-    </p:spTree>
-  </p:cSld>
-  <p:clrMapOvr>
-    <a:masterClrMapping/>
-  </p:clrMapOvr>
-</p:notes>
-</file>
-
-<file path=ppt/notesSlides/notesSlide14.xml><?xml version="1.0" encoding="utf-8"?>
-<p:notes xmlns:a="http://schemas.openxmlformats.org/drawingml/2006/main" xmlns:p="http://schemas.openxmlformats.org/presentationml/2006/main" xmlns:r="http://schemas.openxmlformats.org/officeDocument/2006/relationships">
-  <p:cSld>
-    <p:spTree>
-      <p:nvGrpSpPr>
-        <p:cNvPr id="1" name=""/>
-        <p:cNvGrpSpPr/>
-        <p:nvPr/>
-      </p:nvGrpSpPr>
-      <p:grpSpPr>
-        <a:xfrm>
-          <a:off x="0" y="0"/>
-          <a:ext cx="0" cy="0"/>
-          <a:chOff x="0" y="0"/>
-          <a:chExt cx="0" cy="0"/>
-        </a:xfrm>
-      </p:grpSpPr>
-      <p:sp>
-        <p:nvSpPr>
-          <p:cNvPr id="2" name="Slide Image Placeholder 1"/>
-          <p:cNvSpPr>
-            <a:spLocks noGrp="1"/>
-          </p:cNvSpPr>
-          <p:nvPr>
-            <p:ph type="sldImg" idx="2"/>
-          </p:nvPr>
-        </p:nvSpPr>
-        <p:spPr/>
-      </p:sp>
-      <p:sp>
-        <p:nvSpPr>
-          <p:cNvPr id="3" name="Notes Placeholder 2"/>
-          <p:cNvSpPr>
-            <a:spLocks noGrp="1"/>
-          </p:cNvSpPr>
-          <p:nvPr>
-            <p:ph type="body" idx="3" sz="quarter"/>
-          </p:nvPr>
-        </p:nvSpPr>
-        <p:spPr/>
-        <p:txBody>
-          <a:bodyPr/>
-          <a:lstStyle/>
-          <a:p>
-            <a:r>
-              <a:t>11:25 · 25 min. First collect everybody's kcat, Km_ManNAc, Km_PEP: how much do they differ and why (windows, priors, reactions used)? Then the misfit: one shared kcat over-predicts the ManNAc series and under-predicts the PEP series; the series were measured on different days and differ by roughly 25 % in activity. Ask: a per-day activity factor, a new experiment, both? Which decisions did the assistant try to make for you, and which did you take back?</a:t>
-            </a:r>
-          </a:p>
-        </p:txBody>
-      </p:sp>
-      <p:sp>
-        <p:nvSpPr>
-          <p:cNvPr id="4" name="Slide Number Placeholder 3"/>
-          <p:cNvSpPr>
-            <a:spLocks noGrp="1"/>
-          </p:cNvSpPr>
-          <p:nvPr>
-            <p:ph type="sldNum" idx="5" sz="quarter"/>
-          </p:nvPr>
-        </p:nvSpPr>
-        <p:spPr/>
-      </p:sp>
-    </p:spTree>
-  </p:cSld>
-  <p:clrMapOvr>
-    <a:masterClrMapping/>
-  </p:clrMapOvr>
-</p:notes>
-</file>
-
-<file path=ppt/notesSlides/notesSlide15.xml><?xml version="1.0" encoding="utf-8"?>
-<p:notes xmlns:a="http://schemas.openxmlformats.org/drawingml/2006/main" xmlns:p="http://schemas.openxmlformats.org/presentationml/2006/main" xmlns:r="http://schemas.openxmlformats.org/officeDocument/2006/relationships">
-  <p:cSld>
-    <p:spTree>
-      <p:nvGrpSpPr>
-        <p:cNvPr id="1" name=""/>
-        <p:cNvGrpSpPr/>
-        <p:nvPr/>
-      </p:nvGrpSpPr>
-      <p:grpSpPr>
-        <a:xfrm>
-          <a:off x="0" y="0"/>
-          <a:ext cx="0" cy="0"/>
-          <a:chOff x="0" y="0"/>
-          <a:chExt cx="0" cy="0"/>
-        </a:xfrm>
-      </p:grpSpPr>
-      <p:sp>
-        <p:nvSpPr>
-          <p:cNvPr id="2" name="Slide Image Placeholder 1"/>
-          <p:cNvSpPr>
-            <a:spLocks noGrp="1"/>
-          </p:cNvSpPr>
-          <p:nvPr>
-            <p:ph type="sldImg" idx="2"/>
-          </p:nvPr>
-        </p:nvSpPr>
-        <p:spPr/>
-      </p:sp>
-      <p:sp>
-        <p:nvSpPr>
-          <p:cNvPr id="3" name="Notes Placeholder 2"/>
-          <p:cNvSpPr>
-            <a:spLocks noGrp="1"/>
-          </p:cNvSpPr>
-          <p:nvPr>
-            <p:ph type="body" idx="3" sz="quarter"/>
-          </p:nvPr>
-        </p:nvSpPr>
-        <p:spPr/>
-        <p:txBody>
-          <a:bodyPr/>
-          <a:lstStyle/>
-          <a:p>
-            <a:r>
-              <a:t>11:50 · 10 min. Take-home and feedback round. Ask explicitly what did not work: that is what we need to improve the cards. The cards are reusable as SKILL.md / AGENTS.md for coding agents.</a:t>
-            </a:r>
-          </a:p>
-        </p:txBody>
-      </p:sp>
-      <p:sp>
-        <p:nvSpPr>
-          <p:cNvPr id="4" name="Slide Number Placeholder 3"/>
-          <p:cNvSpPr>
-            <a:spLocks noGrp="1"/>
-          </p:cNvSpPr>
-          <p:nvPr>
-            <p:ph type="sldNum" idx="5" sz="quarter"/>
-          </p:nvPr>
-        </p:nvSpPr>
-        <p:spPr/>
-      </p:sp>
-    </p:spTree>
-  </p:cSld>
-  <p:clrMapOvr>
-    <a:masterClrMapping/>
-  </p:clrMapOvr>
-</p:notes>
-</file>
-
-<file path=ppt/notesSlides/notesSlide16.xml><?xml version="1.0" encoding="utf-8"?>
 <p:notes xmlns:a="http://schemas.openxmlformats.org/drawingml/2006/main" xmlns:p="http://schemas.openxmlformats.org/presentationml/2006/main" xmlns:r="http://schemas.openxmlformats.org/officeDocument/2006/relationships">
   <p:cSld>
     <p:spTree>
@@ -3746,7 +3533,7 @@
           <a:p>
             <a:r>
               <a:rPr/>
-              <a:t>What we do today</a:t>
+              <a:t>Two tasks, one repository</a:t>
             </a:r>
           </a:p>
         </p:txBody>
@@ -3758,7 +3545,7 @@
             <a:spLocks noGrp="1"/>
           </p:cNvSpPr>
           <p:nvPr>
-            <p:ph idx="1"/>
+            <p:ph idx="1" sz="half"/>
           </p:nvPr>
         </p:nvSpPr>
         <p:spPr/>
@@ -3766,23 +3553,32 @@
           <a:bodyPr/>
           <a:lstStyle/>
           <a:p>
+            <a:pPr marL="0" indent="0">
+              <a:buNone/>
+            </a:pPr>
             <a:r>
               <a:rPr b="1"/>
-              <a:t>Task 1: </a:t>
+              <a:t>Tasks</a:t>
+            </a:r>
+          </a:p>
+          <a:p>
+            <a:r>
+              <a:rPr b="1"/>
+              <a:t>Task 1 · chromatograms to EnzymeML: </a:t>
             </a:r>
             <a:r>
               <a:rPr/>
-              <a:t>from the peak tables to an EnzymeML document (Chromhandler)</a:t>
+              <a:t>plot the data, check the assay design, calibrate, export the document</a:t>
             </a:r>
           </a:p>
           <a:p>
             <a:r>
               <a:rPr b="1"/>
-              <a:t>Task 2: </a:t>
+              <a:t>Task 2 · kinetic parameters: </a:t>
             </a:r>
             <a:r>
               <a:rPr/>
-              <a:t>from the EnzymeML document to </a:t>
+              <a:t>infer </a:t>
             </a:r>
             <a:r>
               <a:rPr i="1"/>
@@ -3806,32 +3602,89 @@
             </a:r>
             <a:r>
               <a:rPr/>
-              <a:t> by Bayesian inference (Catalax)</a:t>
-            </a:r>
-          </a:p>
-          <a:p>
+              <a:t> with their uncertainty and correlation; does the model describe the data?</a:t>
+            </a:r>
+          </a:p>
+          <a:p>
+            <a:r>
+              <a:rPr b="1"/>
+              <a:t>At the end </a:t>
+            </a:r>
             <a:r>
               <a:rPr/>
-              <a:t>A live demo of each task first, then you work in pairs</a:t>
-            </a:r>
-          </a:p>
-          <a:p>
+              <a:t>we compare everybody's parameters</a:t>
+            </a:r>
+          </a:p>
+        </p:txBody>
+      </p:sp>
+      <p:sp>
+        <p:nvSpPr>
+          <p:cNvPr id="4" name="Content Placeholder 3"/>
+          <p:cNvSpPr>
+            <a:spLocks noGrp="1"/>
+          </p:cNvSpPr>
+          <p:nvPr>
+            <p:ph idx="2" sz="half"/>
+          </p:nvPr>
+        </p:nvSpPr>
+        <p:spPr/>
+        <p:txBody>
+          <a:bodyPr/>
+          <a:lstStyle/>
+          <a:p>
+            <a:pPr marL="0" indent="0">
+              <a:buNone/>
+            </a:pPr>
+            <a:r>
+              <a:rPr b="1"/>
+              <a:t>How to get started</a:t>
+            </a:r>
+          </a:p>
+          <a:p>
+            <a:r>
+              <a:rPr b="1"/>
+              <a:t>Coding assistant on your computer: </a:t>
+            </a:r>
             <a:r>
               <a:rPr/>
-              <a:t>The checks in the task card say when you are done</a:t>
-            </a:r>
-          </a:p>
-          <a:p>
+              <a:t>give it the cards in briefs/</a:t>
+            </a:r>
+          </a:p>
+          <a:p>
+            <a:r>
+              <a:rPr b="1"/>
+              <a:t>Chat assistant only: </a:t>
+            </a:r>
             <a:r>
               <a:rPr/>
-              <a:t>At the end we compare everybody's parameters and discuss</a:t>
-            </a:r>
-          </a:p>
-        </p:txBody>
-      </p:sp>
-      <p:sp>
-        <p:nvSpPr>
-          <p:cNvPr id="4" name="Text Placeholder 3"/>
+              <a:t>the Colab starter notebook</a:t>
+            </a:r>
+          </a:p>
+          <a:p>
+            <a:r>
+              <a:rPr b="1"/>
+              <a:t>No assistant that runs code? </a:t>
+            </a:r>
+            <a:r>
+              <a:rPr/>
+              <a:t>team up</a:t>
+            </a:r>
+          </a:p>
+          <a:p>
+            <a:r>
+              <a:rPr b="1"/>
+              <a:t>Details: </a:t>
+            </a:r>
+            <a:r>
+              <a:rPr/>
+              <a:t>README, sections How to do it, Task 1, Task 2</a:t>
+            </a:r>
+          </a:p>
+        </p:txBody>
+      </p:sp>
+      <p:sp>
+        <p:nvSpPr>
+          <p:cNvPr id="5" name="Text Placeholder 4"/>
           <p:cNvSpPr>
             <a:spLocks noGrp="1"/>
           </p:cNvSpPr>
@@ -3846,7 +3699,29 @@
           <a:p>
             <a:r>
               <a:rPr/>
-              <a:t>Today</a:t>
+              <a:t>Hands-on</a:t>
+            </a:r>
+          </a:p>
+        </p:txBody>
+      </p:sp>
+      <p:sp>
+        <p:nvSpPr>
+          <p:cNvPr id="6" name="Text Placeholder 5"/>
+          <p:cNvSpPr>
+            <a:spLocks noGrp="1"/>
+          </p:cNvSpPr>
+          <p:nvPr>
+            <p:ph type="body" idx="15" sz="quarter"/>
+          </p:nvPr>
+        </p:nvSpPr>
+        <p:spPr/>
+        <p:txBody>
+          <a:bodyPr/>
+          <a:lstStyle/>
+          <a:p>
+            <a:r>
+              <a:rPr/>
+              <a:t>Everything is in the README: tinyurl.com/enzymeml2026</a:t>
             </a:r>
           </a:p>
         </p:txBody>
@@ -3860,702 +3735,6 @@
 </file>
 
 <file path=ppt/slides/slide11.xml><?xml version="1.0" encoding="utf-8"?>
-<p:sld xmlns:a="http://schemas.openxmlformats.org/drawingml/2006/main" xmlns:p="http://schemas.openxmlformats.org/presentationml/2006/main" xmlns:r="http://schemas.openxmlformats.org/officeDocument/2006/relationships">
-  <p:cSld>
-    <p:spTree>
-      <p:nvGrpSpPr>
-        <p:cNvPr id="1" name=""/>
-        <p:cNvGrpSpPr/>
-        <p:nvPr/>
-      </p:nvGrpSpPr>
-      <p:grpSpPr/>
-      <p:sp>
-        <p:nvSpPr>
-          <p:cNvPr id="2" name="Title 1"/>
-          <p:cNvSpPr>
-            <a:spLocks noGrp="1"/>
-          </p:cNvSpPr>
-          <p:nvPr>
-            <p:ph type="title"/>
-          </p:nvPr>
-        </p:nvSpPr>
-        <p:spPr/>
-        <p:txBody>
-          <a:bodyPr/>
-          <a:lstStyle/>
-          <a:p>
-            <a:r>
-              <a:rPr/>
-              <a:t>One repository, two ways to work</a:t>
-            </a:r>
-          </a:p>
-        </p:txBody>
-      </p:sp>
-      <p:sp>
-        <p:nvSpPr>
-          <p:cNvPr id="3" name="Content Placeholder 2"/>
-          <p:cNvSpPr>
-            <a:spLocks noGrp="1"/>
-          </p:cNvSpPr>
-          <p:nvPr>
-            <p:ph idx="1" sz="half"/>
-          </p:nvPr>
-        </p:nvSpPr>
-        <p:spPr/>
-        <p:txBody>
-          <a:bodyPr/>
-          <a:lstStyle/>
-          <a:p>
-            <a:pPr marL="0" indent="0">
-              <a:buNone/>
-            </a:pPr>
-            <a:r>
-              <a:rPr b="1"/>
-              <a:t>With a language model</a:t>
-            </a:r>
-          </a:p>
-          <a:p>
-            <a:r>
-              <a:rPr b="1"/>
-              <a:t>Any chat model, </a:t>
-            </a:r>
-            <a:r>
-              <a:rPr/>
-              <a:t>free or by subscription: ChatGPT, Claude, Gemini, …</a:t>
-            </a:r>
-          </a:p>
-          <a:p>
-            <a:r>
-              <a:rPr b="1"/>
-              <a:t>Paste </a:t>
-            </a:r>
-            <a:r>
-              <a:rPr/>
-              <a:t>the tool card and the task card; run the code, paste errors back</a:t>
-            </a:r>
-          </a:p>
-          <a:p>
-            <a:r>
-              <a:rPr b="1"/>
-              <a:t>The checks </a:t>
-            </a:r>
-            <a:r>
-              <a:rPr/>
-              <a:t>decide when you are done</a:t>
-            </a:r>
-          </a:p>
-          <a:p>
-            <a:r>
-              <a:rPr b="1"/>
-              <a:t>notebooks/ </a:t>
-            </a:r>
-            <a:r>
-              <a:rPr/>
-              <a:t>are the reference solutions, checkpoints/ the result of task 1</a:t>
-            </a:r>
-          </a:p>
-        </p:txBody>
-      </p:sp>
-      <p:sp>
-        <p:nvSpPr>
-          <p:cNvPr id="4" name="Content Placeholder 3"/>
-          <p:cNvSpPr>
-            <a:spLocks noGrp="1"/>
-          </p:cNvSpPr>
-          <p:nvPr>
-            <p:ph idx="2" sz="half"/>
-          </p:nvPr>
-        </p:nvSpPr>
-        <p:spPr/>
-        <p:txBody>
-          <a:bodyPr/>
-          <a:lstStyle/>
-          <a:p>
-            <a:pPr marL="0" indent="0">
-              <a:buNone/>
-            </a:pPr>
-            <a:r>
-              <a:rPr b="1"/>
-              <a:t>Without writing code</a:t>
-            </a:r>
-          </a:p>
-          <a:p>
-            <a:r>
-              <a:rPr b="1"/>
-              <a:t>Open the Colab link: </a:t>
-            </a:r>
-            <a:r>
-              <a:rPr/>
-              <a:t>a prepared notebook, tools installed, data loaded</a:t>
-            </a:r>
-          </a:p>
-          <a:p>
-            <a:r>
-              <a:rPr b="1"/>
-              <a:t>Run it cell by cell; </a:t>
-            </a:r>
-            <a:r>
-              <a:rPr/>
-              <a:t>change a window, a prior, a series</a:t>
-            </a:r>
-          </a:p>
-          <a:p>
-            <a:r>
-              <a:rPr b="1"/>
-              <a:t>Ask the model in Colab </a:t>
-            </a:r>
-            <a:r>
-              <a:rPr/>
-              <a:t>to explain any cell</a:t>
-            </a:r>
-          </a:p>
-        </p:txBody>
-      </p:sp>
-      <p:sp>
-        <p:nvSpPr>
-          <p:cNvPr id="5" name="Text Placeholder 4"/>
-          <p:cNvSpPr>
-            <a:spLocks noGrp="1"/>
-          </p:cNvSpPr>
-          <p:nvPr>
-            <p:ph type="body" idx="13" sz="quarter"/>
-          </p:nvPr>
-        </p:nvSpPr>
-        <p:spPr/>
-        <p:txBody>
-          <a:bodyPr/>
-          <a:lstStyle/>
-          <a:p>
-            <a:r>
-              <a:rPr/>
-              <a:t>Toolkit</a:t>
-            </a:r>
-          </a:p>
-        </p:txBody>
-      </p:sp>
-      <p:sp>
-        <p:nvSpPr>
-          <p:cNvPr id="6" name="Text Placeholder 5"/>
-          <p:cNvSpPr>
-            <a:spLocks noGrp="1"/>
-          </p:cNvSpPr>
-          <p:nvPr>
-            <p:ph type="body" idx="15" sz="quarter"/>
-          </p:nvPr>
-        </p:nvSpPr>
-        <p:spPr/>
-        <p:txBody>
-          <a:bodyPr/>
-          <a:lstStyle/>
-          <a:p>
-            <a:r>
-              <a:rPr/>
-              <a:t>tinyurl.com/enzymeml2026 · start with the README</a:t>
-            </a:r>
-          </a:p>
-        </p:txBody>
-      </p:sp>
-    </p:spTree>
-  </p:cSld>
-  <p:clrMapOvr>
-    <a:masterClrMapping/>
-  </p:clrMapOvr>
-</p:sld>
-</file>
-
-<file path=ppt/slides/slide12.xml><?xml version="1.0" encoding="utf-8"?>
-<p:sld xmlns:a="http://schemas.openxmlformats.org/drawingml/2006/main" xmlns:p="http://schemas.openxmlformats.org/presentationml/2006/main" xmlns:r="http://schemas.openxmlformats.org/officeDocument/2006/relationships">
-  <p:cSld>
-    <p:spTree>
-      <p:nvGrpSpPr>
-        <p:cNvPr id="1" name=""/>
-        <p:cNvGrpSpPr/>
-        <p:nvPr/>
-      </p:nvGrpSpPr>
-      <p:grpSpPr/>
-      <p:sp>
-        <p:nvSpPr>
-          <p:cNvPr id="2" name="Title 1"/>
-          <p:cNvSpPr>
-            <a:spLocks noGrp="1"/>
-          </p:cNvSpPr>
-          <p:nvPr>
-            <p:ph type="title"/>
-          </p:nvPr>
-        </p:nvSpPr>
-        <p:spPr/>
-        <p:txBody>
-          <a:bodyPr/>
-          <a:lstStyle/>
-          <a:p>
-            <a:r>
-              <a:rPr/>
-              <a:t>Task 1: from chromatograms to EnzymeML</a:t>
-            </a:r>
-          </a:p>
-        </p:txBody>
-      </p:sp>
-      <p:sp>
-        <p:nvSpPr>
-          <p:cNvPr id="3" name="Content Placeholder 2"/>
-          <p:cNvSpPr>
-            <a:spLocks noGrp="1"/>
-          </p:cNvSpPr>
-          <p:nvPr>
-            <p:ph idx="1" sz="half"/>
-          </p:nvPr>
-        </p:nvSpPr>
-        <p:spPr/>
-        <p:txBody>
-          <a:bodyPr/>
-          <a:lstStyle/>
-          <a:p>
-            <a:pPr marL="0" indent="0">
-              <a:buNone/>
-            </a:pPr>
-            <a:r>
-              <a:rPr b="1"/>
-              <a:t>Tasks</a:t>
-            </a:r>
-          </a:p>
-          <a:p>
-            <a:r>
-              <a:rPr/>
-              <a:t>Plot the data</a:t>
-            </a:r>
-          </a:p>
-          <a:p>
-            <a:r>
-              <a:rPr/>
-              <a:t>Check how the kinetic assay was designed</a:t>
-            </a:r>
-          </a:p>
-          <a:p>
-            <a:r>
-              <a:rPr/>
-              <a:t>Calibrate: the calibration parameters</a:t>
-            </a:r>
-          </a:p>
-          <a:p>
-            <a:r>
-              <a:rPr/>
-              <a:t>Assign the product peak in the reactions</a:t>
-            </a:r>
-          </a:p>
-          <a:p>
-            <a:r>
-              <a:rPr/>
-              <a:t>Export the EnzymeML document</a:t>
-            </a:r>
-          </a:p>
-          <a:p>
-            <a:r>
-              <a:rPr b="1"/>
-              <a:t>Details: </a:t>
-            </a:r>
-            <a:r>
-              <a:rPr/>
-              <a:t>README, section Task 1</a:t>
-            </a:r>
-          </a:p>
-        </p:txBody>
-      </p:sp>
-      <p:sp>
-        <p:nvSpPr>
-          <p:cNvPr id="4" name="Content Placeholder 3"/>
-          <p:cNvSpPr>
-            <a:spLocks noGrp="1"/>
-          </p:cNvSpPr>
-          <p:nvPr>
-            <p:ph idx="2" sz="half"/>
-          </p:nvPr>
-        </p:nvSpPr>
-        <p:spPr/>
-        <p:txBody>
-          <a:bodyPr/>
-          <a:lstStyle/>
-          <a:p>
-            <a:pPr marL="0" indent="0">
-              <a:buNone/>
-            </a:pPr>
-            <a:r>
-              <a:rPr b="1"/>
-              <a:t>How to do it</a:t>
-            </a:r>
-          </a:p>
-          <a:p>
-            <a:r>
-              <a:rPr b="1"/>
-              <a:t>Coding assistant on your computer: </a:t>
-            </a:r>
-            <a:r>
-              <a:rPr/>
-              <a:t>the cards in briefs/</a:t>
-            </a:r>
-          </a:p>
-          <a:p>
-            <a:r>
-              <a:rPr b="1"/>
-              <a:t>Chat assistant only: </a:t>
-            </a:r>
-            <a:r>
-              <a:rPr/>
-              <a:t>the Colab starter notebook</a:t>
-            </a:r>
-          </a:p>
-          <a:p>
-            <a:r>
-              <a:rPr b="1"/>
-              <a:t>No assistant that runs code? </a:t>
-            </a:r>
-            <a:r>
-              <a:rPr/>
-              <a:t>team up</a:t>
-            </a:r>
-          </a:p>
-          <a:p>
-            <a:r>
-              <a:rPr b="1"/>
-              <a:t>Details: </a:t>
-            </a:r>
-            <a:r>
-              <a:rPr/>
-              <a:t>README, section How to do it</a:t>
-            </a:r>
-          </a:p>
-          <a:p>
-            <a:r>
-              <a:rPr b="1"/>
-              <a:t>Repository: </a:t>
-            </a:r>
-            <a:r>
-              <a:rPr/>
-              <a:t>tinyurl.com/enzymeml2026</a:t>
-            </a:r>
-          </a:p>
-        </p:txBody>
-      </p:sp>
-      <p:sp>
-        <p:nvSpPr>
-          <p:cNvPr id="5" name="Text Placeholder 4"/>
-          <p:cNvSpPr>
-            <a:spLocks noGrp="1"/>
-          </p:cNvSpPr>
-          <p:nvPr>
-            <p:ph type="body" idx="13" sz="quarter"/>
-          </p:nvPr>
-        </p:nvSpPr>
-        <p:spPr/>
-        <p:txBody>
-          <a:bodyPr/>
-          <a:lstStyle/>
-          <a:p>
-            <a:r>
-              <a:rPr/>
-              <a:t>Task 1</a:t>
-            </a:r>
-          </a:p>
-        </p:txBody>
-      </p:sp>
-      <p:sp>
-        <p:nvSpPr>
-          <p:cNvPr id="6" name="Text Placeholder 5"/>
-          <p:cNvSpPr>
-            <a:spLocks noGrp="1"/>
-          </p:cNvSpPr>
-          <p:nvPr>
-            <p:ph type="body" idx="15" sz="quarter"/>
-          </p:nvPr>
-        </p:nvSpPr>
-        <p:spPr/>
-        <p:txBody>
-          <a:bodyPr/>
-          <a:lstStyle/>
-          <a:p>
-            <a:r>
-              <a:rPr/>
-              <a:t>Result: an EnzymeML document with the Neu5Ac time course of every reaction</a:t>
-            </a:r>
-          </a:p>
-        </p:txBody>
-      </p:sp>
-    </p:spTree>
-  </p:cSld>
-  <p:clrMapOvr>
-    <a:masterClrMapping/>
-  </p:clrMapOvr>
-</p:sld>
-</file>
-
-<file path=ppt/slides/slide13.xml><?xml version="1.0" encoding="utf-8"?>
-<p:sld xmlns:a="http://schemas.openxmlformats.org/drawingml/2006/main" xmlns:p="http://schemas.openxmlformats.org/presentationml/2006/main" xmlns:r="http://schemas.openxmlformats.org/officeDocument/2006/relationships">
-  <p:cSld>
-    <p:spTree>
-      <p:nvGrpSpPr>
-        <p:cNvPr id="1" name=""/>
-        <p:cNvGrpSpPr/>
-        <p:nvPr/>
-      </p:nvGrpSpPr>
-      <p:grpSpPr/>
-      <p:sp>
-        <p:nvSpPr>
-          <p:cNvPr id="2" name="Title 1"/>
-          <p:cNvSpPr>
-            <a:spLocks noGrp="1"/>
-          </p:cNvSpPr>
-          <p:nvPr>
-            <p:ph type="title"/>
-          </p:nvPr>
-        </p:nvSpPr>
-        <p:spPr/>
-        <p:txBody>
-          <a:bodyPr/>
-          <a:lstStyle/>
-          <a:p>
-            <a:r>
-              <a:rPr/>
-              <a:t>Task 2: kinetic parameters by Bayesian inference</a:t>
-            </a:r>
-          </a:p>
-        </p:txBody>
-      </p:sp>
-      <p:sp>
-        <p:nvSpPr>
-          <p:cNvPr id="3" name="Content Placeholder 2"/>
-          <p:cNvSpPr>
-            <a:spLocks noGrp="1"/>
-          </p:cNvSpPr>
-          <p:nvPr>
-            <p:ph idx="1" sz="half"/>
-          </p:nvPr>
-        </p:nvSpPr>
-        <p:spPr/>
-        <p:txBody>
-          <a:bodyPr/>
-          <a:lstStyle/>
-          <a:p>
-            <a:pPr marL="0" indent="0">
-              <a:buNone/>
-            </a:pPr>
-            <a:r>
-              <a:rPr b="1"/>
-              <a:t>Tasks</a:t>
-            </a:r>
-          </a:p>
-          <a:p>
-            <a:r>
-              <a:rPr/>
-              <a:t>Plot the time courses</a:t>
-            </a:r>
-          </a:p>
-          <a:p>
-            <a:r>
-              <a:rPr/>
-              <a:t>Define the model and the priors</a:t>
-            </a:r>
-          </a:p>
-          <a:p>
-            <a:r>
-              <a:rPr/>
-              <a:t>Infer the kinetic parameters and their uncertainty</a:t>
-            </a:r>
-          </a:p>
-          <a:p>
-            <a:r>
-              <a:rPr/>
-              <a:t>The correlation between the kinetic parameters</a:t>
-            </a:r>
-          </a:p>
-          <a:p>
-            <a:r>
-              <a:rPr/>
-              <a:t>Does one model describe both series?</a:t>
-            </a:r>
-          </a:p>
-          <a:p>
-            <a:r>
-              <a:rPr b="1"/>
-              <a:t>Details: </a:t>
-            </a:r>
-            <a:r>
-              <a:rPr/>
-              <a:t>README, section Task 2</a:t>
-            </a:r>
-          </a:p>
-        </p:txBody>
-      </p:sp>
-      <p:sp>
-        <p:nvSpPr>
-          <p:cNvPr id="4" name="Content Placeholder 3"/>
-          <p:cNvSpPr>
-            <a:spLocks noGrp="1"/>
-          </p:cNvSpPr>
-          <p:nvPr>
-            <p:ph idx="2" sz="half"/>
-          </p:nvPr>
-        </p:nvSpPr>
-        <p:spPr/>
-        <p:txBody>
-          <a:bodyPr/>
-          <a:lstStyle/>
-          <a:p>
-            <a:pPr marL="0" indent="0">
-              <a:buNone/>
-            </a:pPr>
-            <a:r>
-              <a:rPr b="1"/>
-              <a:t>How to do it</a:t>
-            </a:r>
-          </a:p>
-          <a:p>
-            <a:r>
-              <a:rPr b="1"/>
-              <a:t>Coding assistant on your computer: </a:t>
-            </a:r>
-            <a:r>
-              <a:rPr/>
-              <a:t>the cards in briefs/</a:t>
-            </a:r>
-          </a:p>
-          <a:p>
-            <a:r>
-              <a:rPr b="1"/>
-              <a:t>Chat assistant only: </a:t>
-            </a:r>
-            <a:r>
-              <a:rPr/>
-              <a:t>the Colab starter notebook</a:t>
-            </a:r>
-          </a:p>
-          <a:p>
-            <a:r>
-              <a:rPr b="1"/>
-              <a:t>No assistant that runs code? </a:t>
-            </a:r>
-            <a:r>
-              <a:rPr/>
-              <a:t>team up</a:t>
-            </a:r>
-          </a:p>
-          <a:p>
-            <a:r>
-              <a:rPr b="1"/>
-              <a:t>Details: </a:t>
-            </a:r>
-            <a:r>
-              <a:rPr/>
-              <a:t>README, section How to do it</a:t>
-            </a:r>
-          </a:p>
-          <a:p>
-            <a:r>
-              <a:rPr b="1"/>
-              <a:t>Repository: </a:t>
-            </a:r>
-            <a:r>
-              <a:rPr/>
-              <a:t>tinyurl.com/enzymeml2026</a:t>
-            </a:r>
-          </a:p>
-        </p:txBody>
-      </p:sp>
-      <p:sp>
-        <p:nvSpPr>
-          <p:cNvPr id="5" name="Text Placeholder 4"/>
-          <p:cNvSpPr>
-            <a:spLocks noGrp="1"/>
-          </p:cNvSpPr>
-          <p:nvPr>
-            <p:ph type="body" idx="13" sz="quarter"/>
-          </p:nvPr>
-        </p:nvSpPr>
-        <p:spPr/>
-        <p:txBody>
-          <a:bodyPr/>
-          <a:lstStyle/>
-          <a:p>
-            <a:r>
-              <a:rPr/>
-              <a:t>Task 2</a:t>
-            </a:r>
-          </a:p>
-        </p:txBody>
-      </p:sp>
-      <p:sp>
-        <p:nvSpPr>
-          <p:cNvPr id="6" name="Text Placeholder 5"/>
-          <p:cNvSpPr>
-            <a:spLocks noGrp="1"/>
-          </p:cNvSpPr>
-          <p:nvPr>
-            <p:ph type="body" idx="15" sz="quarter"/>
-          </p:nvPr>
-        </p:nvSpPr>
-        <p:spPr/>
-        <p:txBody>
-          <a:bodyPr/>
-          <a:lstStyle/>
-          <a:p>
-            <a:r>
-              <a:rPr/>
-              <a:t>v = </a:t>
-            </a:r>
-            <a:r>
-              <a:rPr i="1"/>
-              <a:t>k</a:t>
-            </a:r>
-            <a:r>
-              <a:rPr baseline="-25000"/>
-              <a:t>cat</a:t>
-            </a:r>
-            <a:r>
-              <a:rPr/>
-              <a:t> · [NeuS] · [ManNAc] · [PEP] / ((</a:t>
-            </a:r>
-            <a:r>
-              <a:rPr i="1"/>
-              <a:t>K</a:t>
-            </a:r>
-            <a:r>
-              <a:rPr i="1" baseline="-25000"/>
-              <a:t>M</a:t>
-            </a:r>
-            <a:r>
-              <a:rPr baseline="30000"/>
-              <a:t>ManNAc</a:t>
-            </a:r>
-            <a:r>
-              <a:rPr/>
-              <a:t> + [ManNAc]) (</a:t>
-            </a:r>
-            <a:r>
-              <a:rPr i="1"/>
-              <a:t>K</a:t>
-            </a:r>
-            <a:r>
-              <a:rPr i="1" baseline="-25000"/>
-              <a:t>M</a:t>
-            </a:r>
-            <a:r>
-              <a:rPr baseline="30000"/>
-              <a:t>PEP</a:t>
-            </a:r>
-            <a:r>
-              <a:rPr/>
-              <a:t> + [PEP]))</a:t>
-            </a:r>
-          </a:p>
-        </p:txBody>
-      </p:sp>
-    </p:spTree>
-  </p:cSld>
-  <p:clrMapOvr>
-    <a:masterClrMapping/>
-  </p:clrMapOvr>
-</p:sld>
-</file>
-
-<file path=ppt/slides/slide14.xml><?xml version="1.0" encoding="utf-8"?>
 <p:sld xmlns:a="http://schemas.openxmlformats.org/drawingml/2006/main" xmlns:p="http://schemas.openxmlformats.org/presentationml/2006/main" xmlns:r="http://schemas.openxmlformats.org/officeDocument/2006/relationships">
   <p:cSld>
     <p:spTree>
@@ -4850,7 +4029,7 @@
 </p:sld>
 </file>
 
-<file path=ppt/slides/slide15.xml><?xml version="1.0" encoding="utf-8"?>
+<file path=ppt/slides/slide12.xml><?xml version="1.0" encoding="utf-8"?>
 <p:sld xmlns:a="http://schemas.openxmlformats.org/drawingml/2006/main" xmlns:p="http://schemas.openxmlformats.org/presentationml/2006/main" xmlns:r="http://schemas.openxmlformats.org/officeDocument/2006/relationships">
   <p:cSld>
     <p:spTree>
@@ -4952,7 +4131,7 @@
 </p:sld>
 </file>
 
-<file path=ppt/slides/slide16.xml><?xml version="1.0" encoding="utf-8"?>
+<file path=ppt/slides/slide13.xml><?xml version="1.0" encoding="utf-8"?>
 <p:sld xmlns:a="http://schemas.openxmlformats.org/drawingml/2006/main" xmlns:p="http://schemas.openxmlformats.org/presentationml/2006/main" xmlns:r="http://schemas.openxmlformats.org/officeDocument/2006/relationships">
   <p:cSld>
     <p:spTree>

</xml_diff>

<commit_message>
Deck: Tabler icons on the hands-on slide (MIT), icon_list helper
Co-Authored-By: Claude Fable 5.1 <noreply@anthropic.com>
</commit_message>
<xml_diff>
--- a/slides/workshop.pptx
+++ b/slides/workshop.pptx
@@ -3540,150 +3540,6 @@
       </p:sp>
       <p:sp>
         <p:nvSpPr>
-          <p:cNvPr id="3" name="Content Placeholder 2"/>
-          <p:cNvSpPr>
-            <a:spLocks noGrp="1"/>
-          </p:cNvSpPr>
-          <p:nvPr>
-            <p:ph idx="1" sz="half"/>
-          </p:nvPr>
-        </p:nvSpPr>
-        <p:spPr/>
-        <p:txBody>
-          <a:bodyPr/>
-          <a:lstStyle/>
-          <a:p>
-            <a:pPr marL="0" indent="0">
-              <a:buNone/>
-            </a:pPr>
-            <a:r>
-              <a:rPr b="1"/>
-              <a:t>Tasks</a:t>
-            </a:r>
-          </a:p>
-          <a:p>
-            <a:r>
-              <a:rPr b="1"/>
-              <a:t>Task 1 · chromatograms to EnzymeML: </a:t>
-            </a:r>
-            <a:r>
-              <a:rPr/>
-              <a:t>plot the data, check the assay design, calibrate, export the document</a:t>
-            </a:r>
-          </a:p>
-          <a:p>
-            <a:r>
-              <a:rPr b="1"/>
-              <a:t>Task 2 · kinetic parameters: </a:t>
-            </a:r>
-            <a:r>
-              <a:rPr/>
-              <a:t>infer </a:t>
-            </a:r>
-            <a:r>
-              <a:rPr i="1"/>
-              <a:t>k</a:t>
-            </a:r>
-            <a:r>
-              <a:rPr baseline="-25000"/>
-              <a:t>cat</a:t>
-            </a:r>
-            <a:r>
-              <a:rPr/>
-              <a:t> and </a:t>
-            </a:r>
-            <a:r>
-              <a:rPr i="1"/>
-              <a:t>K</a:t>
-            </a:r>
-            <a:r>
-              <a:rPr i="1" baseline="-25000"/>
-              <a:t>M</a:t>
-            </a:r>
-            <a:r>
-              <a:rPr/>
-              <a:t> with their uncertainty and correlation; does the model describe the data?</a:t>
-            </a:r>
-          </a:p>
-          <a:p>
-            <a:r>
-              <a:rPr b="1"/>
-              <a:t>At the end </a:t>
-            </a:r>
-            <a:r>
-              <a:rPr/>
-              <a:t>we compare everybody's parameters</a:t>
-            </a:r>
-          </a:p>
-        </p:txBody>
-      </p:sp>
-      <p:sp>
-        <p:nvSpPr>
-          <p:cNvPr id="4" name="Content Placeholder 3"/>
-          <p:cNvSpPr>
-            <a:spLocks noGrp="1"/>
-          </p:cNvSpPr>
-          <p:nvPr>
-            <p:ph idx="2" sz="half"/>
-          </p:nvPr>
-        </p:nvSpPr>
-        <p:spPr/>
-        <p:txBody>
-          <a:bodyPr/>
-          <a:lstStyle/>
-          <a:p>
-            <a:pPr marL="0" indent="0">
-              <a:buNone/>
-            </a:pPr>
-            <a:r>
-              <a:rPr b="1"/>
-              <a:t>How to get started</a:t>
-            </a:r>
-          </a:p>
-          <a:p>
-            <a:r>
-              <a:rPr b="1"/>
-              <a:t>Coding assistant on your computer: </a:t>
-            </a:r>
-            <a:r>
-              <a:rPr/>
-              <a:t>give it the cards in briefs/</a:t>
-            </a:r>
-          </a:p>
-          <a:p>
-            <a:r>
-              <a:rPr b="1"/>
-              <a:t>Chat assistant only: </a:t>
-            </a:r>
-            <a:r>
-              <a:rPr/>
-              <a:t>the Colab starter notebook</a:t>
-            </a:r>
-          </a:p>
-          <a:p>
-            <a:r>
-              <a:rPr b="1"/>
-              <a:t>No assistant that runs code? </a:t>
-            </a:r>
-            <a:r>
-              <a:rPr/>
-              <a:t>team up</a:t>
-            </a:r>
-          </a:p>
-          <a:p>
-            <a:r>
-              <a:rPr b="1"/>
-              <a:t>Details: </a:t>
-            </a:r>
-            <a:r>
-              <a:rPr/>
-              <a:t>README, sections How to do it, Task 1, Task 2</a:t>
-            </a:r>
-          </a:p>
-        </p:txBody>
-      </p:sp>
-      <p:sp>
-        <p:nvSpPr>
           <p:cNvPr id="5" name="Text Placeholder 4"/>
           <p:cNvSpPr>
             <a:spLocks noGrp="1"/>
@@ -3722,6 +3578,487 @@
             <a:r>
               <a:rPr/>
               <a:t>Everything is in the README: tinyurl.com/enzymeml2026</a:t>
+            </a:r>
+          </a:p>
+        </p:txBody>
+      </p:sp>
+      <p:sp>
+        <p:nvSpPr>
+          <p:cNvPr id="8" name="TextBox 7"/>
+          <p:cNvSpPr txBox="1"/>
+          <p:nvPr/>
+        </p:nvSpPr>
+        <p:spPr>
+          <a:xfrm>
+            <a:off x="822960" y="2011680"/>
+            <a:ext cx="5029200" cy="365760"/>
+          </a:xfrm>
+          <a:prstGeom prst="rect">
+            <a:avLst/>
+          </a:prstGeom>
+          <a:noFill/>
+        </p:spPr>
+        <p:txBody>
+          <a:bodyPr wrap="none" lIns="0" tIns="0" bIns="0">
+            <a:spAutoFit/>
+          </a:bodyPr>
+          <a:lstStyle/>
+          <a:p>
+            <a:r>
+              <a:rPr b="1" sz="1600"/>
+              <a:t>Tasks</a:t>
+            </a:r>
+          </a:p>
+        </p:txBody>
+      </p:sp>
+      <p:pic>
+        <p:nvPicPr>
+          <p:cNvPr id="9" name="Picture 8" descr="chart-area-line.png"/>
+          <p:cNvPicPr>
+            <a:picLocks noChangeAspect="1"/>
+          </p:cNvPicPr>
+          <p:nvPr/>
+        </p:nvPicPr>
+        <p:blipFill>
+          <a:blip r:embed="rId3"/>
+          <a:stretch>
+            <a:fillRect/>
+          </a:stretch>
+        </p:blipFill>
+        <p:spPr>
+          <a:xfrm>
+            <a:off x="822960" y="2487168"/>
+            <a:ext cx="384048" cy="384048"/>
+          </a:xfrm>
+          <a:prstGeom prst="rect">
+            <a:avLst/>
+          </a:prstGeom>
+        </p:spPr>
+      </p:pic>
+      <p:sp>
+        <p:nvSpPr>
+          <p:cNvPr id="10" name="TextBox 9"/>
+          <p:cNvSpPr txBox="1"/>
+          <p:nvPr/>
+        </p:nvSpPr>
+        <p:spPr>
+          <a:xfrm>
+            <a:off x="1389888" y="2468880"/>
+            <a:ext cx="4462272" cy="960119"/>
+          </a:xfrm>
+          <a:prstGeom prst="rect">
+            <a:avLst/>
+          </a:prstGeom>
+          <a:noFill/>
+        </p:spPr>
+        <p:txBody>
+          <a:bodyPr wrap="square" lIns="0" tIns="0" bIns="0">
+            <a:spAutoFit/>
+          </a:bodyPr>
+          <a:lstStyle/>
+          <a:p>
+            <a:r>
+              <a:rPr b="1" sz="1600"/>
+              <a:t>Task 1 · chromatograms to EnzymeML: </a:t>
+            </a:r>
+            <a:r>
+              <a:rPr sz="1600"/>
+              <a:t>plot the data, check the assay design, calibrate, export the document</a:t>
+            </a:r>
+          </a:p>
+        </p:txBody>
+      </p:sp>
+      <p:pic>
+        <p:nvPicPr>
+          <p:cNvPr id="11" name="Picture 10" descr="chart-scatter.png"/>
+          <p:cNvPicPr>
+            <a:picLocks noChangeAspect="1"/>
+          </p:cNvPicPr>
+          <p:nvPr/>
+        </p:nvPicPr>
+        <p:blipFill>
+          <a:blip r:embed="rId4"/>
+          <a:stretch>
+            <a:fillRect/>
+          </a:stretch>
+        </p:blipFill>
+        <p:spPr>
+          <a:xfrm>
+            <a:off x="822960" y="3538728"/>
+            <a:ext cx="384048" cy="384048"/>
+          </a:xfrm>
+          <a:prstGeom prst="rect">
+            <a:avLst/>
+          </a:prstGeom>
+        </p:spPr>
+      </p:pic>
+      <p:sp>
+        <p:nvSpPr>
+          <p:cNvPr id="12" name="TextBox 11"/>
+          <p:cNvSpPr txBox="1"/>
+          <p:nvPr/>
+        </p:nvSpPr>
+        <p:spPr>
+          <a:xfrm>
+            <a:off x="1389888" y="3520440"/>
+            <a:ext cx="4462272" cy="960119"/>
+          </a:xfrm>
+          <a:prstGeom prst="rect">
+            <a:avLst/>
+          </a:prstGeom>
+          <a:noFill/>
+        </p:spPr>
+        <p:txBody>
+          <a:bodyPr wrap="square" lIns="0" tIns="0" bIns="0">
+            <a:spAutoFit/>
+          </a:bodyPr>
+          <a:lstStyle/>
+          <a:p>
+            <a:r>
+              <a:rPr b="1" sz="1600"/>
+              <a:t>Task 2 · kinetic parameters: </a:t>
+            </a:r>
+            <a:r>
+              <a:rPr sz="1600"/>
+              <a:t>infer </a:t>
+            </a:r>
+            <a:r>
+              <a:rPr i="1" sz="1600"/>
+              <a:t>k</a:t>
+            </a:r>
+            <a:r>
+              <a:rPr sz="1600" baseline="-25000"/>
+              <a:t>cat</a:t>
+            </a:r>
+            <a:r>
+              <a:rPr sz="1600"/>
+              <a:t> and </a:t>
+            </a:r>
+            <a:r>
+              <a:rPr i="1" sz="1600"/>
+              <a:t>K</a:t>
+            </a:r>
+            <a:r>
+              <a:rPr i="1" sz="1600" baseline="-25000"/>
+              <a:t>M</a:t>
+            </a:r>
+            <a:r>
+              <a:rPr sz="1600"/>
+              <a:t> with their uncertainty and correlation; does the model describe the data?</a:t>
+            </a:r>
+          </a:p>
+        </p:txBody>
+      </p:sp>
+      <p:pic>
+        <p:nvPicPr>
+          <p:cNvPr id="13" name="Picture 12" descr="users-group.png"/>
+          <p:cNvPicPr>
+            <a:picLocks noChangeAspect="1"/>
+          </p:cNvPicPr>
+          <p:nvPr/>
+        </p:nvPicPr>
+        <p:blipFill>
+          <a:blip r:embed="rId5"/>
+          <a:stretch>
+            <a:fillRect/>
+          </a:stretch>
+        </p:blipFill>
+        <p:spPr>
+          <a:xfrm>
+            <a:off x="822960" y="4590288"/>
+            <a:ext cx="384048" cy="384048"/>
+          </a:xfrm>
+          <a:prstGeom prst="rect">
+            <a:avLst/>
+          </a:prstGeom>
+        </p:spPr>
+      </p:pic>
+      <p:sp>
+        <p:nvSpPr>
+          <p:cNvPr id="14" name="TextBox 13"/>
+          <p:cNvSpPr txBox="1"/>
+          <p:nvPr/>
+        </p:nvSpPr>
+        <p:spPr>
+          <a:xfrm>
+            <a:off x="1389888" y="4572000"/>
+            <a:ext cx="4462272" cy="960119"/>
+          </a:xfrm>
+          <a:prstGeom prst="rect">
+            <a:avLst/>
+          </a:prstGeom>
+          <a:noFill/>
+        </p:spPr>
+        <p:txBody>
+          <a:bodyPr wrap="square" lIns="0" tIns="0" bIns="0">
+            <a:spAutoFit/>
+          </a:bodyPr>
+          <a:lstStyle/>
+          <a:p>
+            <a:r>
+              <a:rPr b="1" sz="1600"/>
+              <a:t>At the end </a:t>
+            </a:r>
+            <a:r>
+              <a:rPr sz="1600"/>
+              <a:t>we compare everybody's parameters</a:t>
+            </a:r>
+          </a:p>
+        </p:txBody>
+      </p:sp>
+      <p:sp>
+        <p:nvSpPr>
+          <p:cNvPr id="15" name="TextBox 14"/>
+          <p:cNvSpPr txBox="1"/>
+          <p:nvPr/>
+        </p:nvSpPr>
+        <p:spPr>
+          <a:xfrm>
+            <a:off x="6339535" y="2011680"/>
+            <a:ext cx="5029200" cy="365760"/>
+          </a:xfrm>
+          <a:prstGeom prst="rect">
+            <a:avLst/>
+          </a:prstGeom>
+          <a:noFill/>
+        </p:spPr>
+        <p:txBody>
+          <a:bodyPr wrap="none" lIns="0" tIns="0" bIns="0">
+            <a:spAutoFit/>
+          </a:bodyPr>
+          <a:lstStyle/>
+          <a:p>
+            <a:r>
+              <a:rPr b="1" sz="1600"/>
+              <a:t>How to get started</a:t>
+            </a:r>
+          </a:p>
+        </p:txBody>
+      </p:sp>
+      <p:pic>
+        <p:nvPicPr>
+          <p:cNvPr id="16" name="Picture 15" descr="terminal-2.png"/>
+          <p:cNvPicPr>
+            <a:picLocks noChangeAspect="1"/>
+          </p:cNvPicPr>
+          <p:nvPr/>
+        </p:nvPicPr>
+        <p:blipFill>
+          <a:blip r:embed="rId6"/>
+          <a:stretch>
+            <a:fillRect/>
+          </a:stretch>
+        </p:blipFill>
+        <p:spPr>
+          <a:xfrm>
+            <a:off x="6339535" y="2487168"/>
+            <a:ext cx="384048" cy="384048"/>
+          </a:xfrm>
+          <a:prstGeom prst="rect">
+            <a:avLst/>
+          </a:prstGeom>
+        </p:spPr>
+      </p:pic>
+      <p:sp>
+        <p:nvSpPr>
+          <p:cNvPr id="17" name="TextBox 16"/>
+          <p:cNvSpPr txBox="1"/>
+          <p:nvPr/>
+        </p:nvSpPr>
+        <p:spPr>
+          <a:xfrm>
+            <a:off x="6906463" y="2468880"/>
+            <a:ext cx="4462272" cy="685800"/>
+          </a:xfrm>
+          <a:prstGeom prst="rect">
+            <a:avLst/>
+          </a:prstGeom>
+          <a:noFill/>
+        </p:spPr>
+        <p:txBody>
+          <a:bodyPr wrap="square" lIns="0" tIns="0" bIns="0">
+            <a:spAutoFit/>
+          </a:bodyPr>
+          <a:lstStyle/>
+          <a:p>
+            <a:r>
+              <a:rPr b="1" sz="1600"/>
+              <a:t>Coding assistant on your computer: </a:t>
+            </a:r>
+            <a:r>
+              <a:rPr sz="1600"/>
+              <a:t>give it the cards in briefs/</a:t>
+            </a:r>
+          </a:p>
+        </p:txBody>
+      </p:sp>
+      <p:pic>
+        <p:nvPicPr>
+          <p:cNvPr id="18" name="Picture 17" descr="message-chatbot.png"/>
+          <p:cNvPicPr>
+            <a:picLocks noChangeAspect="1"/>
+          </p:cNvPicPr>
+          <p:nvPr/>
+        </p:nvPicPr>
+        <p:blipFill>
+          <a:blip r:embed="rId7"/>
+          <a:stretch>
+            <a:fillRect/>
+          </a:stretch>
+        </p:blipFill>
+        <p:spPr>
+          <a:xfrm>
+            <a:off x="6339535" y="3264408"/>
+            <a:ext cx="384048" cy="384048"/>
+          </a:xfrm>
+          <a:prstGeom prst="rect">
+            <a:avLst/>
+          </a:prstGeom>
+        </p:spPr>
+      </p:pic>
+      <p:sp>
+        <p:nvSpPr>
+          <p:cNvPr id="19" name="TextBox 18"/>
+          <p:cNvSpPr txBox="1"/>
+          <p:nvPr/>
+        </p:nvSpPr>
+        <p:spPr>
+          <a:xfrm>
+            <a:off x="6906463" y="3246120"/>
+            <a:ext cx="4462272" cy="685800"/>
+          </a:xfrm>
+          <a:prstGeom prst="rect">
+            <a:avLst/>
+          </a:prstGeom>
+          <a:noFill/>
+        </p:spPr>
+        <p:txBody>
+          <a:bodyPr wrap="square" lIns="0" tIns="0" bIns="0">
+            <a:spAutoFit/>
+          </a:bodyPr>
+          <a:lstStyle/>
+          <a:p>
+            <a:r>
+              <a:rPr b="1" sz="1600"/>
+              <a:t>Chat assistant only: </a:t>
+            </a:r>
+            <a:r>
+              <a:rPr sz="1600"/>
+              <a:t>the Colab starter notebook</a:t>
+            </a:r>
+          </a:p>
+        </p:txBody>
+      </p:sp>
+      <p:pic>
+        <p:nvPicPr>
+          <p:cNvPr id="20" name="Picture 19" descr="users.png"/>
+          <p:cNvPicPr>
+            <a:picLocks noChangeAspect="1"/>
+          </p:cNvPicPr>
+          <p:nvPr/>
+        </p:nvPicPr>
+        <p:blipFill>
+          <a:blip r:embed="rId8"/>
+          <a:stretch>
+            <a:fillRect/>
+          </a:stretch>
+        </p:blipFill>
+        <p:spPr>
+          <a:xfrm>
+            <a:off x="6339535" y="4041648"/>
+            <a:ext cx="384048" cy="384048"/>
+          </a:xfrm>
+          <a:prstGeom prst="rect">
+            <a:avLst/>
+          </a:prstGeom>
+        </p:spPr>
+      </p:pic>
+      <p:sp>
+        <p:nvSpPr>
+          <p:cNvPr id="21" name="TextBox 20"/>
+          <p:cNvSpPr txBox="1"/>
+          <p:nvPr/>
+        </p:nvSpPr>
+        <p:spPr>
+          <a:xfrm>
+            <a:off x="6906463" y="4023360"/>
+            <a:ext cx="4462272" cy="685800"/>
+          </a:xfrm>
+          <a:prstGeom prst="rect">
+            <a:avLst/>
+          </a:prstGeom>
+          <a:noFill/>
+        </p:spPr>
+        <p:txBody>
+          <a:bodyPr wrap="square" lIns="0" tIns="0" bIns="0">
+            <a:spAutoFit/>
+          </a:bodyPr>
+          <a:lstStyle/>
+          <a:p>
+            <a:r>
+              <a:rPr b="1" sz="1600"/>
+              <a:t>No assistant that runs code? </a:t>
+            </a:r>
+            <a:r>
+              <a:rPr sz="1600"/>
+              <a:t>team up</a:t>
+            </a:r>
+          </a:p>
+        </p:txBody>
+      </p:sp>
+      <p:pic>
+        <p:nvPicPr>
+          <p:cNvPr id="22" name="Picture 21" descr="book-2.png"/>
+          <p:cNvPicPr>
+            <a:picLocks noChangeAspect="1"/>
+          </p:cNvPicPr>
+          <p:nvPr/>
+        </p:nvPicPr>
+        <p:blipFill>
+          <a:blip r:embed="rId9"/>
+          <a:stretch>
+            <a:fillRect/>
+          </a:stretch>
+        </p:blipFill>
+        <p:spPr>
+          <a:xfrm>
+            <a:off x="6339535" y="4818888"/>
+            <a:ext cx="384048" cy="384048"/>
+          </a:xfrm>
+          <a:prstGeom prst="rect">
+            <a:avLst/>
+          </a:prstGeom>
+        </p:spPr>
+      </p:pic>
+      <p:sp>
+        <p:nvSpPr>
+          <p:cNvPr id="23" name="TextBox 22"/>
+          <p:cNvSpPr txBox="1"/>
+          <p:nvPr/>
+        </p:nvSpPr>
+        <p:spPr>
+          <a:xfrm>
+            <a:off x="6906463" y="4800600"/>
+            <a:ext cx="4462272" cy="685800"/>
+          </a:xfrm>
+          <a:prstGeom prst="rect">
+            <a:avLst/>
+          </a:prstGeom>
+          <a:noFill/>
+        </p:spPr>
+        <p:txBody>
+          <a:bodyPr wrap="square" lIns="0" tIns="0" bIns="0">
+            <a:spAutoFit/>
+          </a:bodyPr>
+          <a:lstStyle/>
+          <a:p>
+            <a:r>
+              <a:rPr b="1" sz="1600"/>
+              <a:t>Details: </a:t>
+            </a:r>
+            <a:r>
+              <a:rPr sz="1600"/>
+              <a:t>README, sections How to do it, Task 1, Task 2</a:t>
             </a:r>
           </a:p>
         </p:txBody>

</xml_diff>

<commit_message>
README: routes A, B, C as entry points; slide names them the same way
Co-Authored-By: Claude Fable 5.1 <noreply@anthropic.com>
</commit_message>
<xml_diff>
--- a/slides/workshop.pptx
+++ b/slides/workshop.pptx
@@ -3883,7 +3883,7 @@
           <a:p>
             <a:r>
               <a:rPr b="1" sz="1600"/>
-              <a:t>Coding assistant on your computer: </a:t>
+              <a:t>Route A · coding assistant on your computer: </a:t>
             </a:r>
             <a:r>
               <a:rPr sz="1600"/>
@@ -3940,7 +3940,7 @@
           <a:p>
             <a:r>
               <a:rPr b="1" sz="1600"/>
-              <a:t>Chat assistant only: </a:t>
+              <a:t>Route B · chat assistant only: </a:t>
             </a:r>
             <a:r>
               <a:rPr sz="1600"/>
@@ -3997,7 +3997,7 @@
           <a:p>
             <a:r>
               <a:rPr b="1" sz="1600"/>
-              <a:t>No assistant that runs code? </a:t>
+              <a:t>Route C · no assistant that runs code: </a:t>
             </a:r>
             <a:r>
               <a:rPr sz="1600"/>

</xml_diff>